<commit_message>
Add archive photos to the MOPI presentation
Title slide gets the pre-war MOPI building in an arch frame; the diploma,
directors' portraits and the 1933 Literature faculty group fill slides 2-4,
9 and 10. prep_photos.py crops and grades the sources in photos/src.

Co-Authored-By: Claude Opus 5.5 <noreply@anthropic.com>
Claude-Session: https://claude.ai/code/session_01Gbke9ULM5RvL1ZnrLDt9QB
</commit_message>
<xml_diff>
--- a/presentation/MOPI_History_1931-1940.pptx
+++ b/presentation/MOPI_History_1931-1940.pptx
@@ -116,12 +116,12 @@
   <p:extLst>
     <p:ext uri="{521415D9-36F7-43E2-AB2F-B90AF26B5E84}">
       <p14:sectionLst xmlns:p14="http://schemas.microsoft.com/office/powerpoint/2010/main">
-        <p14:section name="Introduction" id="{19b8ca47-a073-f580-cb1b-6f4bad823b36}">
+        <p14:section name="Introduction" id="{0a51c069-02b8-ee59-5a2f-2d85a8beea2d}">
           <p14:sldIdLst>
             <p14:sldId id="256"/>
           </p14:sldIdLst>
         </p14:section>
-        <p14:section name="The First Decade" id="{176ef4a5-1768-c58e-87de-93e7baf3f576}">
+        <p14:section name="The First Decade" id="{1ea9688a-95ee-32b8-ad56-4f5720d2bd84}">
           <p14:sldIdLst>
             <p14:sldId id="257"/>
             <p14:sldId id="258"/>
@@ -132,7 +132,7 @@
             <p14:sldId id="263"/>
           </p14:sldIdLst>
         </p14:section>
-        <p14:section name="1941" id="{bebf3482-9507-29e3-b2b8-cfa77a927886}">
+        <p14:section name="1941" id="{d897a739-f253-9ebc-6d05-20d62e12e959}">
           <p14:sldIdLst>
             <p14:sldId id="264"/>
             <p14:sldId id="265"/>
@@ -1408,6 +1408,228 @@
 
 <file path=ppt/slideLayouts/slideLayout10.xml><?xml version="1.0" encoding="utf-8"?>
 <p:sldLayout xmlns:a="http://schemas.openxmlformats.org/drawingml/2006/main" xmlns:r="http://schemas.openxmlformats.org/officeDocument/2006/relationships" xmlns:p="http://schemas.openxmlformats.org/presentationml/2006/main" preserve="1">
+  <p:cSld name="Dark Photo Right">
+    <p:bg>
+      <p:bgPr>
+        <a:solidFill>
+          <a:schemeClr val="tx1"/>
+        </a:solidFill>
+      </p:bgPr>
+    </p:bg>
+    <p:spTree>
+      <p:nvGrpSpPr>
+        <p:cNvPr id="1" name=""/>
+        <p:cNvGrpSpPr/>
+        <p:nvPr/>
+      </p:nvGrpSpPr>
+      <p:grpSpPr>
+        <a:xfrm>
+          <a:off x="0" y="0"/>
+          <a:ext cx="0" cy="0"/>
+          <a:chOff x="0" y="0"/>
+          <a:chExt cx="0" cy="0"/>
+        </a:xfrm>
+      </p:grpSpPr>
+      <p:sp>
+        <p:nvSpPr>
+          <p:cNvPr id="2" name="Shape 0"/>
+          <p:cNvSpPr/>
+          <p:nvPr/>
+        </p:nvSpPr>
+        <p:spPr>
+          <a:xfrm>
+            <a:off x="7223760" y="0"/>
+            <a:ext cx="4967935" cy="6858000"/>
+          </a:xfrm>
+          <a:prstGeom prst="rect">
+            <a:avLst/>
+          </a:prstGeom>
+          <a:solidFill>
+            <a:schemeClr val="accent5"/>
+          </a:solidFill>
+          <a:ln/>
+        </p:spPr>
+      </p:sp>
+      <p:sp>
+        <p:nvSpPr>
+          <p:cNvPr id="3" name="Text 1"/>
+          <p:cNvSpPr/>
+          <p:nvPr>
+            <p:ph type="pic" idx="101" hasCustomPrompt="1"/>
+          </p:nvPr>
+        </p:nvSpPr>
+        <p:spPr>
+          <a:xfrm>
+            <a:off x="7223760" y="0"/>
+            <a:ext cx="4967935" cy="6858000"/>
+          </a:xfrm>
+          <a:prstGeom prst="rect">
+            <a:avLst/>
+          </a:prstGeom>
+          <a:noFill/>
+          <a:ln/>
+        </p:spPr>
+        <p:txBody>
+          <a:bodyPr wrap="square" rtlCol="0"/>
+          <a:lstStyle>
+            <a:lvl1pPr algn="ctr" indent="0" marL="0">
+              <a:buNone/>
+              <a:defRPr lang="en-US" sz="1200" dirty="0">
+                <a:solidFill>
+                  <a:srgbClr val="ECE4E7"/>
+                </a:solidFill>
+              </a:defRPr>
+            </a:lvl1pPr>
+          </a:lstStyle>
+          <a:p>
+            <a:pPr algn="ctr" indent="0" marL="0">
+              <a:buNone/>
+            </a:pPr>
+            <a:r>
+              <a:rPr lang="en-US" sz="1200" dirty="0">
+                <a:solidFill>
+                  <a:srgbClr val="ECE4E7"/>
+                </a:solidFill>
+              </a:rPr>
+              <a:t>Click the icon to add a photo</a:t>
+            </a:r>
+            <a:endParaRPr lang="en-US" sz="1200" dirty="0"/>
+          </a:p>
+        </p:txBody>
+      </p:sp>
+      <p:sp>
+        <p:nvSpPr>
+          <p:cNvPr id="4" name="Text 1"/>
+          <p:cNvSpPr/>
+          <p:nvPr>
+            <p:ph idx="102" type="title" hasCustomPrompt="1"/>
+          </p:nvPr>
+        </p:nvSpPr>
+        <p:spPr>
+          <a:xfrm>
+            <a:off x="640080" y="502920"/>
+            <a:ext cx="6309360" cy="822960"/>
+          </a:xfrm>
+          <a:prstGeom prst="rect">
+            <a:avLst/>
+          </a:prstGeom>
+          <a:noFill/>
+          <a:ln/>
+        </p:spPr>
+        <p:txBody>
+          <a:bodyPr wrap="square" rtlCol="0"/>
+          <a:lstStyle>
+            <a:lvl1pPr algn="l" indent="0" marL="0">
+              <a:buNone/>
+              <a:defRPr lang="en-US" sz="4000" dirty="0">
+                <a:solidFill>
+                  <a:schemeClr val="bg1"/>
+                </a:solidFill>
+                <a:latin typeface="Times New Roman" pitchFamily="34" charset="0"/>
+                <a:ea typeface="Times New Roman" pitchFamily="34" charset="-122"/>
+                <a:cs typeface="Times New Roman" pitchFamily="34" charset="-120"/>
+              </a:defRPr>
+            </a:lvl1pPr>
+          </a:lstStyle>
+          <a:p>
+            <a:pPr algn="l" indent="0" marL="0">
+              <a:buNone/>
+            </a:pPr>
+            <a:endParaRPr lang="en-US" sz="4000" dirty="0"/>
+          </a:p>
+        </p:txBody>
+      </p:sp>
+      <p:sp>
+        <p:nvSpPr>
+          <p:cNvPr id="5" name="Text 1"/>
+          <p:cNvSpPr/>
+          <p:nvPr/>
+        </p:nvSpPr>
+        <p:spPr>
+          <a:xfrm>
+            <a:off x="640080" y="6309360"/>
+            <a:ext cx="4572000" cy="274320"/>
+          </a:xfrm>
+          <a:prstGeom prst="rect">
+            <a:avLst/>
+          </a:prstGeom>
+          <a:noFill/>
+          <a:ln/>
+        </p:spPr>
+        <p:txBody>
+          <a:bodyPr wrap="square" lIns="0" tIns="0" rIns="0" bIns="0" rtlCol="0" anchor="ctr"/>
+          <a:lstStyle/>
+          <a:p>
+            <a:pPr indent="0" marL="0">
+              <a:buNone/>
+            </a:pPr>
+            <a:r>
+              <a:rPr lang="en-US" sz="1000" spc="300" kern="0" dirty="0">
+                <a:solidFill>
+                  <a:schemeClr val="accent1"/>
+                </a:solidFill>
+              </a:rPr>
+              <a:t>HISTORY OF MY UNIVERSITY  ·  1931–1940</a:t>
+            </a:r>
+            <a:endParaRPr lang="en-US" sz="1000" dirty="0"/>
+          </a:p>
+        </p:txBody>
+      </p:sp>
+      <p:sp>
+        <p:nvSpPr>
+          <p:cNvPr id="25" name="Slide Number Placeholder 0"/>
+          <p:cNvSpPr>
+            <a:spLocks noGrp="1"/>
+          </p:cNvSpPr>
+          <p:nvPr>
+            <p:ph type="sldNum" sz="quarter" idx="4294967295"/>
+          </p:nvPr>
+        </p:nvSpPr>
+        <p:spPr>
+          <a:xfrm>
+            <a:off x="6309360" y="6309360"/>
+            <a:ext cx="457200" cy="274320"/>
+          </a:xfrm>
+          <a:prstGeom prst="rect">
+            <a:avLst/>
+          </a:prstGeom>
+          <a:extLst>
+            <a:ext uri="{C572A759-6A51-4108-AA02-DFA0A04FC94B}">
+              <ma14:wrappingTextBoxFlag xmlns:ma14="http://schemas.microsoft.com/office/mac/drawingml/2011/main" val="0"/>
+            </a:ext>
+          </a:extLst>
+        </p:spPr>
+        <p:txBody>
+          <a:bodyPr lIns="0" tIns="0" rIns="0" bIns="0" anchor="ctr"/>
+          <a:lstStyle>
+            <a:lvl1pPr>
+              <a:defRPr sz="1000">
+                <a:solidFill>
+                  <a:schemeClr val="accent1"/>
+                </a:solidFill>
+              </a:defRPr>
+            </a:lvl1pPr>
+          </a:lstStyle>
+          <a:p>
+            <a:pPr algn="r"/>
+            <a:fld id="{F7021451-1387-4CA6-816F-3879F97B5CBC}" type="slidenum">
+              <a:rPr b="0" lang="en-US"/>
+              <a:t>1010</a:t>
+            </a:fld>
+            <a:endParaRPr lang="en-US"/>
+          </a:p>
+        </p:txBody>
+      </p:sp>
+    </p:spTree>
+  </p:cSld>
+  <p:clrMapOvr>
+    <a:masterClrMapping/>
+  </p:clrMapOvr>
+</p:sldLayout>
+</file>
+
+<file path=ppt/slideLayouts/slideLayout11.xml><?xml version="1.0" encoding="utf-8"?>
+<p:sldLayout xmlns:a="http://schemas.openxmlformats.org/drawingml/2006/main" xmlns:r="http://schemas.openxmlformats.org/officeDocument/2006/relationships" xmlns:p="http://schemas.openxmlformats.org/presentationml/2006/main" preserve="1">
   <p:cSld name="Dark Photo Left">
     <p:bg>
       <p:bgPr>
@@ -1531,83 +1753,16 @@
       </p:grpSpPr>
       <p:sp>
         <p:nvSpPr>
-          <p:cNvPr id="2" name="Shape 0"/>
-          <p:cNvSpPr/>
-          <p:nvPr/>
-        </p:nvSpPr>
-        <p:spPr>
-          <a:xfrm>
-            <a:off x="6035040" y="0"/>
-            <a:ext cx="6156655" cy="6858000"/>
-          </a:xfrm>
-          <a:prstGeom prst="rect">
-            <a:avLst/>
-          </a:prstGeom>
-          <a:solidFill>
-            <a:schemeClr val="accent5"/>
-          </a:solidFill>
-          <a:ln/>
-        </p:spPr>
-      </p:sp>
-      <p:sp>
-        <p:nvSpPr>
-          <p:cNvPr id="3" name="Text 1"/>
+          <p:cNvPr id="2" name="Text 0"/>
           <p:cNvSpPr/>
           <p:nvPr>
-            <p:ph type="pic" idx="101" hasCustomPrompt="1"/>
+            <p:ph idx="100" type="title" hasCustomPrompt="1"/>
           </p:nvPr>
         </p:nvSpPr>
         <p:spPr>
           <a:xfrm>
-            <a:off x="6035040" y="0"/>
-            <a:ext cx="6156655" cy="6858000"/>
-          </a:xfrm>
-          <a:prstGeom prst="rect">
-            <a:avLst/>
-          </a:prstGeom>
-          <a:noFill/>
-          <a:ln/>
-        </p:spPr>
-        <p:txBody>
-          <a:bodyPr wrap="square" rtlCol="0"/>
-          <a:lstStyle>
-            <a:lvl1pPr algn="ctr" indent="0" marL="0">
-              <a:buNone/>
-              <a:defRPr lang="en-US" sz="1200" dirty="0">
-                <a:solidFill>
-                  <a:srgbClr val="ECE4E7"/>
-                </a:solidFill>
-              </a:defRPr>
-            </a:lvl1pPr>
-          </a:lstStyle>
-          <a:p>
-            <a:pPr algn="ctr" indent="0" marL="0">
-              <a:buNone/>
-            </a:pPr>
-            <a:r>
-              <a:rPr lang="en-US" sz="1200" dirty="0">
-                <a:solidFill>
-                  <a:srgbClr val="ECE4E7"/>
-                </a:solidFill>
-              </a:rPr>
-              <a:t>Click the icon to add a photo</a:t>
-            </a:r>
-            <a:endParaRPr lang="en-US" sz="1200" dirty="0"/>
-          </a:p>
-        </p:txBody>
-      </p:sp>
-      <p:sp>
-        <p:nvSpPr>
-          <p:cNvPr id="4" name="Text 1"/>
-          <p:cNvSpPr/>
-          <p:nvPr>
-            <p:ph idx="102" type="title" hasCustomPrompt="1"/>
-          </p:nvPr>
-        </p:nvSpPr>
-        <p:spPr>
-          <a:xfrm>
             <a:off x="640080" y="1463040"/>
-            <a:ext cx="5212080" cy="1828800"/>
+            <a:ext cx="5669280" cy="1828800"/>
           </a:xfrm>
           <a:prstGeom prst="rect">
             <a:avLst/>
@@ -1647,6 +1802,181 @@
 </file>
 
 <file path=ppt/slideLayouts/slideLayout3.xml><?xml version="1.0" encoding="utf-8"?>
+<p:sldLayout xmlns:a="http://schemas.openxmlformats.org/drawingml/2006/main" xmlns:r="http://schemas.openxmlformats.org/officeDocument/2006/relationships" xmlns:p="http://schemas.openxmlformats.org/presentationml/2006/main" preserve="1">
+  <p:cSld name="Blush Left">
+    <p:bg>
+      <p:bgPr>
+        <a:solidFill>
+          <a:schemeClr val="bg1"/>
+        </a:solidFill>
+      </p:bgPr>
+    </p:bg>
+    <p:spTree>
+      <p:nvGrpSpPr>
+        <p:cNvPr id="1" name=""/>
+        <p:cNvGrpSpPr/>
+        <p:nvPr/>
+      </p:nvGrpSpPr>
+      <p:grpSpPr>
+        <a:xfrm>
+          <a:off x="0" y="0"/>
+          <a:ext cx="0" cy="0"/>
+          <a:chOff x="0" y="0"/>
+          <a:chExt cx="0" cy="0"/>
+        </a:xfrm>
+      </p:grpSpPr>
+      <p:sp>
+        <p:nvSpPr>
+          <p:cNvPr id="2" name="Shape 0"/>
+          <p:cNvSpPr/>
+          <p:nvPr/>
+        </p:nvSpPr>
+        <p:spPr>
+          <a:xfrm>
+            <a:off x="0" y="0"/>
+            <a:ext cx="4572000" cy="6858000"/>
+          </a:xfrm>
+          <a:prstGeom prst="rect">
+            <a:avLst/>
+          </a:prstGeom>
+          <a:solidFill>
+            <a:schemeClr val="bg2"/>
+          </a:solidFill>
+          <a:ln/>
+        </p:spPr>
+      </p:sp>
+      <p:sp>
+        <p:nvSpPr>
+          <p:cNvPr id="3" name="Text 1"/>
+          <p:cNvSpPr/>
+          <p:nvPr>
+            <p:ph idx="101" type="title" hasCustomPrompt="1"/>
+          </p:nvPr>
+        </p:nvSpPr>
+        <p:spPr>
+          <a:xfrm>
+            <a:off x="5212080" y="502920"/>
+            <a:ext cx="6400800" cy="822960"/>
+          </a:xfrm>
+          <a:prstGeom prst="rect">
+            <a:avLst/>
+          </a:prstGeom>
+          <a:noFill/>
+          <a:ln/>
+        </p:spPr>
+        <p:txBody>
+          <a:bodyPr wrap="square" rtlCol="0"/>
+          <a:lstStyle>
+            <a:lvl1pPr algn="l" indent="0" marL="0">
+              <a:buNone/>
+              <a:defRPr lang="en-US" sz="4000" dirty="0">
+                <a:solidFill>
+                  <a:schemeClr val="tx1"/>
+                </a:solidFill>
+                <a:latin typeface="Times New Roman" pitchFamily="34" charset="0"/>
+                <a:ea typeface="Times New Roman" pitchFamily="34" charset="-122"/>
+                <a:cs typeface="Times New Roman" pitchFamily="34" charset="-120"/>
+              </a:defRPr>
+            </a:lvl1pPr>
+          </a:lstStyle>
+          <a:p>
+            <a:pPr algn="l" indent="0" marL="0">
+              <a:buNone/>
+            </a:pPr>
+            <a:endParaRPr lang="en-US" sz="4000" dirty="0"/>
+          </a:p>
+        </p:txBody>
+      </p:sp>
+      <p:sp>
+        <p:nvSpPr>
+          <p:cNvPr id="4" name="Text 1"/>
+          <p:cNvSpPr/>
+          <p:nvPr/>
+        </p:nvSpPr>
+        <p:spPr>
+          <a:xfrm>
+            <a:off x="5212080" y="6309360"/>
+            <a:ext cx="4572000" cy="274320"/>
+          </a:xfrm>
+          <a:prstGeom prst="rect">
+            <a:avLst/>
+          </a:prstGeom>
+          <a:noFill/>
+          <a:ln/>
+        </p:spPr>
+        <p:txBody>
+          <a:bodyPr wrap="square" lIns="0" tIns="0" rIns="0" bIns="0" rtlCol="0" anchor="ctr"/>
+          <a:lstStyle/>
+          <a:p>
+            <a:pPr indent="0" marL="0">
+              <a:buNone/>
+            </a:pPr>
+            <a:r>
+              <a:rPr lang="en-US" sz="1000" spc="300" kern="0" dirty="0">
+                <a:solidFill>
+                  <a:schemeClr val="tx2"/>
+                </a:solidFill>
+              </a:rPr>
+              <a:t>HISTORY OF MY UNIVERSITY  ·  1931–1940</a:t>
+            </a:r>
+            <a:endParaRPr lang="en-US" sz="1000" dirty="0"/>
+          </a:p>
+        </p:txBody>
+      </p:sp>
+      <p:sp>
+        <p:nvSpPr>
+          <p:cNvPr id="25" name="Slide Number Placeholder 0"/>
+          <p:cNvSpPr>
+            <a:spLocks noGrp="1"/>
+          </p:cNvSpPr>
+          <p:nvPr>
+            <p:ph type="sldNum" sz="quarter" idx="4294967295"/>
+          </p:nvPr>
+        </p:nvSpPr>
+        <p:spPr>
+          <a:xfrm>
+            <a:off x="11091672" y="6309360"/>
+            <a:ext cx="457200" cy="274320"/>
+          </a:xfrm>
+          <a:prstGeom prst="rect">
+            <a:avLst/>
+          </a:prstGeom>
+          <a:extLst>
+            <a:ext uri="{C572A759-6A51-4108-AA02-DFA0A04FC94B}">
+              <ma14:wrappingTextBoxFlag xmlns:ma14="http://schemas.microsoft.com/office/mac/drawingml/2011/main" val="0"/>
+            </a:ext>
+          </a:extLst>
+        </p:spPr>
+        <p:txBody>
+          <a:bodyPr lIns="0" tIns="0" rIns="0" bIns="0" anchor="ctr"/>
+          <a:lstStyle>
+            <a:lvl1pPr>
+              <a:defRPr sz="1000">
+                <a:solidFill>
+                  <a:schemeClr val="tx2"/>
+                </a:solidFill>
+              </a:defRPr>
+            </a:lvl1pPr>
+          </a:lstStyle>
+          <a:p>
+            <a:pPr algn="r"/>
+            <a:fld id="{F7021451-1387-4CA6-816F-3879F97B5CBC}" type="slidenum">
+              <a:rPr b="0" lang="en-US"/>
+              <a:t>1003</a:t>
+            </a:fld>
+            <a:endParaRPr lang="en-US"/>
+          </a:p>
+        </p:txBody>
+      </p:sp>
+    </p:spTree>
+  </p:cSld>
+  <p:clrMapOvr>
+    <a:masterClrMapping/>
+  </p:clrMapOvr>
+</p:sldLayout>
+</file>
+
+<file path=ppt/slideLayouts/slideLayout4.xml><?xml version="1.0" encoding="utf-8"?>
 <p:sldLayout xmlns:a="http://schemas.openxmlformats.org/drawingml/2006/main" xmlns:r="http://schemas.openxmlformats.org/officeDocument/2006/relationships" xmlns:p="http://schemas.openxmlformats.org/presentationml/2006/main" preserve="1">
   <p:cSld name="Photo Left">
     <p:bg>
@@ -1854,7 +2184,7 @@
             <a:pPr algn="r"/>
             <a:fld id="{F7021451-1387-4CA6-816F-3879F97B5CBC}" type="slidenum">
               <a:rPr b="0" lang="en-US"/>
-              <a:t>1003</a:t>
+              <a:t>1004</a:t>
             </a:fld>
             <a:endParaRPr lang="en-US"/>
           </a:p>
@@ -1868,7 +2198,7 @@
 </p:sldLayout>
 </file>
 
-<file path=ppt/slideLayouts/slideLayout4.xml><?xml version="1.0" encoding="utf-8"?>
+<file path=ppt/slideLayouts/slideLayout5.xml><?xml version="1.0" encoding="utf-8"?>
 <p:sldLayout xmlns:a="http://schemas.openxmlformats.org/drawingml/2006/main" xmlns:r="http://schemas.openxmlformats.org/officeDocument/2006/relationships" xmlns:p="http://schemas.openxmlformats.org/presentationml/2006/main" preserve="1">
   <p:cSld name="Photo Right">
     <p:bg>
@@ -2076,7 +2406,7 @@
             <a:pPr algn="r"/>
             <a:fld id="{F7021451-1387-4CA6-816F-3879F97B5CBC}" type="slidenum">
               <a:rPr b="0" lang="en-US"/>
-              <a:t>1004</a:t>
+              <a:t>1005</a:t>
             </a:fld>
             <a:endParaRPr lang="en-US"/>
           </a:p>
@@ -2090,7 +2420,7 @@
 </p:sldLayout>
 </file>
 
-<file path=ppt/slideLayouts/slideLayout5.xml><?xml version="1.0" encoding="utf-8"?>
+<file path=ppt/slideLayouts/slideLayout6.xml><?xml version="1.0" encoding="utf-8"?>
 <p:sldLayout xmlns:a="http://schemas.openxmlformats.org/drawingml/2006/main" xmlns:r="http://schemas.openxmlformats.org/officeDocument/2006/relationships" xmlns:p="http://schemas.openxmlformats.org/presentationml/2006/main" preserve="1">
   <p:cSld name="Photo Diagonal">
     <p:bg>
@@ -2298,7 +2628,7 @@
             <a:pPr algn="r"/>
             <a:fld id="{F7021451-1387-4CA6-816F-3879F97B5CBC}" type="slidenum">
               <a:rPr b="0" lang="en-US"/>
-              <a:t>1005</a:t>
+              <a:t>1006</a:t>
             </a:fld>
             <a:endParaRPr lang="en-US"/>
           </a:p>
@@ -2312,7 +2642,7 @@
 </p:sldLayout>
 </file>
 
-<file path=ppt/slideLayouts/slideLayout6.xml><?xml version="1.0" encoding="utf-8"?>
+<file path=ppt/slideLayouts/slideLayout7.xml><?xml version="1.0" encoding="utf-8"?>
 <p:sldLayout xmlns:a="http://schemas.openxmlformats.org/drawingml/2006/main" xmlns:r="http://schemas.openxmlformats.org/officeDocument/2006/relationships" xmlns:p="http://schemas.openxmlformats.org/presentationml/2006/main" preserve="1">
   <p:cSld name="Rose Panel">
     <p:bg>
@@ -2473,7 +2803,7 @@
             <a:pPr algn="r"/>
             <a:fld id="{F7021451-1387-4CA6-816F-3879F97B5CBC}" type="slidenum">
               <a:rPr b="0" lang="en-US"/>
-              <a:t>1006</a:t>
+              <a:t>1007</a:t>
             </a:fld>
             <a:endParaRPr lang="en-US"/>
           </a:p>
@@ -2487,7 +2817,7 @@
 </p:sldLayout>
 </file>
 
-<file path=ppt/slideLayouts/slideLayout7.xml><?xml version="1.0" encoding="utf-8"?>
+<file path=ppt/slideLayouts/slideLayout8.xml><?xml version="1.0" encoding="utf-8"?>
 <p:sldLayout xmlns:a="http://schemas.openxmlformats.org/drawingml/2006/main" xmlns:r="http://schemas.openxmlformats.org/officeDocument/2006/relationships" xmlns:p="http://schemas.openxmlformats.org/presentationml/2006/main" preserve="1">
   <p:cSld name="Title Only">
     <p:bg>
@@ -2628,7 +2958,7 @@
             <a:pPr algn="r"/>
             <a:fld id="{F7021451-1387-4CA6-816F-3879F97B5CBC}" type="slidenum">
               <a:rPr b="0" lang="en-US"/>
-              <a:t>1007</a:t>
+              <a:t>1008</a:t>
             </a:fld>
             <a:endParaRPr lang="en-US"/>
           </a:p>
@@ -2642,7 +2972,7 @@
 </p:sldLayout>
 </file>
 
-<file path=ppt/slideLayouts/slideLayout8.xml><?xml version="1.0" encoding="utf-8"?>
+<file path=ppt/slideLayouts/slideLayout9.xml><?xml version="1.0" encoding="utf-8"?>
 <p:sldLayout xmlns:a="http://schemas.openxmlformats.org/drawingml/2006/main" xmlns:r="http://schemas.openxmlformats.org/officeDocument/2006/relationships" xmlns:p="http://schemas.openxmlformats.org/presentationml/2006/main" preserve="1">
   <p:cSld name="Title Only Blush">
     <p:bg>
@@ -2775,228 +3105,6 @@
               <a:defRPr sz="1000">
                 <a:solidFill>
                   <a:schemeClr val="tx2"/>
-                </a:solidFill>
-              </a:defRPr>
-            </a:lvl1pPr>
-          </a:lstStyle>
-          <a:p>
-            <a:pPr algn="r"/>
-            <a:fld id="{F7021451-1387-4CA6-816F-3879F97B5CBC}" type="slidenum">
-              <a:rPr b="0" lang="en-US"/>
-              <a:t>1008</a:t>
-            </a:fld>
-            <a:endParaRPr lang="en-US"/>
-          </a:p>
-        </p:txBody>
-      </p:sp>
-    </p:spTree>
-  </p:cSld>
-  <p:clrMapOvr>
-    <a:masterClrMapping/>
-  </p:clrMapOvr>
-</p:sldLayout>
-</file>
-
-<file path=ppt/slideLayouts/slideLayout9.xml><?xml version="1.0" encoding="utf-8"?>
-<p:sldLayout xmlns:a="http://schemas.openxmlformats.org/drawingml/2006/main" xmlns:r="http://schemas.openxmlformats.org/officeDocument/2006/relationships" xmlns:p="http://schemas.openxmlformats.org/presentationml/2006/main" preserve="1">
-  <p:cSld name="Dark Photo Right">
-    <p:bg>
-      <p:bgPr>
-        <a:solidFill>
-          <a:schemeClr val="tx1"/>
-        </a:solidFill>
-      </p:bgPr>
-    </p:bg>
-    <p:spTree>
-      <p:nvGrpSpPr>
-        <p:cNvPr id="1" name=""/>
-        <p:cNvGrpSpPr/>
-        <p:nvPr/>
-      </p:nvGrpSpPr>
-      <p:grpSpPr>
-        <a:xfrm>
-          <a:off x="0" y="0"/>
-          <a:ext cx="0" cy="0"/>
-          <a:chOff x="0" y="0"/>
-          <a:chExt cx="0" cy="0"/>
-        </a:xfrm>
-      </p:grpSpPr>
-      <p:sp>
-        <p:nvSpPr>
-          <p:cNvPr id="2" name="Shape 0"/>
-          <p:cNvSpPr/>
-          <p:nvPr/>
-        </p:nvSpPr>
-        <p:spPr>
-          <a:xfrm>
-            <a:off x="7223760" y="0"/>
-            <a:ext cx="4967935" cy="6858000"/>
-          </a:xfrm>
-          <a:prstGeom prst="rect">
-            <a:avLst/>
-          </a:prstGeom>
-          <a:solidFill>
-            <a:schemeClr val="accent5"/>
-          </a:solidFill>
-          <a:ln/>
-        </p:spPr>
-      </p:sp>
-      <p:sp>
-        <p:nvSpPr>
-          <p:cNvPr id="3" name="Text 1"/>
-          <p:cNvSpPr/>
-          <p:nvPr>
-            <p:ph type="pic" idx="101" hasCustomPrompt="1"/>
-          </p:nvPr>
-        </p:nvSpPr>
-        <p:spPr>
-          <a:xfrm>
-            <a:off x="7223760" y="0"/>
-            <a:ext cx="4967935" cy="6858000"/>
-          </a:xfrm>
-          <a:prstGeom prst="rect">
-            <a:avLst/>
-          </a:prstGeom>
-          <a:noFill/>
-          <a:ln/>
-        </p:spPr>
-        <p:txBody>
-          <a:bodyPr wrap="square" rtlCol="0"/>
-          <a:lstStyle>
-            <a:lvl1pPr algn="ctr" indent="0" marL="0">
-              <a:buNone/>
-              <a:defRPr lang="en-US" sz="1200" dirty="0">
-                <a:solidFill>
-                  <a:srgbClr val="ECE4E7"/>
-                </a:solidFill>
-              </a:defRPr>
-            </a:lvl1pPr>
-          </a:lstStyle>
-          <a:p>
-            <a:pPr algn="ctr" indent="0" marL="0">
-              <a:buNone/>
-            </a:pPr>
-            <a:r>
-              <a:rPr lang="en-US" sz="1200" dirty="0">
-                <a:solidFill>
-                  <a:srgbClr val="ECE4E7"/>
-                </a:solidFill>
-              </a:rPr>
-              <a:t>Click the icon to add a photo</a:t>
-            </a:r>
-            <a:endParaRPr lang="en-US" sz="1200" dirty="0"/>
-          </a:p>
-        </p:txBody>
-      </p:sp>
-      <p:sp>
-        <p:nvSpPr>
-          <p:cNvPr id="4" name="Text 1"/>
-          <p:cNvSpPr/>
-          <p:nvPr>
-            <p:ph idx="102" type="title" hasCustomPrompt="1"/>
-          </p:nvPr>
-        </p:nvSpPr>
-        <p:spPr>
-          <a:xfrm>
-            <a:off x="640080" y="502920"/>
-            <a:ext cx="6309360" cy="822960"/>
-          </a:xfrm>
-          <a:prstGeom prst="rect">
-            <a:avLst/>
-          </a:prstGeom>
-          <a:noFill/>
-          <a:ln/>
-        </p:spPr>
-        <p:txBody>
-          <a:bodyPr wrap="square" rtlCol="0"/>
-          <a:lstStyle>
-            <a:lvl1pPr algn="l" indent="0" marL="0">
-              <a:buNone/>
-              <a:defRPr lang="en-US" sz="4000" dirty="0">
-                <a:solidFill>
-                  <a:schemeClr val="bg1"/>
-                </a:solidFill>
-                <a:latin typeface="Times New Roman" pitchFamily="34" charset="0"/>
-                <a:ea typeface="Times New Roman" pitchFamily="34" charset="-122"/>
-                <a:cs typeface="Times New Roman" pitchFamily="34" charset="-120"/>
-              </a:defRPr>
-            </a:lvl1pPr>
-          </a:lstStyle>
-          <a:p>
-            <a:pPr algn="l" indent="0" marL="0">
-              <a:buNone/>
-            </a:pPr>
-            <a:endParaRPr lang="en-US" sz="4000" dirty="0"/>
-          </a:p>
-        </p:txBody>
-      </p:sp>
-      <p:sp>
-        <p:nvSpPr>
-          <p:cNvPr id="5" name="Text 1"/>
-          <p:cNvSpPr/>
-          <p:nvPr/>
-        </p:nvSpPr>
-        <p:spPr>
-          <a:xfrm>
-            <a:off x="640080" y="6309360"/>
-            <a:ext cx="4572000" cy="274320"/>
-          </a:xfrm>
-          <a:prstGeom prst="rect">
-            <a:avLst/>
-          </a:prstGeom>
-          <a:noFill/>
-          <a:ln/>
-        </p:spPr>
-        <p:txBody>
-          <a:bodyPr wrap="square" lIns="0" tIns="0" rIns="0" bIns="0" rtlCol="0" anchor="ctr"/>
-          <a:lstStyle/>
-          <a:p>
-            <a:pPr indent="0" marL="0">
-              <a:buNone/>
-            </a:pPr>
-            <a:r>
-              <a:rPr lang="en-US" sz="1000" spc="300" kern="0" dirty="0">
-                <a:solidFill>
-                  <a:schemeClr val="accent1"/>
-                </a:solidFill>
-              </a:rPr>
-              <a:t>HISTORY OF MY UNIVERSITY  ·  1931–1940</a:t>
-            </a:r>
-            <a:endParaRPr lang="en-US" sz="1000" dirty="0"/>
-          </a:p>
-        </p:txBody>
-      </p:sp>
-      <p:sp>
-        <p:nvSpPr>
-          <p:cNvPr id="25" name="Slide Number Placeholder 0"/>
-          <p:cNvSpPr>
-            <a:spLocks noGrp="1"/>
-          </p:cNvSpPr>
-          <p:nvPr>
-            <p:ph type="sldNum" sz="quarter" idx="4294967295"/>
-          </p:nvPr>
-        </p:nvSpPr>
-        <p:spPr>
-          <a:xfrm>
-            <a:off x="6309360" y="6309360"/>
-            <a:ext cx="457200" cy="274320"/>
-          </a:xfrm>
-          <a:prstGeom prst="rect">
-            <a:avLst/>
-          </a:prstGeom>
-          <a:extLst>
-            <a:ext uri="{C572A759-6A51-4108-AA02-DFA0A04FC94B}">
-              <ma14:wrappingTextBoxFlag xmlns:ma14="http://schemas.microsoft.com/office/mac/drawingml/2011/main" val="0"/>
-            </a:ext>
-          </a:extLst>
-        </p:spPr>
-        <p:txBody>
-          <a:bodyPr lIns="0" tIns="0" rIns="0" bIns="0" anchor="ctr"/>
-          <a:lstStyle>
-            <a:lvl1pPr>
-              <a:defRPr sz="1000">
-                <a:solidFill>
-                  <a:schemeClr val="accent1"/>
                 </a:solidFill>
               </a:defRPr>
             </a:lvl1pPr>
@@ -3095,6 +3203,7 @@
     <p:sldLayoutId id="2147483656" r:id="rId8"/>
     <p:sldLayoutId id="2147483657" r:id="rId9"/>
     <p:sldLayoutId id="2147483658" r:id="rId10"/>
+    <p:sldLayoutId id="2147483659" r:id="rId11"/>
   </p:sldLayoutIdLst>
   <p:hf sldNum="0" hdr="0" ftr="0" dt="0"/>
   <p:txStyles>
@@ -3367,86 +3476,102 @@
           <a:chExt cx="0" cy="0"/>
         </a:xfrm>
       </p:grpSpPr>
-      <p:sp>
-        <p:nvSpPr>
-          <p:cNvPr id="2" name="Text 1"/>
+      <p:pic>
+        <p:nvPicPr>
+          <p:cNvPr id="2" name="Arch outline" descr="/home/user/paintbot/presentation/photos/title_arch_outline.png">    </p:cNvPr>
+          <p:cNvPicPr>
+            <a:picLocks noChangeAspect="1"/>
+          </p:cNvPicPr>
+          <p:nvPr/>
+        </p:nvPicPr>
+        <p:blipFill>
+          <a:blip r:embed="rId1"/>
+          <a:stretch>
+            <a:fillRect/>
+          </a:stretch>
+        </p:blipFill>
+        <p:spPr>
+          <a:xfrm>
+            <a:off x="6355080" y="228600"/>
+            <a:ext cx="5212080" cy="6400800"/>
+          </a:xfrm>
+          <a:prstGeom prst="rect">
+            <a:avLst/>
+          </a:prstGeom>
+        </p:spPr>
+      </p:pic>
+      <p:pic>
+        <p:nvPicPr>
+          <p:cNvPr id="3" name="MOPI building" descr="Archive photo of the first and main pre-war MOPI building, Moscow, Podsosensky Lane, 20">    </p:cNvPr>
+          <p:cNvPicPr>
+            <a:picLocks noChangeAspect="1"/>
+          </p:cNvPicPr>
+          <p:nvPr/>
+        </p:nvPicPr>
+        <p:blipFill>
+          <a:blip r:embed="rId2"/>
+          <a:stretch>
+            <a:fillRect/>
+          </a:stretch>
+        </p:blipFill>
+        <p:spPr>
+          <a:xfrm>
+            <a:off x="6583680" y="457200"/>
+            <a:ext cx="4754880" cy="5852160"/>
+          </a:xfrm>
+          <a:prstGeom prst="rect">
+            <a:avLst/>
+          </a:prstGeom>
+        </p:spPr>
+      </p:pic>
+      <p:sp>
+        <p:nvSpPr>
+          <p:cNvPr id="4" name="Text 0"/>
+          <p:cNvSpPr txBox="1"/>
+          <p:nvPr/>
+        </p:nvSpPr>
+        <p:spPr>
+          <a:xfrm>
+            <a:off x="640080" y="731520"/>
+            <a:ext cx="5486400" cy="274320"/>
+          </a:xfrm>
+          <a:prstGeom prst="rect">
+            <a:avLst/>
+          </a:prstGeom>
+          <a:noFill/>
+          <a:ln/>
+        </p:spPr>
+        <p:txBody>
+          <a:bodyPr wrap="square" lIns="0" tIns="0" rIns="0" bIns="0" rtlCol="0" anchor="t"/>
+          <a:lstStyle/>
+          <a:p>
+            <a:pPr indent="0" marL="0">
+              <a:buNone/>
+            </a:pPr>
+            <a:r>
+              <a:rPr lang="en-US" sz="1100" b="1" spc="300" kern="0" dirty="0">
+                <a:solidFill>
+                  <a:schemeClr val="accent1"/>
+                </a:solidFill>
+              </a:rPr>
+              <a:t>MOSCOW REGIONAL PEDAGOGICAL INSTITUTE</a:t>
+            </a:r>
+            <a:endParaRPr lang="en-US" sz="1100" dirty="0"/>
+          </a:p>
+        </p:txBody>
+      </p:sp>
+      <p:sp>
+        <p:nvSpPr>
+          <p:cNvPr id="5" name="Text 0"/>
           <p:cNvSpPr/>
           <p:nvPr>
-            <p:ph type="pic" idx="101" hasCustomPrompt="1"/>
+            <p:ph idx="100" type="title" hasCustomPrompt="1"/>
           </p:nvPr>
         </p:nvSpPr>
         <p:spPr>
           <a:xfrm>
-            <a:off x="6035040" y="0"/>
-            <a:ext cx="6156655" cy="6858000"/>
-          </a:xfrm>
-          <a:prstGeom prst="rect">
-            <a:avLst/>
-          </a:prstGeom>
-          <a:solidFill>
-            <a:schemeClr val="accent5"/>
-          </a:solidFill>
-          <a:ln/>
-        </p:spPr>
-        <p:txBody>
-          <a:bodyPr wrap="square" rtlCol="0" anchor="ctr"/>
-          <a:lstStyle/>
-          <a:p>
-            <a:pPr algn="ctr" indent="0" marL="0">
-              <a:buNone/>
-            </a:pPr>
-            <a:endParaRPr lang="en-US" sz="1200" dirty="0"/>
-          </a:p>
-        </p:txBody>
-      </p:sp>
-      <p:sp>
-        <p:nvSpPr>
-          <p:cNvPr id="3" name="Text 1"/>
-          <p:cNvSpPr txBox="1"/>
-          <p:nvPr/>
-        </p:nvSpPr>
-        <p:spPr>
-          <a:xfrm>
-            <a:off x="640080" y="731520"/>
-            <a:ext cx="5120640" cy="274320"/>
-          </a:xfrm>
-          <a:prstGeom prst="rect">
-            <a:avLst/>
-          </a:prstGeom>
-          <a:noFill/>
-          <a:ln/>
-        </p:spPr>
-        <p:txBody>
-          <a:bodyPr wrap="square" lIns="0" tIns="0" rIns="0" bIns="0" rtlCol="0" anchor="t"/>
-          <a:lstStyle/>
-          <a:p>
-            <a:pPr indent="0" marL="0">
-              <a:buNone/>
-            </a:pPr>
-            <a:r>
-              <a:rPr lang="en-US" sz="1100" b="1" spc="300" kern="0" dirty="0">
-                <a:solidFill>
-                  <a:schemeClr val="accent1"/>
-                </a:solidFill>
-              </a:rPr>
-              <a:t>MOSCOW REGIONAL PEDAGOGICAL INSTITUTE</a:t>
-            </a:r>
-            <a:endParaRPr lang="en-US" sz="1100" dirty="0"/>
-          </a:p>
-        </p:txBody>
-      </p:sp>
-      <p:sp>
-        <p:nvSpPr>
-          <p:cNvPr id="4" name="Text 1"/>
-          <p:cNvSpPr/>
-          <p:nvPr>
-            <p:ph idx="102" type="title" hasCustomPrompt="1"/>
-          </p:nvPr>
-        </p:nvSpPr>
-        <p:spPr>
-          <a:xfrm>
             <a:off x="640080" y="1463040"/>
-            <a:ext cx="5212080" cy="1828800"/>
+            <a:ext cx="5669280" cy="1828800"/>
           </a:xfrm>
           <a:prstGeom prst="rect">
             <a:avLst/>
@@ -3495,7 +3620,7 @@
       </p:sp>
       <p:sp>
         <p:nvSpPr>
-          <p:cNvPr id="5" name="Text 3"/>
+          <p:cNvPr id="6" name="Text 2"/>
           <p:cNvSpPr txBox="1"/>
           <p:nvPr/>
         </p:nvSpPr>
@@ -3534,7 +3659,7 @@
       </p:sp>
       <p:sp>
         <p:nvSpPr>
-          <p:cNvPr id="6" name="Text 4"/>
+          <p:cNvPr id="7" name="Text 3"/>
           <p:cNvSpPr txBox="1"/>
           <p:nvPr/>
         </p:nvSpPr>
@@ -3570,7 +3695,7 @@
       </p:sp>
       <p:sp>
         <p:nvSpPr>
-          <p:cNvPr id="7" name="Text 5"/>
+          <p:cNvPr id="8" name="Text 4"/>
           <p:cNvSpPr txBox="1"/>
           <p:nvPr/>
         </p:nvSpPr>
@@ -3666,9 +3791,248 @@
           <a:chExt cx="0" cy="0"/>
         </a:xfrm>
       </p:grpSpPr>
-      <p:sp>
-        <p:nvSpPr>
-          <p:cNvPr id="2" name="Text 1"/>
+      <p:pic>
+        <p:nvPicPr>
+          <p:cNvPr id="2" name="closing_group1933.jpg" descr="Group A, 2nd year, Literature faculty of MOPI, 1933">    </p:cNvPr>
+          <p:cNvPicPr>
+            <a:picLocks noChangeAspect="1"/>
+          </p:cNvPicPr>
+          <p:nvPr/>
+        </p:nvPicPr>
+        <p:blipFill>
+          <a:blip r:embed="rId1"/>
+          <a:stretch>
+            <a:fillRect/>
+          </a:stretch>
+        </p:blipFill>
+        <p:spPr>
+          <a:xfrm>
+            <a:off x="0" y="0"/>
+            <a:ext cx="4754880" cy="6858000"/>
+          </a:xfrm>
+          <a:prstGeom prst="rect">
+            <a:avLst/>
+          </a:prstGeom>
+        </p:spPr>
+      </p:pic>
+      <p:sp>
+        <p:nvSpPr>
+          <p:cNvPr id="3" name="Caption strip"/>
+          <p:cNvSpPr/>
+          <p:nvPr/>
+        </p:nvSpPr>
+        <p:spPr>
+          <a:xfrm>
+            <a:off x="0" y="6172200"/>
+            <a:ext cx="4754880" cy="384048"/>
+          </a:xfrm>
+          <a:prstGeom prst="rect">
+            <a:avLst/>
+          </a:prstGeom>
+          <a:solidFill>
+            <a:schemeClr val="tx1">
+              <a:alpha val="75000"/>
+            </a:schemeClr>
+          </a:solidFill>
+          <a:ln w="12700">
+            <a:solidFill>
+              <a:schemeClr val="tx1">
+                <a:alpha val="0"/>
+              </a:schemeClr>
+            </a:solidFill>
+            <a:prstDash val="solid"/>
+          </a:ln>
+        </p:spPr>
+      </p:sp>
+      <p:sp>
+        <p:nvSpPr>
+          <p:cNvPr id="4" name="Text 1"/>
+          <p:cNvSpPr txBox="1"/>
+          <p:nvPr/>
+        </p:nvSpPr>
+        <p:spPr>
+          <a:xfrm>
+            <a:off x="137160" y="6172200"/>
+            <a:ext cx="4480560" cy="384048"/>
+          </a:xfrm>
+          <a:prstGeom prst="rect">
+            <a:avLst/>
+          </a:prstGeom>
+          <a:noFill/>
+          <a:ln/>
+        </p:spPr>
+        <p:txBody>
+          <a:bodyPr wrap="square" lIns="0" tIns="0" rIns="0" bIns="0" rtlCol="0" anchor="ctr"/>
+          <a:lstStyle/>
+          <a:p>
+            <a:pPr indent="0" marL="0">
+              <a:buNone/>
+            </a:pPr>
+            <a:r>
+              <a:rPr lang="en-US" sz="1100" i="1" dirty="0">
+                <a:solidFill>
+                  <a:schemeClr val="bg1"/>
+                </a:solidFill>
+              </a:rPr>
+              <a:t>Literature faculty students, 1933</a:t>
+            </a:r>
+            <a:endParaRPr lang="en-US" sz="1100" dirty="0"/>
+          </a:p>
+        </p:txBody>
+      </p:sp>
+      <p:sp>
+        <p:nvSpPr>
+          <p:cNvPr id="5" name="Text 2"/>
+          <p:cNvSpPr txBox="1"/>
+          <p:nvPr/>
+        </p:nvSpPr>
+        <p:spPr>
+          <a:xfrm>
+            <a:off x="5394960" y="1417320"/>
+            <a:ext cx="6126480" cy="274320"/>
+          </a:xfrm>
+          <a:prstGeom prst="rect">
+            <a:avLst/>
+          </a:prstGeom>
+          <a:noFill/>
+          <a:ln/>
+        </p:spPr>
+        <p:txBody>
+          <a:bodyPr wrap="square" lIns="0" tIns="0" rIns="0" bIns="0" rtlCol="0" anchor="t"/>
+          <a:lstStyle/>
+          <a:p>
+            <a:pPr indent="0" marL="0">
+              <a:buNone/>
+            </a:pPr>
+            <a:r>
+              <a:rPr lang="en-US" sz="1100" b="1" spc="300" kern="0" dirty="0">
+                <a:solidFill>
+                  <a:schemeClr val="accent1"/>
+                </a:solidFill>
+              </a:rPr>
+              <a:t>TO BE CONTINUED</a:t>
+            </a:r>
+            <a:endParaRPr lang="en-US" sz="1100" dirty="0"/>
+          </a:p>
+        </p:txBody>
+      </p:sp>
+      <p:sp>
+        <p:nvSpPr>
+          <p:cNvPr id="6" name="Text 3"/>
+          <p:cNvSpPr txBox="1"/>
+          <p:nvPr/>
+        </p:nvSpPr>
+        <p:spPr>
+          <a:xfrm>
+            <a:off x="5394960" y="1828800"/>
+            <a:ext cx="6126480" cy="1920240"/>
+          </a:xfrm>
+          <a:prstGeom prst="rect">
+            <a:avLst/>
+          </a:prstGeom>
+          <a:noFill/>
+          <a:ln/>
+        </p:spPr>
+        <p:txBody>
+          <a:bodyPr wrap="square" lIns="0" tIns="0" rIns="0" bIns="0" rtlCol="0" anchor="t"/>
+          <a:lstStyle/>
+          <a:p>
+            <a:pPr indent="0" marL="0">
+              <a:buNone/>
+            </a:pPr>
+            <a:r>
+              <a:rPr lang="en-US" sz="3600" i="1" dirty="0">
+                <a:solidFill>
+                  <a:schemeClr val="bg1"/>
+                </a:solidFill>
+                <a:latin typeface="Times New Roman" pitchFamily="34" charset="0"/>
+                <a:ea typeface="Times New Roman" pitchFamily="34" charset="-122"/>
+                <a:cs typeface="Times New Roman" pitchFamily="34" charset="-120"/>
+              </a:rPr>
+              <a:t>But that is already a different page of our history —</a:t>
+            </a:r>
+            <a:endParaRPr lang="en-US" sz="3600" dirty="0"/>
+          </a:p>
+        </p:txBody>
+      </p:sp>
+      <p:sp>
+        <p:nvSpPr>
+          <p:cNvPr id="7" name="Text 4"/>
+          <p:cNvSpPr txBox="1"/>
+          <p:nvPr/>
+        </p:nvSpPr>
+        <p:spPr>
+          <a:xfrm>
+            <a:off x="5394960" y="3383280"/>
+            <a:ext cx="6126480" cy="914400"/>
+          </a:xfrm>
+          <a:prstGeom prst="rect">
+            <a:avLst/>
+          </a:prstGeom>
+          <a:noFill/>
+          <a:ln/>
+        </p:spPr>
+        <p:txBody>
+          <a:bodyPr wrap="square" lIns="0" tIns="0" rIns="0" bIns="0" rtlCol="0" anchor="t"/>
+          <a:lstStyle/>
+          <a:p>
+            <a:pPr indent="0" marL="0">
+              <a:buNone/>
+            </a:pPr>
+            <a:r>
+              <a:rPr lang="en-US" sz="3600" dirty="0">
+                <a:solidFill>
+                  <a:schemeClr val="accent1"/>
+                </a:solidFill>
+                <a:latin typeface="Segoe Script" pitchFamily="34" charset="0"/>
+                <a:ea typeface="Segoe Script" pitchFamily="34" charset="-122"/>
+                <a:cs typeface="Segoe Script" pitchFamily="34" charset="-120"/>
+              </a:rPr>
+              <a:t>the war years.</a:t>
+            </a:r>
+            <a:endParaRPr lang="en-US" sz="3600" dirty="0"/>
+          </a:p>
+        </p:txBody>
+      </p:sp>
+      <p:sp>
+        <p:nvSpPr>
+          <p:cNvPr id="8" name="Text 5"/>
+          <p:cNvSpPr txBox="1"/>
+          <p:nvPr/>
+        </p:nvSpPr>
+        <p:spPr>
+          <a:xfrm>
+            <a:off x="5394960" y="5852160"/>
+            <a:ext cx="6309360" cy="320040"/>
+          </a:xfrm>
+          <a:prstGeom prst="rect">
+            <a:avLst/>
+          </a:prstGeom>
+          <a:noFill/>
+          <a:ln/>
+        </p:spPr>
+        <p:txBody>
+          <a:bodyPr wrap="square" lIns="0" tIns="0" rIns="0" bIns="0" rtlCol="0" anchor="t"/>
+          <a:lstStyle/>
+          <a:p>
+            <a:pPr indent="0" marL="0">
+              <a:buNone/>
+            </a:pPr>
+            <a:r>
+              <a:rPr lang="en-US" sz="1200" dirty="0">
+                <a:solidFill>
+                  <a:srgbClr val="ECE4E7"/>
+                </a:solidFill>
+              </a:rPr>
+              <a:t>Margarita Kondakova  ·  Elizaveta Vashchina  ·  Alexandra Abdulmanova</a:t>
+            </a:r>
+            <a:endParaRPr lang="en-US" sz="1200" dirty="0"/>
+          </a:p>
+        </p:txBody>
+      </p:sp>
+      <p:sp>
+        <p:nvSpPr>
+          <p:cNvPr id="9" name="Text 1"/>
           <p:cNvSpPr/>
           <p:nvPr>
             <p:ph type="pic" idx="101" hasCustomPrompt="1"/>
@@ -3682,9 +4046,7 @@
           <a:prstGeom prst="rect">
             <a:avLst/>
           </a:prstGeom>
-          <a:solidFill>
-            <a:schemeClr val="accent5"/>
-          </a:solidFill>
+          <a:noFill/>
           <a:ln/>
         </p:spPr>
         <p:txBody>
@@ -3694,156 +4056,6 @@
             <a:pPr algn="ctr" indent="0" marL="0">
               <a:buNone/>
             </a:pPr>
-            <a:endParaRPr lang="en-US" sz="1200" dirty="0"/>
-          </a:p>
-        </p:txBody>
-      </p:sp>
-      <p:sp>
-        <p:nvSpPr>
-          <p:cNvPr id="3" name="Text 1"/>
-          <p:cNvSpPr txBox="1"/>
-          <p:nvPr/>
-        </p:nvSpPr>
-        <p:spPr>
-          <a:xfrm>
-            <a:off x="5394960" y="1417320"/>
-            <a:ext cx="6126480" cy="274320"/>
-          </a:xfrm>
-          <a:prstGeom prst="rect">
-            <a:avLst/>
-          </a:prstGeom>
-          <a:noFill/>
-          <a:ln/>
-        </p:spPr>
-        <p:txBody>
-          <a:bodyPr wrap="square" lIns="0" tIns="0" rIns="0" bIns="0" rtlCol="0" anchor="t"/>
-          <a:lstStyle/>
-          <a:p>
-            <a:pPr indent="0" marL="0">
-              <a:buNone/>
-            </a:pPr>
-            <a:r>
-              <a:rPr lang="en-US" sz="1100" b="1" spc="300" kern="0" dirty="0">
-                <a:solidFill>
-                  <a:schemeClr val="accent1"/>
-                </a:solidFill>
-              </a:rPr>
-              <a:t>TO BE CONTINUED</a:t>
-            </a:r>
-            <a:endParaRPr lang="en-US" sz="1100" dirty="0"/>
-          </a:p>
-        </p:txBody>
-      </p:sp>
-      <p:sp>
-        <p:nvSpPr>
-          <p:cNvPr id="4" name="Text 2"/>
-          <p:cNvSpPr txBox="1"/>
-          <p:nvPr/>
-        </p:nvSpPr>
-        <p:spPr>
-          <a:xfrm>
-            <a:off x="5394960" y="1828800"/>
-            <a:ext cx="6126480" cy="1920240"/>
-          </a:xfrm>
-          <a:prstGeom prst="rect">
-            <a:avLst/>
-          </a:prstGeom>
-          <a:noFill/>
-          <a:ln/>
-        </p:spPr>
-        <p:txBody>
-          <a:bodyPr wrap="square" lIns="0" tIns="0" rIns="0" bIns="0" rtlCol="0" anchor="t"/>
-          <a:lstStyle/>
-          <a:p>
-            <a:pPr indent="0" marL="0">
-              <a:buNone/>
-            </a:pPr>
-            <a:r>
-              <a:rPr lang="en-US" sz="3600" i="1" dirty="0">
-                <a:solidFill>
-                  <a:schemeClr val="bg1"/>
-                </a:solidFill>
-                <a:latin typeface="Times New Roman" pitchFamily="34" charset="0"/>
-                <a:ea typeface="Times New Roman" pitchFamily="34" charset="-122"/>
-                <a:cs typeface="Times New Roman" pitchFamily="34" charset="-120"/>
-              </a:rPr>
-              <a:t>But that is already a different page of our history —</a:t>
-            </a:r>
-            <a:endParaRPr lang="en-US" sz="3600" dirty="0"/>
-          </a:p>
-        </p:txBody>
-      </p:sp>
-      <p:sp>
-        <p:nvSpPr>
-          <p:cNvPr id="5" name="Text 3"/>
-          <p:cNvSpPr txBox="1"/>
-          <p:nvPr/>
-        </p:nvSpPr>
-        <p:spPr>
-          <a:xfrm>
-            <a:off x="5394960" y="3383280"/>
-            <a:ext cx="6126480" cy="914400"/>
-          </a:xfrm>
-          <a:prstGeom prst="rect">
-            <a:avLst/>
-          </a:prstGeom>
-          <a:noFill/>
-          <a:ln/>
-        </p:spPr>
-        <p:txBody>
-          <a:bodyPr wrap="square" lIns="0" tIns="0" rIns="0" bIns="0" rtlCol="0" anchor="t"/>
-          <a:lstStyle/>
-          <a:p>
-            <a:pPr indent="0" marL="0">
-              <a:buNone/>
-            </a:pPr>
-            <a:r>
-              <a:rPr lang="en-US" sz="3600" dirty="0">
-                <a:solidFill>
-                  <a:schemeClr val="accent1"/>
-                </a:solidFill>
-                <a:latin typeface="Segoe Script" pitchFamily="34" charset="0"/>
-                <a:ea typeface="Segoe Script" pitchFamily="34" charset="-122"/>
-                <a:cs typeface="Segoe Script" pitchFamily="34" charset="-120"/>
-              </a:rPr>
-              <a:t>the war years.</a:t>
-            </a:r>
-            <a:endParaRPr lang="en-US" sz="3600" dirty="0"/>
-          </a:p>
-        </p:txBody>
-      </p:sp>
-      <p:sp>
-        <p:nvSpPr>
-          <p:cNvPr id="6" name="Text 4"/>
-          <p:cNvSpPr txBox="1"/>
-          <p:nvPr/>
-        </p:nvSpPr>
-        <p:spPr>
-          <a:xfrm>
-            <a:off x="5394960" y="5852160"/>
-            <a:ext cx="6309360" cy="320040"/>
-          </a:xfrm>
-          <a:prstGeom prst="rect">
-            <a:avLst/>
-          </a:prstGeom>
-          <a:noFill/>
-          <a:ln/>
-        </p:spPr>
-        <p:txBody>
-          <a:bodyPr wrap="square" lIns="0" tIns="0" rIns="0" bIns="0" rtlCol="0" anchor="t"/>
-          <a:lstStyle/>
-          <a:p>
-            <a:pPr indent="0" marL="0">
-              <a:buNone/>
-            </a:pPr>
-            <a:r>
-              <a:rPr lang="en-US" sz="1200" dirty="0">
-                <a:solidFill>
-                  <a:srgbClr val="ECE4E7"/>
-                </a:solidFill>
-              </a:rPr>
-              <a:t>Margarita Kondakova  ·  Elizaveta Vashchina  ·  Alexandra Abdulmanova</a:t>
-            </a:r>
             <a:endParaRPr lang="en-US" sz="1200" dirty="0"/>
           </a:p>
         </p:txBody>
@@ -3875,39 +4087,99 @@
       </p:grpSpPr>
       <p:sp>
         <p:nvSpPr>
-          <p:cNvPr id="2" name="Text 1"/>
+          <p:cNvPr id="2" name="Diploma mat"/>
           <p:cNvSpPr/>
-          <p:nvPr>
-            <p:ph type="pic" idx="101" hasCustomPrompt="1"/>
-          </p:nvPr>
-        </p:nvSpPr>
-        <p:spPr>
-          <a:xfrm>
-            <a:off x="0" y="0"/>
-            <a:ext cx="4572000" cy="6858000"/>
+          <p:nvPr/>
+        </p:nvSpPr>
+        <p:spPr>
+          <a:xfrm>
+            <a:off x="411480" y="1874520"/>
+            <a:ext cx="3749040" cy="2715768"/>
           </a:xfrm>
           <a:prstGeom prst="rect">
             <a:avLst/>
           </a:prstGeom>
           <a:solidFill>
-            <a:schemeClr val="accent3"/>
+            <a:schemeClr val="bg1"/>
           </a:solidFill>
-          <a:ln/>
-        </p:spPr>
-        <p:txBody>
-          <a:bodyPr wrap="square" rtlCol="0" anchor="ctr"/>
-          <a:lstStyle/>
-          <a:p>
-            <a:pPr algn="ctr" indent="0" marL="0">
-              <a:buNone/>
-            </a:pPr>
-            <a:endParaRPr lang="en-US" sz="1200" dirty="0"/>
-          </a:p>
-        </p:txBody>
-      </p:sp>
-      <p:sp>
-        <p:nvSpPr>
-          <p:cNvPr id="3" name="Decor 1931"/>
+          <a:ln w="12700">
+            <a:solidFill>
+              <a:schemeClr val="bg1"/>
+            </a:solidFill>
+            <a:prstDash val="solid"/>
+          </a:ln>
+          <a:effectLst>
+            <a:outerShdw sx="100000" sy="100000" kx="0" ky="0" algn="bl" rotWithShape="0" blurRad="127000" dist="50800" dir="5400000">
+              <a:srgbClr val="5E5459">
+                <a:alpha val="25000"/>
+              </a:srgbClr>
+            </a:outerShdw>
+          </a:effectLst>
+        </p:spPr>
+      </p:sp>
+      <p:pic>
+        <p:nvPicPr>
+          <p:cNvPr id="3" name="Diploma 1931" descr="MOPI diploma, 1931">    </p:cNvPr>
+          <p:cNvPicPr>
+            <a:picLocks noChangeAspect="1"/>
+          </p:cNvPicPr>
+          <p:nvPr/>
+        </p:nvPicPr>
+        <p:blipFill>
+          <a:blip r:embed="rId1"/>
+          <a:stretch>
+            <a:fillRect/>
+          </a:stretch>
+        </p:blipFill>
+        <p:spPr>
+          <a:xfrm>
+            <a:off x="502920" y="1965960"/>
+            <a:ext cx="3566160" cy="2532888"/>
+          </a:xfrm>
+          <a:prstGeom prst="rect">
+            <a:avLst/>
+          </a:prstGeom>
+        </p:spPr>
+      </p:pic>
+      <p:sp>
+        <p:nvSpPr>
+          <p:cNvPr id="4" name="Text 1"/>
+          <p:cNvSpPr txBox="1"/>
+          <p:nvPr/>
+        </p:nvSpPr>
+        <p:spPr>
+          <a:xfrm>
+            <a:off x="411480" y="4754880"/>
+            <a:ext cx="3749040" cy="457200"/>
+          </a:xfrm>
+          <a:prstGeom prst="rect">
+            <a:avLst/>
+          </a:prstGeom>
+          <a:noFill/>
+          <a:ln/>
+        </p:spPr>
+        <p:txBody>
+          <a:bodyPr wrap="square" lIns="0" tIns="0" rIns="0" bIns="0" rtlCol="0" anchor="t"/>
+          <a:lstStyle/>
+          <a:p>
+            <a:pPr indent="0" marL="0">
+              <a:buNone/>
+            </a:pPr>
+            <a:r>
+              <a:rPr lang="en-US" sz="1100" i="1" dirty="0">
+                <a:solidFill>
+                  <a:schemeClr val="tx2"/>
+                </a:solidFill>
+              </a:rPr>
+              <a:t>MOPI diploma, 1931</a:t>
+            </a:r>
+            <a:endParaRPr lang="en-US" sz="1100" dirty="0"/>
+          </a:p>
+        </p:txBody>
+      </p:sp>
+      <p:sp>
+        <p:nvSpPr>
+          <p:cNvPr id="5" name="Decor 1931"/>
           <p:cNvSpPr txBox="1"/>
           <p:nvPr/>
         </p:nvSpPr>
@@ -3946,10 +4218,10 @@
       </p:sp>
       <p:sp>
         <p:nvSpPr>
-          <p:cNvPr id="4" name="Text 1"/>
+          <p:cNvPr id="6" name="Text 1"/>
           <p:cNvSpPr/>
           <p:nvPr>
-            <p:ph idx="102" type="title" hasCustomPrompt="1"/>
+            <p:ph idx="101" type="title" hasCustomPrompt="1"/>
           </p:nvPr>
         </p:nvSpPr>
         <p:spPr>
@@ -3987,7 +4259,7 @@
       </p:sp>
       <p:sp>
         <p:nvSpPr>
-          <p:cNvPr id="5" name="Text 3"/>
+          <p:cNvPr id="7" name="Text 4"/>
           <p:cNvSpPr txBox="1"/>
           <p:nvPr/>
         </p:nvSpPr>
@@ -4023,7 +4295,7 @@
       </p:sp>
       <p:sp>
         <p:nvSpPr>
-          <p:cNvPr id="6" name="Text 4"/>
+          <p:cNvPr id="8" name="Text 5"/>
           <p:cNvSpPr txBox="1"/>
           <p:nvPr/>
         </p:nvSpPr>
@@ -4059,7 +4331,7 @@
       </p:sp>
       <p:sp>
         <p:nvSpPr>
-          <p:cNvPr id="7" name="Text 5"/>
+          <p:cNvPr id="9" name="Text 6"/>
           <p:cNvSpPr txBox="1"/>
           <p:nvPr/>
         </p:nvSpPr>
@@ -4095,7 +4367,7 @@
       </p:sp>
       <p:sp>
         <p:nvSpPr>
-          <p:cNvPr id="8" name="Text 6"/>
+          <p:cNvPr id="10" name="Text 7"/>
           <p:cNvSpPr txBox="1"/>
           <p:nvPr/>
         </p:nvSpPr>
@@ -4374,80 +4646,56 @@
           </a:p>
         </p:txBody>
       </p:sp>
-      <p:sp>
-        <p:nvSpPr>
-          <p:cNvPr id="6" name="Timeline"/>
-          <p:cNvSpPr/>
-          <p:nvPr/>
-        </p:nvSpPr>
-        <p:spPr>
-          <a:xfrm>
-            <a:off x="4983480" y="2514600"/>
-            <a:ext cx="0" cy="2743200"/>
-          </a:xfrm>
-          <a:prstGeom prst="line">
-            <a:avLst/>
-          </a:prstGeom>
-          <a:noFill/>
-          <a:ln w="19050">
-            <a:solidFill>
-              <a:schemeClr val="accent3"/>
-            </a:solidFill>
-            <a:prstDash val="solid"/>
-          </a:ln>
-        </p:spPr>
-      </p:sp>
-      <p:sp>
-        <p:nvSpPr>
-          <p:cNvPr id="7" name="Timeline dot 1"/>
-          <p:cNvSpPr/>
-          <p:nvPr/>
-        </p:nvSpPr>
-        <p:spPr>
-          <a:xfrm>
-            <a:off x="4873752" y="2505456"/>
-            <a:ext cx="219456" cy="219456"/>
-          </a:xfrm>
-          <a:prstGeom prst="ellipse">
-            <a:avLst/>
-          </a:prstGeom>
-          <a:solidFill>
-            <a:schemeClr val="accent2"/>
-          </a:solidFill>
-          <a:ln w="25400">
-            <a:solidFill>
-              <a:schemeClr val="bg1"/>
-            </a:solidFill>
-            <a:prstDash val="solid"/>
-          </a:ln>
-        </p:spPr>
-      </p:sp>
-      <p:sp>
-        <p:nvSpPr>
-          <p:cNvPr id="8" name="Text 6"/>
-          <p:cNvSpPr txBox="1"/>
-          <p:nvPr/>
-        </p:nvSpPr>
-        <p:spPr>
-          <a:xfrm>
-            <a:off x="5349240" y="2377440"/>
-            <a:ext cx="2286000" cy="502920"/>
-          </a:xfrm>
-          <a:prstGeom prst="rect">
-            <a:avLst/>
-          </a:prstGeom>
-          <a:noFill/>
-          <a:ln/>
-        </p:spPr>
-        <p:txBody>
-          <a:bodyPr wrap="square" lIns="0" tIns="0" rIns="0" bIns="0" rtlCol="0" anchor="t"/>
-          <a:lstStyle/>
-          <a:p>
-            <a:pPr indent="0" marL="0">
-              <a:buNone/>
-            </a:pPr>
-            <a:r>
-              <a:rPr lang="en-US" sz="2800" dirty="0">
+      <p:pic>
+        <p:nvPicPr>
+          <p:cNvPr id="6" name="Portrait Afanasy Vasilyevich Shulgin" descr="Afanasy Vasilyevich Shulgin">    </p:cNvPr>
+          <p:cNvPicPr>
+            <a:picLocks noChangeAspect="1"/>
+          </p:cNvPicPr>
+          <p:nvPr/>
+        </p:nvPicPr>
+        <p:blipFill>
+          <a:blip r:embed="rId1"/>
+          <a:stretch>
+            <a:fillRect/>
+          </a:stretch>
+        </p:blipFill>
+        <p:spPr>
+          <a:xfrm>
+            <a:off x="4846320" y="2194560"/>
+            <a:ext cx="868680" cy="1143000"/>
+          </a:xfrm>
+          <a:prstGeom prst="rect">
+            <a:avLst/>
+          </a:prstGeom>
+        </p:spPr>
+      </p:pic>
+      <p:sp>
+        <p:nvSpPr>
+          <p:cNvPr id="7" name="Text 4"/>
+          <p:cNvSpPr txBox="1"/>
+          <p:nvPr/>
+        </p:nvSpPr>
+        <p:spPr>
+          <a:xfrm>
+            <a:off x="5989320" y="2468880"/>
+            <a:ext cx="2011680" cy="502920"/>
+          </a:xfrm>
+          <a:prstGeom prst="rect">
+            <a:avLst/>
+          </a:prstGeom>
+          <a:noFill/>
+          <a:ln/>
+        </p:spPr>
+        <p:txBody>
+          <a:bodyPr wrap="square" lIns="0" tIns="0" rIns="0" bIns="0" rtlCol="0" anchor="t"/>
+          <a:lstStyle/>
+          <a:p>
+            <a:pPr indent="0" marL="0">
+              <a:buNone/>
+            </a:pPr>
+            <a:r>
+              <a:rPr lang="en-US" sz="2600" dirty="0">
                 <a:solidFill>
                   <a:schemeClr val="accent2"/>
                 </a:solidFill>
@@ -4457,20 +4705,20 @@
               </a:rPr>
               <a:t>1931</a:t>
             </a:r>
-            <a:endParaRPr lang="en-US" sz="2800" dirty="0"/>
-          </a:p>
-        </p:txBody>
-      </p:sp>
-      <p:sp>
-        <p:nvSpPr>
-          <p:cNvPr id="9" name="Text 7"/>
-          <p:cNvSpPr txBox="1"/>
-          <p:nvPr/>
-        </p:nvSpPr>
-        <p:spPr>
-          <a:xfrm>
-            <a:off x="7680960" y="2450592"/>
-            <a:ext cx="4023360" cy="365760"/>
+            <a:endParaRPr lang="en-US" sz="2600" dirty="0"/>
+          </a:p>
+        </p:txBody>
+      </p:sp>
+      <p:sp>
+        <p:nvSpPr>
+          <p:cNvPr id="8" name="Text 5"/>
+          <p:cNvSpPr txBox="1"/>
+          <p:nvPr/>
+        </p:nvSpPr>
+        <p:spPr>
+          <a:xfrm>
+            <a:off x="8001000" y="2523744"/>
+            <a:ext cx="3749040" cy="365760"/>
           </a:xfrm>
           <a:prstGeom prst="rect">
             <a:avLst/>
@@ -4499,14 +4747,14 @@
       </p:sp>
       <p:sp>
         <p:nvSpPr>
-          <p:cNvPr id="10" name="Text 8"/>
-          <p:cNvSpPr txBox="1"/>
-          <p:nvPr/>
-        </p:nvSpPr>
-        <p:spPr>
-          <a:xfrm>
-            <a:off x="7680960" y="2834640"/>
-            <a:ext cx="4023360" cy="320040"/>
+          <p:cNvPr id="9" name="Text 6"/>
+          <p:cNvSpPr txBox="1"/>
+          <p:nvPr/>
+        </p:nvSpPr>
+        <p:spPr>
+          <a:xfrm>
+            <a:off x="8001000" y="2907792"/>
+            <a:ext cx="3749040" cy="320040"/>
           </a:xfrm>
           <a:prstGeom prst="rect">
             <a:avLst/>
@@ -4533,57 +4781,56 @@
           </a:p>
         </p:txBody>
       </p:sp>
-      <p:sp>
-        <p:nvSpPr>
-          <p:cNvPr id="11" name="Timeline dot 2"/>
-          <p:cNvSpPr/>
-          <p:nvPr/>
-        </p:nvSpPr>
-        <p:spPr>
-          <a:xfrm>
-            <a:off x="4873752" y="3694176"/>
-            <a:ext cx="219456" cy="219456"/>
-          </a:xfrm>
-          <a:prstGeom prst="ellipse">
-            <a:avLst/>
-          </a:prstGeom>
-          <a:solidFill>
-            <a:schemeClr val="accent2"/>
-          </a:solidFill>
-          <a:ln w="25400">
-            <a:solidFill>
-              <a:schemeClr val="bg1"/>
-            </a:solidFill>
-            <a:prstDash val="solid"/>
-          </a:ln>
-        </p:spPr>
-      </p:sp>
-      <p:sp>
-        <p:nvSpPr>
-          <p:cNvPr id="12" name="Text 10"/>
-          <p:cNvSpPr txBox="1"/>
-          <p:nvPr/>
-        </p:nvSpPr>
-        <p:spPr>
-          <a:xfrm>
-            <a:off x="5349240" y="3566160"/>
-            <a:ext cx="2286000" cy="502920"/>
-          </a:xfrm>
-          <a:prstGeom prst="rect">
-            <a:avLst/>
-          </a:prstGeom>
-          <a:noFill/>
-          <a:ln/>
-        </p:spPr>
-        <p:txBody>
-          <a:bodyPr wrap="square" lIns="0" tIns="0" rIns="0" bIns="0" rtlCol="0" anchor="t"/>
-          <a:lstStyle/>
-          <a:p>
-            <a:pPr indent="0" marL="0">
-              <a:buNone/>
-            </a:pPr>
-            <a:r>
-              <a:rPr lang="en-US" sz="2800" dirty="0">
+      <p:pic>
+        <p:nvPicPr>
+          <p:cNvPr id="10" name="Portrait A. A. Savrasova" descr="A. A. Savrasova">    </p:cNvPr>
+          <p:cNvPicPr>
+            <a:picLocks noChangeAspect="1"/>
+          </p:cNvPicPr>
+          <p:nvPr/>
+        </p:nvPicPr>
+        <p:blipFill>
+          <a:blip r:embed="rId2"/>
+          <a:stretch>
+            <a:fillRect/>
+          </a:stretch>
+        </p:blipFill>
+        <p:spPr>
+          <a:xfrm>
+            <a:off x="4846320" y="3493008"/>
+            <a:ext cx="868680" cy="1143000"/>
+          </a:xfrm>
+          <a:prstGeom prst="rect">
+            <a:avLst/>
+          </a:prstGeom>
+        </p:spPr>
+      </p:pic>
+      <p:sp>
+        <p:nvSpPr>
+          <p:cNvPr id="11" name="Text 7"/>
+          <p:cNvSpPr txBox="1"/>
+          <p:nvPr/>
+        </p:nvSpPr>
+        <p:spPr>
+          <a:xfrm>
+            <a:off x="5989320" y="3767328"/>
+            <a:ext cx="2011680" cy="502920"/>
+          </a:xfrm>
+          <a:prstGeom prst="rect">
+            <a:avLst/>
+          </a:prstGeom>
+          <a:noFill/>
+          <a:ln/>
+        </p:spPr>
+        <p:txBody>
+          <a:bodyPr wrap="square" lIns="0" tIns="0" rIns="0" bIns="0" rtlCol="0" anchor="t"/>
+          <a:lstStyle/>
+          <a:p>
+            <a:pPr indent="0" marL="0">
+              <a:buNone/>
+            </a:pPr>
+            <a:r>
+              <a:rPr lang="en-US" sz="2600" dirty="0">
                 <a:solidFill>
                   <a:schemeClr val="accent2"/>
                 </a:solidFill>
@@ -4593,20 +4840,20 @@
               </a:rPr>
               <a:t>1935–1936</a:t>
             </a:r>
-            <a:endParaRPr lang="en-US" sz="2800" dirty="0"/>
-          </a:p>
-        </p:txBody>
-      </p:sp>
-      <p:sp>
-        <p:nvSpPr>
-          <p:cNvPr id="13" name="Text 11"/>
-          <p:cNvSpPr txBox="1"/>
-          <p:nvPr/>
-        </p:nvSpPr>
-        <p:spPr>
-          <a:xfrm>
-            <a:off x="7680960" y="3639312"/>
-            <a:ext cx="4023360" cy="365760"/>
+            <a:endParaRPr lang="en-US" sz="2600" dirty="0"/>
+          </a:p>
+        </p:txBody>
+      </p:sp>
+      <p:sp>
+        <p:nvSpPr>
+          <p:cNvPr id="12" name="Text 8"/>
+          <p:cNvSpPr txBox="1"/>
+          <p:nvPr/>
+        </p:nvSpPr>
+        <p:spPr>
+          <a:xfrm>
+            <a:off x="8001000" y="3822192"/>
+            <a:ext cx="3749040" cy="365760"/>
           </a:xfrm>
           <a:prstGeom prst="rect">
             <a:avLst/>
@@ -4633,57 +4880,56 @@
           </a:p>
         </p:txBody>
       </p:sp>
-      <p:sp>
-        <p:nvSpPr>
-          <p:cNvPr id="14" name="Timeline dot 3"/>
-          <p:cNvSpPr/>
-          <p:nvPr/>
-        </p:nvSpPr>
-        <p:spPr>
-          <a:xfrm>
-            <a:off x="4873752" y="4882896"/>
-            <a:ext cx="219456" cy="219456"/>
-          </a:xfrm>
-          <a:prstGeom prst="ellipse">
-            <a:avLst/>
-          </a:prstGeom>
-          <a:solidFill>
-            <a:schemeClr val="accent2"/>
-          </a:solidFill>
-          <a:ln w="25400">
-            <a:solidFill>
-              <a:schemeClr val="bg1"/>
-            </a:solidFill>
-            <a:prstDash val="solid"/>
-          </a:ln>
-        </p:spPr>
-      </p:sp>
-      <p:sp>
-        <p:nvSpPr>
-          <p:cNvPr id="15" name="Text 13"/>
-          <p:cNvSpPr txBox="1"/>
-          <p:nvPr/>
-        </p:nvSpPr>
-        <p:spPr>
-          <a:xfrm>
-            <a:off x="5349240" y="4754880"/>
-            <a:ext cx="2286000" cy="502920"/>
-          </a:xfrm>
-          <a:prstGeom prst="rect">
-            <a:avLst/>
-          </a:prstGeom>
-          <a:noFill/>
-          <a:ln/>
-        </p:spPr>
-        <p:txBody>
-          <a:bodyPr wrap="square" lIns="0" tIns="0" rIns="0" bIns="0" rtlCol="0" anchor="t"/>
-          <a:lstStyle/>
-          <a:p>
-            <a:pPr indent="0" marL="0">
-              <a:buNone/>
-            </a:pPr>
-            <a:r>
-              <a:rPr lang="en-US" sz="2800" dirty="0">
+      <p:pic>
+        <p:nvPicPr>
+          <p:cNvPr id="13" name="Portrait D. A. Allakhverdyan" descr="D. A. Allakhverdyan">    </p:cNvPr>
+          <p:cNvPicPr>
+            <a:picLocks noChangeAspect="1"/>
+          </p:cNvPicPr>
+          <p:nvPr/>
+        </p:nvPicPr>
+        <p:blipFill>
+          <a:blip r:embed="rId3"/>
+          <a:stretch>
+            <a:fillRect/>
+          </a:stretch>
+        </p:blipFill>
+        <p:spPr>
+          <a:xfrm>
+            <a:off x="4846320" y="4791456"/>
+            <a:ext cx="868680" cy="1143000"/>
+          </a:xfrm>
+          <a:prstGeom prst="rect">
+            <a:avLst/>
+          </a:prstGeom>
+        </p:spPr>
+      </p:pic>
+      <p:sp>
+        <p:nvSpPr>
+          <p:cNvPr id="14" name="Text 9"/>
+          <p:cNvSpPr txBox="1"/>
+          <p:nvPr/>
+        </p:nvSpPr>
+        <p:spPr>
+          <a:xfrm>
+            <a:off x="5989320" y="5065776"/>
+            <a:ext cx="2011680" cy="502920"/>
+          </a:xfrm>
+          <a:prstGeom prst="rect">
+            <a:avLst/>
+          </a:prstGeom>
+          <a:noFill/>
+          <a:ln/>
+        </p:spPr>
+        <p:txBody>
+          <a:bodyPr wrap="square" lIns="0" tIns="0" rIns="0" bIns="0" rtlCol="0" anchor="t"/>
+          <a:lstStyle/>
+          <a:p>
+            <a:pPr indent="0" marL="0">
+              <a:buNone/>
+            </a:pPr>
+            <a:r>
+              <a:rPr lang="en-US" sz="2600" dirty="0">
                 <a:solidFill>
                   <a:schemeClr val="accent2"/>
                 </a:solidFill>
@@ -4693,20 +4939,20 @@
               </a:rPr>
               <a:t>1938–1941</a:t>
             </a:r>
-            <a:endParaRPr lang="en-US" sz="2800" dirty="0"/>
-          </a:p>
-        </p:txBody>
-      </p:sp>
-      <p:sp>
-        <p:nvSpPr>
-          <p:cNvPr id="16" name="Text 14"/>
-          <p:cNvSpPr txBox="1"/>
-          <p:nvPr/>
-        </p:nvSpPr>
-        <p:spPr>
-          <a:xfrm>
-            <a:off x="7680960" y="4828032"/>
-            <a:ext cx="4023360" cy="365760"/>
+            <a:endParaRPr lang="en-US" sz="2600" dirty="0"/>
+          </a:p>
+        </p:txBody>
+      </p:sp>
+      <p:sp>
+        <p:nvSpPr>
+          <p:cNvPr id="15" name="Text 10"/>
+          <p:cNvSpPr txBox="1"/>
+          <p:nvPr/>
+        </p:nvSpPr>
+        <p:spPr>
+          <a:xfrm>
+            <a:off x="8001000" y="5120640"/>
+            <a:ext cx="3749040" cy="365760"/>
           </a:xfrm>
           <a:prstGeom prst="rect">
             <a:avLst/>
@@ -4803,14 +5049,20 @@
           <a:chExt cx="0" cy="0"/>
         </a:xfrm>
       </p:grpSpPr>
-      <p:sp>
-        <p:nvSpPr>
-          <p:cNvPr id="2" name="Text 1"/>
-          <p:cNvSpPr/>
-          <p:nvPr>
-            <p:ph type="pic" idx="101" hasCustomPrompt="1"/>
-          </p:nvPr>
-        </p:nvSpPr>
+      <p:pic>
+        <p:nvPicPr>
+          <p:cNvPr id="2" name="faculties_group1933.jpg" descr="Group A, 2nd year, Literature faculty of MOPI, 1933">    </p:cNvPr>
+          <p:cNvPicPr>
+            <a:picLocks noChangeAspect="1"/>
+          </p:cNvPicPr>
+          <p:nvPr/>
+        </p:nvPicPr>
+        <p:blipFill>
+          <a:blip r:embed="rId1"/>
+          <a:stretch>
+            <a:fillRect/>
+          </a:stretch>
+        </p:blipFill>
         <p:spPr>
           <a:xfrm>
             <a:off x="5852160" y="0"/>
@@ -4819,22 +5071,8 @@
           <a:prstGeom prst="rect">
             <a:avLst/>
           </a:prstGeom>
-          <a:solidFill>
-            <a:schemeClr val="accent3"/>
-          </a:solidFill>
-          <a:ln/>
-        </p:spPr>
-        <p:txBody>
-          <a:bodyPr wrap="square" rtlCol="0" anchor="ctr"/>
-          <a:lstStyle/>
-          <a:p>
-            <a:pPr algn="ctr" indent="0" marL="0">
-              <a:buNone/>
-            </a:pPr>
-            <a:endParaRPr lang="en-US" sz="1200" dirty="0"/>
-          </a:p>
-        </p:txBody>
-      </p:sp>
+        </p:spPr>
+      </p:pic>
       <p:sp>
         <p:nvSpPr>
           <p:cNvPr id="3" name="Diagonal cut"/>
@@ -4885,7 +5123,72 @@
       </p:sp>
       <p:sp>
         <p:nvSpPr>
-          <p:cNvPr id="5" name="Text 1"/>
+          <p:cNvPr id="5" name="Caption strip"/>
+          <p:cNvSpPr/>
+          <p:nvPr/>
+        </p:nvSpPr>
+        <p:spPr>
+          <a:xfrm>
+            <a:off x="7863840" y="6172200"/>
+            <a:ext cx="4325112" cy="384048"/>
+          </a:xfrm>
+          <a:prstGeom prst="rect">
+            <a:avLst/>
+          </a:prstGeom>
+          <a:solidFill>
+            <a:schemeClr val="tx1">
+              <a:alpha val="75000"/>
+            </a:schemeClr>
+          </a:solidFill>
+          <a:ln w="12700">
+            <a:solidFill>
+              <a:schemeClr val="tx1">
+                <a:alpha val="0"/>
+              </a:schemeClr>
+            </a:solidFill>
+            <a:prstDash val="solid"/>
+          </a:ln>
+        </p:spPr>
+      </p:sp>
+      <p:sp>
+        <p:nvSpPr>
+          <p:cNvPr id="6" name="Text 3"/>
+          <p:cNvSpPr txBox="1"/>
+          <p:nvPr/>
+        </p:nvSpPr>
+        <p:spPr>
+          <a:xfrm>
+            <a:off x="8001000" y="6172200"/>
+            <a:ext cx="4050792" cy="384048"/>
+          </a:xfrm>
+          <a:prstGeom prst="rect">
+            <a:avLst/>
+          </a:prstGeom>
+          <a:noFill/>
+          <a:ln/>
+        </p:spPr>
+        <p:txBody>
+          <a:bodyPr wrap="square" lIns="0" tIns="0" rIns="0" bIns="0" rtlCol="0" anchor="ctr"/>
+          <a:lstStyle/>
+          <a:p>
+            <a:pPr indent="0" marL="0">
+              <a:buNone/>
+            </a:pPr>
+            <a:r>
+              <a:rPr lang="en-US" sz="1100" i="1" dirty="0">
+                <a:solidFill>
+                  <a:schemeClr val="bg1"/>
+                </a:solidFill>
+              </a:rPr>
+              <a:t>Group A, 2nd year, Literature faculty, 1933</a:t>
+            </a:r>
+            <a:endParaRPr lang="en-US" sz="1100" dirty="0"/>
+          </a:p>
+        </p:txBody>
+      </p:sp>
+      <p:sp>
+        <p:nvSpPr>
+          <p:cNvPr id="7" name="Text 1"/>
           <p:cNvSpPr/>
           <p:nvPr>
             <p:ph idx="102" type="title" hasCustomPrompt="1"/>
@@ -4926,7 +5229,7 @@
       </p:sp>
       <p:sp>
         <p:nvSpPr>
-          <p:cNvPr id="6" name="Text 4"/>
+          <p:cNvPr id="8" name="Text 5"/>
           <p:cNvSpPr txBox="1"/>
           <p:nvPr/>
         </p:nvSpPr>
@@ -4962,7 +5265,7 @@
       </p:sp>
       <p:sp>
         <p:nvSpPr>
-          <p:cNvPr id="7" name="Text 5"/>
+          <p:cNvPr id="9" name="Text 6"/>
           <p:cNvSpPr txBox="1"/>
           <p:nvPr/>
         </p:nvSpPr>
@@ -5001,7 +5304,7 @@
       </p:sp>
       <p:sp>
         <p:nvSpPr>
-          <p:cNvPr id="8" name="Text 6"/>
+          <p:cNvPr id="10" name="Text 7"/>
           <p:cNvSpPr txBox="1"/>
           <p:nvPr/>
         </p:nvSpPr>
@@ -5037,7 +5340,7 @@
       </p:sp>
       <p:sp>
         <p:nvSpPr>
-          <p:cNvPr id="9" name="Text 7"/>
+          <p:cNvPr id="11" name="Text 8"/>
           <p:cNvSpPr txBox="1"/>
           <p:nvPr/>
         </p:nvSpPr>
@@ -5073,7 +5376,7 @@
       </p:sp>
       <p:sp>
         <p:nvSpPr>
-          <p:cNvPr id="10" name="Text 8"/>
+          <p:cNvPr id="12" name="Text 9"/>
           <p:cNvSpPr txBox="1"/>
           <p:nvPr/>
         </p:nvSpPr>
@@ -5112,7 +5415,7 @@
       </p:sp>
       <p:sp>
         <p:nvSpPr>
-          <p:cNvPr id="11" name="Text 9"/>
+          <p:cNvPr id="13" name="Text 10"/>
           <p:cNvSpPr txBox="1"/>
           <p:nvPr/>
         </p:nvSpPr>
@@ -5148,7 +5451,7 @@
       </p:sp>
       <p:sp>
         <p:nvSpPr>
-          <p:cNvPr id="12" name="Text 10"/>
+          <p:cNvPr id="14" name="Text 11"/>
           <p:cNvSpPr txBox="1"/>
           <p:nvPr/>
         </p:nvSpPr>
@@ -5187,7 +5490,7 @@
       </p:sp>
       <p:sp>
         <p:nvSpPr>
-          <p:cNvPr id="13" name="Text 11"/>
+          <p:cNvPr id="15" name="Text 12"/>
           <p:cNvSpPr txBox="1"/>
           <p:nvPr/>
         </p:nvSpPr>
@@ -5223,7 +5526,7 @@
       </p:sp>
       <p:sp>
         <p:nvSpPr>
-          <p:cNvPr id="14" name="Stat card 1"/>
+          <p:cNvPr id="16" name="Stat card 1"/>
           <p:cNvSpPr/>
           <p:nvPr/>
         </p:nvSpPr>
@@ -5248,7 +5551,7 @@
       </p:sp>
       <p:sp>
         <p:nvSpPr>
-          <p:cNvPr id="15" name="Text 13"/>
+          <p:cNvPr id="17" name="Text 14"/>
           <p:cNvSpPr txBox="1"/>
           <p:nvPr/>
         </p:nvSpPr>
@@ -5287,7 +5590,7 @@
       </p:sp>
       <p:sp>
         <p:nvSpPr>
-          <p:cNvPr id="16" name="Text 14"/>
+          <p:cNvPr id="18" name="Text 15"/>
           <p:cNvSpPr txBox="1"/>
           <p:nvPr/>
         </p:nvSpPr>
@@ -5323,7 +5626,7 @@
       </p:sp>
       <p:sp>
         <p:nvSpPr>
-          <p:cNvPr id="17" name="Stat card 2"/>
+          <p:cNvPr id="19" name="Stat card 2"/>
           <p:cNvSpPr/>
           <p:nvPr/>
         </p:nvSpPr>
@@ -5348,7 +5651,7 @@
       </p:sp>
       <p:sp>
         <p:nvSpPr>
-          <p:cNvPr id="18" name="Text 16"/>
+          <p:cNvPr id="20" name="Text 17"/>
           <p:cNvSpPr txBox="1"/>
           <p:nvPr/>
         </p:nvSpPr>
@@ -5387,7 +5690,7 @@
       </p:sp>
       <p:sp>
         <p:nvSpPr>
-          <p:cNvPr id="19" name="Text 17"/>
+          <p:cNvPr id="21" name="Text 18"/>
           <p:cNvSpPr txBox="1"/>
           <p:nvPr/>
         </p:nvSpPr>
@@ -5418,6 +5721,36 @@
               <a:t>methodical office</a:t>
             </a:r>
             <a:endParaRPr lang="en-US" sz="1400" dirty="0"/>
+          </a:p>
+        </p:txBody>
+      </p:sp>
+      <p:sp>
+        <p:nvSpPr>
+          <p:cNvPr id="22" name="Text 1"/>
+          <p:cNvSpPr/>
+          <p:nvPr>
+            <p:ph type="pic" idx="101" hasCustomPrompt="1"/>
+          </p:nvPr>
+        </p:nvSpPr>
+        <p:spPr>
+          <a:xfrm>
+            <a:off x="5852160" y="0"/>
+            <a:ext cx="6339535" cy="6858000"/>
+          </a:xfrm>
+          <a:prstGeom prst="rect">
+            <a:avLst/>
+          </a:prstGeom>
+          <a:noFill/>
+          <a:ln/>
+        </p:spPr>
+        <p:txBody>
+          <a:bodyPr wrap="square" rtlCol="0" anchor="ctr"/>
+          <a:lstStyle/>
+          <a:p>
+            <a:pPr algn="ctr" indent="0" marL="0">
+              <a:buNone/>
+            </a:pPr>
+            <a:endParaRPr lang="en-US" sz="1200" dirty="0"/>
           </a:p>
         </p:txBody>
       </p:sp>
@@ -8440,14 +8773,20 @@
           <a:chExt cx="0" cy="0"/>
         </a:xfrm>
       </p:grpSpPr>
-      <p:sp>
-        <p:nvSpPr>
-          <p:cNvPr id="2" name="Text 1"/>
-          <p:cNvSpPr/>
-          <p:nvPr>
-            <p:ph type="pic" idx="101" hasCustomPrompt="1"/>
-          </p:nvPr>
-        </p:nvSpPr>
+      <p:pic>
+        <p:nvPicPr>
+          <p:cNvPr id="2" name="war_building.jpg" descr="The first and main pre-war MOPI building, Moscow, Podsosensky Lane, 20">    </p:cNvPr>
+          <p:cNvPicPr>
+            <a:picLocks noChangeAspect="1"/>
+          </p:cNvPicPr>
+          <p:nvPr/>
+        </p:nvPicPr>
+        <p:blipFill>
+          <a:blip r:embed="rId1"/>
+          <a:stretch>
+            <a:fillRect/>
+          </a:stretch>
+        </p:blipFill>
         <p:spPr>
           <a:xfrm>
             <a:off x="7223760" y="0"/>
@@ -8456,25 +8795,76 @@
           <a:prstGeom prst="rect">
             <a:avLst/>
           </a:prstGeom>
+        </p:spPr>
+      </p:pic>
+      <p:sp>
+        <p:nvSpPr>
+          <p:cNvPr id="3" name="Caption strip"/>
+          <p:cNvSpPr/>
+          <p:nvPr/>
+        </p:nvSpPr>
+        <p:spPr>
+          <a:xfrm>
+            <a:off x="7223760" y="6172200"/>
+            <a:ext cx="4967935" cy="384048"/>
+          </a:xfrm>
+          <a:prstGeom prst="rect">
+            <a:avLst/>
+          </a:prstGeom>
           <a:solidFill>
-            <a:schemeClr val="accent5"/>
+            <a:schemeClr val="tx1">
+              <a:alpha val="75000"/>
+            </a:schemeClr>
           </a:solidFill>
-          <a:ln/>
-        </p:spPr>
-        <p:txBody>
-          <a:bodyPr wrap="square" rtlCol="0" anchor="ctr"/>
-          <a:lstStyle/>
-          <a:p>
-            <a:pPr algn="ctr" indent="0" marL="0">
-              <a:buNone/>
-            </a:pPr>
-            <a:endParaRPr lang="en-US" sz="1200" dirty="0"/>
-          </a:p>
-        </p:txBody>
-      </p:sp>
-      <p:sp>
-        <p:nvSpPr>
-          <p:cNvPr id="3" name="Text 1"/>
+          <a:ln w="12700">
+            <a:solidFill>
+              <a:schemeClr val="tx1">
+                <a:alpha val="0"/>
+              </a:schemeClr>
+            </a:solidFill>
+            <a:prstDash val="solid"/>
+          </a:ln>
+        </p:spPr>
+      </p:sp>
+      <p:sp>
+        <p:nvSpPr>
+          <p:cNvPr id="4" name="Text 1"/>
+          <p:cNvSpPr txBox="1"/>
+          <p:nvPr/>
+        </p:nvSpPr>
+        <p:spPr>
+          <a:xfrm>
+            <a:off x="7360920" y="6172200"/>
+            <a:ext cx="4693615" cy="384048"/>
+          </a:xfrm>
+          <a:prstGeom prst="rect">
+            <a:avLst/>
+          </a:prstGeom>
+          <a:noFill/>
+          <a:ln/>
+        </p:spPr>
+        <p:txBody>
+          <a:bodyPr wrap="square" lIns="0" tIns="0" rIns="0" bIns="0" rtlCol="0" anchor="ctr"/>
+          <a:lstStyle/>
+          <a:p>
+            <a:pPr indent="0" marL="0">
+              <a:buNone/>
+            </a:pPr>
+            <a:r>
+              <a:rPr lang="en-US" sz="1100" i="1" dirty="0">
+                <a:solidFill>
+                  <a:schemeClr val="bg1"/>
+                </a:solidFill>
+              </a:rPr>
+              <a:t>MOPI's main pre-war building, Podsosensky Lane, 20</a:t>
+            </a:r>
+            <a:endParaRPr lang="en-US" sz="1100" dirty="0"/>
+          </a:p>
+        </p:txBody>
+      </p:sp>
+      <p:sp>
+        <p:nvSpPr>
+          <p:cNvPr id="5" name="Text 1"/>
           <p:cNvSpPr/>
           <p:nvPr>
             <p:ph idx="102" type="title" hasCustomPrompt="1"/>
@@ -8515,7 +8905,7 @@
       </p:sp>
       <p:sp>
         <p:nvSpPr>
-          <p:cNvPr id="4" name="Text 2"/>
+          <p:cNvPr id="6" name="Text 3"/>
           <p:cNvSpPr txBox="1"/>
           <p:nvPr/>
         </p:nvSpPr>
@@ -8554,7 +8944,7 @@
       </p:sp>
       <p:sp>
         <p:nvSpPr>
-          <p:cNvPr id="5" name="Text 3"/>
+          <p:cNvPr id="7" name="Text 4"/>
           <p:cNvSpPr txBox="1"/>
           <p:nvPr/>
         </p:nvSpPr>
@@ -8590,7 +8980,7 @@
       </p:sp>
       <p:sp>
         <p:nvSpPr>
-          <p:cNvPr id="6" name="Route line"/>
+          <p:cNvPr id="8" name="Route line"/>
           <p:cNvSpPr/>
           <p:nvPr/>
         </p:nvSpPr>
@@ -8613,7 +9003,7 @@
       </p:sp>
       <p:sp>
         <p:nvSpPr>
-          <p:cNvPr id="7" name="Route stop Moscow"/>
+          <p:cNvPr id="9" name="Route stop Moscow"/>
           <p:cNvSpPr/>
           <p:nvPr/>
         </p:nvSpPr>
@@ -8638,7 +9028,7 @@
       </p:sp>
       <p:sp>
         <p:nvSpPr>
-          <p:cNvPr id="8" name="Text 6"/>
+          <p:cNvPr id="10" name="Text 7"/>
           <p:cNvSpPr txBox="1"/>
           <p:nvPr/>
         </p:nvSpPr>
@@ -8674,7 +9064,7 @@
       </p:sp>
       <p:sp>
         <p:nvSpPr>
-          <p:cNvPr id="9" name="Text 7"/>
+          <p:cNvPr id="11" name="Text 8"/>
           <p:cNvSpPr txBox="1"/>
           <p:nvPr/>
         </p:nvSpPr>
@@ -8710,7 +9100,7 @@
       </p:sp>
       <p:sp>
         <p:nvSpPr>
-          <p:cNvPr id="10" name="Route stop Murom"/>
+          <p:cNvPr id="12" name="Route stop Murom"/>
           <p:cNvSpPr/>
           <p:nvPr/>
         </p:nvSpPr>
@@ -8735,7 +9125,7 @@
       </p:sp>
       <p:sp>
         <p:nvSpPr>
-          <p:cNvPr id="11" name="Text 9"/>
+          <p:cNvPr id="13" name="Text 10"/>
           <p:cNvSpPr txBox="1"/>
           <p:nvPr/>
         </p:nvSpPr>
@@ -8771,7 +9161,7 @@
       </p:sp>
       <p:sp>
         <p:nvSpPr>
-          <p:cNvPr id="12" name="Text 10"/>
+          <p:cNvPr id="14" name="Text 11"/>
           <p:cNvSpPr txBox="1"/>
           <p:nvPr/>
         </p:nvSpPr>
@@ -8807,7 +9197,7 @@
       </p:sp>
       <p:sp>
         <p:nvSpPr>
-          <p:cNvPr id="13" name="Route stop Malmyzh"/>
+          <p:cNvPr id="15" name="Route stop Malmyzh"/>
           <p:cNvSpPr/>
           <p:nvPr/>
         </p:nvSpPr>
@@ -8832,7 +9222,7 @@
       </p:sp>
       <p:sp>
         <p:nvSpPr>
-          <p:cNvPr id="14" name="Text 12"/>
+          <p:cNvPr id="16" name="Text 13"/>
           <p:cNvSpPr txBox="1"/>
           <p:nvPr/>
         </p:nvSpPr>
@@ -8868,7 +9258,7 @@
       </p:sp>
       <p:sp>
         <p:nvSpPr>
-          <p:cNvPr id="15" name="Text 13"/>
+          <p:cNvPr id="17" name="Text 14"/>
           <p:cNvSpPr txBox="1"/>
           <p:nvPr/>
         </p:nvSpPr>
@@ -8904,7 +9294,7 @@
       </p:sp>
       <p:sp>
         <p:nvSpPr>
-          <p:cNvPr id="16" name="Text 14"/>
+          <p:cNvPr id="18" name="Text 15"/>
           <p:cNvSpPr txBox="1"/>
           <p:nvPr/>
         </p:nvSpPr>
@@ -8943,7 +9333,7 @@
       </p:sp>
       <p:sp>
         <p:nvSpPr>
-          <p:cNvPr id="17" name="Text 15"/>
+          <p:cNvPr id="19" name="Text 16"/>
           <p:cNvSpPr txBox="1"/>
           <p:nvPr/>
         </p:nvSpPr>
@@ -8979,7 +9369,7 @@
       </p:sp>
       <p:sp>
         <p:nvSpPr>
-          <p:cNvPr id="18" name="Text 16"/>
+          <p:cNvPr id="20" name="Text 17"/>
           <p:cNvSpPr txBox="1"/>
           <p:nvPr/>
         </p:nvSpPr>
@@ -9018,7 +9408,7 @@
       </p:sp>
       <p:sp>
         <p:nvSpPr>
-          <p:cNvPr id="19" name="Text 17"/>
+          <p:cNvPr id="21" name="Text 18"/>
           <p:cNvSpPr txBox="1"/>
           <p:nvPr/>
         </p:nvSpPr>
@@ -9054,7 +9444,7 @@
       </p:sp>
       <p:sp>
         <p:nvSpPr>
-          <p:cNvPr id="20" name="Text 18"/>
+          <p:cNvPr id="22" name="Text 19"/>
           <p:cNvSpPr txBox="1"/>
           <p:nvPr/>
         </p:nvSpPr>
@@ -9093,7 +9483,7 @@
       </p:sp>
       <p:sp>
         <p:nvSpPr>
-          <p:cNvPr id="21" name="Text 19"/>
+          <p:cNvPr id="23" name="Text 20"/>
           <p:cNvSpPr txBox="1"/>
           <p:nvPr/>
         </p:nvSpPr>
@@ -9124,6 +9514,36 @@
               <a:t>teachers arrived in Malmyzh</a:t>
             </a:r>
             <a:endParaRPr lang="en-US" sz="1400" dirty="0"/>
+          </a:p>
+        </p:txBody>
+      </p:sp>
+      <p:sp>
+        <p:nvSpPr>
+          <p:cNvPr id="24" name="Text 1"/>
+          <p:cNvSpPr/>
+          <p:nvPr>
+            <p:ph type="pic" idx="101" hasCustomPrompt="1"/>
+          </p:nvPr>
+        </p:nvSpPr>
+        <p:spPr>
+          <a:xfrm>
+            <a:off x="7223760" y="0"/>
+            <a:ext cx="4967935" cy="6858000"/>
+          </a:xfrm>
+          <a:prstGeom prst="rect">
+            <a:avLst/>
+          </a:prstGeom>
+          <a:noFill/>
+          <a:ln/>
+        </p:spPr>
+        <p:txBody>
+          <a:bodyPr wrap="square" rtlCol="0" anchor="ctr"/>
+          <a:lstStyle/>
+          <a:p>
+            <a:pPr algn="ctr" indent="0" marL="0">
+              <a:buNone/>
+            </a:pPr>
+            <a:endParaRPr lang="en-US" sz="1200" dirty="0"/>
           </a:p>
         </p:txBody>
       </p:sp>

</xml_diff>

<commit_message>
Add chemistry 1931, Uzboy expedition and Rybakov photos to the deck
Co-Authored-By: Claude Opus 5.5 <noreply@anthropic.com>
Claude-Session: https://claude.ai/code/session_01Gbke9ULM5RvL1ZnrLDt9QB
</commit_message>
<xml_diff>
--- a/presentation/MOPI_History_1931-1940.pptx
+++ b/presentation/MOPI_History_1931-1940.pptx
@@ -116,12 +116,12 @@
   <p:extLst>
     <p:ext uri="{521415D9-36F7-43E2-AB2F-B90AF26B5E84}">
       <p14:sectionLst xmlns:p14="http://schemas.microsoft.com/office/powerpoint/2010/main">
-        <p14:section name="Introduction" id="{0a51c069-02b8-ee59-5a2f-2d85a8beea2d}">
+        <p14:section name="Introduction" id="{853a0a86-09ec-e51e-f725-8fb034a42abc}">
           <p14:sldIdLst>
             <p14:sldId id="256"/>
           </p14:sldIdLst>
         </p14:section>
-        <p14:section name="The First Decade" id="{1ea9688a-95ee-32b8-ad56-4f5720d2bd84}">
+        <p14:section name="The First Decade" id="{44fea766-0207-4755-e9f8-bd2d21c5ebdd}">
           <p14:sldIdLst>
             <p14:sldId id="257"/>
             <p14:sldId id="258"/>
@@ -132,7 +132,7 @@
             <p14:sldId id="263"/>
           </p14:sldIdLst>
         </p14:section>
-        <p14:section name="1941" id="{d897a739-f253-9ebc-6d05-20d62e12e959}">
+        <p14:section name="1941" id="{636576f4-83f0-eb40-48d3-0133e192c734}">
           <p14:sldIdLst>
             <p14:sldId id="264"/>
             <p14:sldId id="265"/>
@@ -5051,7 +5051,7 @@
       </p:grpSpPr>
       <p:pic>
         <p:nvPicPr>
-          <p:cNvPr id="2" name="faculties_group1933.jpg" descr="Group A, 2nd year, Literature faculty of MOPI, 1933">    </p:cNvPr>
+          <p:cNvPr id="2" name="faculties_chem1931.jpg" descr="Chemistry students of the first MOPI intake, 1931">    </p:cNvPr>
           <p:cNvPicPr>
             <a:picLocks noChangeAspect="1"/>
           </p:cNvPicPr>
@@ -5180,7 +5180,7 @@
                   <a:schemeClr val="bg1"/>
                 </a:solidFill>
               </a:rPr>
-              <a:t>Group A, 2nd year, Literature faculty, 1933</a:t>
+              <a:t>Chemistry students of the first MOPI intake, 1931</a:t>
             </a:r>
             <a:endParaRPr lang="en-US" sz="1100" dirty="0"/>
           </a:p>
@@ -5826,46 +5826,7 @@
       </p:grpSpPr>
       <p:sp>
         <p:nvSpPr>
-          <p:cNvPr id="2" name="Decor 1932"/>
-          <p:cNvSpPr txBox="1"/>
-          <p:nvPr/>
-        </p:nvSpPr>
-        <p:spPr>
-          <a:xfrm>
-            <a:off x="5486400" y="45720"/>
-            <a:ext cx="6309360" cy="1828800"/>
-          </a:xfrm>
-          <a:prstGeom prst="rect">
-            <a:avLst/>
-          </a:prstGeom>
-          <a:noFill/>
-          <a:ln/>
-        </p:spPr>
-        <p:txBody>
-          <a:bodyPr wrap="square" lIns="0" tIns="0" rIns="0" bIns="0" rtlCol="0" anchor="t"/>
-          <a:lstStyle/>
-          <a:p>
-            <a:pPr algn="r" indent="0" marL="0">
-              <a:buNone/>
-            </a:pPr>
-            <a:r>
-              <a:rPr lang="en-US" sz="13000" dirty="0">
-                <a:solidFill>
-                  <a:schemeClr val="bg2"/>
-                </a:solidFill>
-                <a:latin typeface="Times New Roman" pitchFamily="34" charset="0"/>
-                <a:ea typeface="Times New Roman" pitchFamily="34" charset="-122"/>
-                <a:cs typeface="Times New Roman" pitchFamily="34" charset="-120"/>
-              </a:rPr>
-              <a:t>1932</a:t>
-            </a:r>
-            <a:endParaRPr lang="en-US" sz="13000" dirty="0"/>
-          </a:p>
-        </p:txBody>
-      </p:sp>
-      <p:sp>
-        <p:nvSpPr>
-          <p:cNvPr id="3" name="Text 0"/>
+          <p:cNvPr id="2" name="Text 0"/>
           <p:cNvSpPr/>
           <p:nvPr>
             <p:ph idx="100" type="title" hasCustomPrompt="1"/>
@@ -5906,7 +5867,7 @@
       </p:sp>
       <p:sp>
         <p:nvSpPr>
-          <p:cNvPr id="4" name="Text 2"/>
+          <p:cNvPr id="3" name="Text 1"/>
           <p:cNvSpPr txBox="1"/>
           <p:nvPr/>
         </p:nvSpPr>
@@ -5942,7 +5903,7 @@
       </p:sp>
       <p:sp>
         <p:nvSpPr>
-          <p:cNvPr id="5" name="Text 3"/>
+          <p:cNvPr id="4" name="Text 2"/>
           <p:cNvSpPr txBox="1"/>
           <p:nvPr/>
         </p:nvSpPr>
@@ -5978,14 +5939,14 @@
       </p:sp>
       <p:sp>
         <p:nvSpPr>
-          <p:cNvPr id="6" name="Faculty Literature"/>
+          <p:cNvPr id="5" name="Faculty Literature"/>
           <p:cNvSpPr/>
           <p:nvPr/>
         </p:nvSpPr>
         <p:spPr>
           <a:xfrm>
-            <a:off x="640080" y="2377440"/>
-            <a:ext cx="1920240" cy="1508760"/>
+            <a:off x="640080" y="2331720"/>
+            <a:ext cx="1920240" cy="777240"/>
           </a:xfrm>
           <a:prstGeom prst="rect">
             <a:avLst/>
@@ -6003,30 +5964,30 @@
       </p:sp>
       <p:sp>
         <p:nvSpPr>
-          <p:cNvPr id="7" name="Text 5"/>
-          <p:cNvSpPr txBox="1"/>
-          <p:nvPr/>
-        </p:nvSpPr>
-        <p:spPr>
-          <a:xfrm>
-            <a:off x="822960" y="2542032"/>
-            <a:ext cx="914400" cy="320040"/>
-          </a:xfrm>
-          <a:prstGeom prst="rect">
-            <a:avLst/>
-          </a:prstGeom>
-          <a:noFill/>
-          <a:ln/>
-        </p:spPr>
-        <p:txBody>
-          <a:bodyPr wrap="square" lIns="0" tIns="0" rIns="0" bIns="0" rtlCol="0" anchor="t"/>
-          <a:lstStyle/>
-          <a:p>
-            <a:pPr indent="0" marL="0">
-              <a:buNone/>
-            </a:pPr>
-            <a:r>
-              <a:rPr lang="en-US" sz="1600" dirty="0">
+          <p:cNvPr id="6" name="Text 4"/>
+          <p:cNvSpPr txBox="1"/>
+          <p:nvPr/>
+        </p:nvSpPr>
+        <p:spPr>
+          <a:xfrm>
+            <a:off x="804672" y="2331720"/>
+            <a:ext cx="457200" cy="777240"/>
+          </a:xfrm>
+          <a:prstGeom prst="rect">
+            <a:avLst/>
+          </a:prstGeom>
+          <a:noFill/>
+          <a:ln/>
+        </p:spPr>
+        <p:txBody>
+          <a:bodyPr wrap="square" lIns="0" tIns="0" rIns="0" bIns="0" rtlCol="0" anchor="ctr"/>
+          <a:lstStyle/>
+          <a:p>
+            <a:pPr indent="0" marL="0">
+              <a:buNone/>
+            </a:pPr>
+            <a:r>
+              <a:rPr lang="en-US" sz="1400" dirty="0">
                 <a:solidFill>
                   <a:schemeClr val="accent2"/>
                 </a:solidFill>
@@ -6036,36 +5997,36 @@
               </a:rPr>
               <a:t>01</a:t>
             </a:r>
-            <a:endParaRPr lang="en-US" sz="1600" dirty="0"/>
-          </a:p>
-        </p:txBody>
-      </p:sp>
-      <p:sp>
-        <p:nvSpPr>
-          <p:cNvPr id="8" name="Text 6"/>
-          <p:cNvSpPr txBox="1"/>
-          <p:nvPr/>
-        </p:nvSpPr>
-        <p:spPr>
-          <a:xfrm>
-            <a:off x="822960" y="3291840"/>
-            <a:ext cx="1645920" cy="411480"/>
-          </a:xfrm>
-          <a:prstGeom prst="rect">
-            <a:avLst/>
-          </a:prstGeom>
-          <a:noFill/>
-          <a:ln/>
-        </p:spPr>
-        <p:txBody>
-          <a:bodyPr wrap="square" lIns="0" tIns="0" rIns="0" bIns="0" rtlCol="0" anchor="t"/>
-          <a:lstStyle/>
-          <a:p>
-            <a:pPr indent="0" marL="0">
-              <a:buNone/>
-            </a:pPr>
-            <a:r>
-              <a:rPr lang="en-US" sz="2000" dirty="0">
+            <a:endParaRPr lang="en-US" sz="1400" dirty="0"/>
+          </a:p>
+        </p:txBody>
+      </p:sp>
+      <p:sp>
+        <p:nvSpPr>
+          <p:cNvPr id="7" name="Text 5"/>
+          <p:cNvSpPr txBox="1"/>
+          <p:nvPr/>
+        </p:nvSpPr>
+        <p:spPr>
+          <a:xfrm>
+            <a:off x="1207008" y="2331720"/>
+            <a:ext cx="1325880" cy="777240"/>
+          </a:xfrm>
+          <a:prstGeom prst="rect">
+            <a:avLst/>
+          </a:prstGeom>
+          <a:noFill/>
+          <a:ln/>
+        </p:spPr>
+        <p:txBody>
+          <a:bodyPr wrap="square" lIns="0" tIns="0" rIns="0" bIns="0" rtlCol="0" anchor="ctr"/>
+          <a:lstStyle/>
+          <a:p>
+            <a:pPr indent="0" marL="0">
+              <a:buNone/>
+            </a:pPr>
+            <a:r>
+              <a:rPr lang="en-US" sz="1700" dirty="0">
                 <a:solidFill>
                   <a:schemeClr val="tx1"/>
                 </a:solidFill>
@@ -6075,20 +6036,20 @@
               </a:rPr>
               <a:t>Literature</a:t>
             </a:r>
-            <a:endParaRPr lang="en-US" sz="2000" dirty="0"/>
-          </a:p>
-        </p:txBody>
-      </p:sp>
-      <p:sp>
-        <p:nvSpPr>
-          <p:cNvPr id="9" name="Faculty Geography"/>
+            <a:endParaRPr lang="en-US" sz="1700" dirty="0"/>
+          </a:p>
+        </p:txBody>
+      </p:sp>
+      <p:sp>
+        <p:nvSpPr>
+          <p:cNvPr id="8" name="Faculty Geography"/>
           <p:cNvSpPr/>
           <p:nvPr/>
         </p:nvSpPr>
         <p:spPr>
           <a:xfrm>
-            <a:off x="2743200" y="2377440"/>
-            <a:ext cx="1920240" cy="1508760"/>
+            <a:off x="2743200" y="2331720"/>
+            <a:ext cx="1920240" cy="777240"/>
           </a:xfrm>
           <a:prstGeom prst="rect">
             <a:avLst/>
@@ -6106,30 +6067,30 @@
       </p:sp>
       <p:sp>
         <p:nvSpPr>
-          <p:cNvPr id="10" name="Text 8"/>
-          <p:cNvSpPr txBox="1"/>
-          <p:nvPr/>
-        </p:nvSpPr>
-        <p:spPr>
-          <a:xfrm>
-            <a:off x="2926080" y="2542032"/>
-            <a:ext cx="914400" cy="320040"/>
-          </a:xfrm>
-          <a:prstGeom prst="rect">
-            <a:avLst/>
-          </a:prstGeom>
-          <a:noFill/>
-          <a:ln/>
-        </p:spPr>
-        <p:txBody>
-          <a:bodyPr wrap="square" lIns="0" tIns="0" rIns="0" bIns="0" rtlCol="0" anchor="t"/>
-          <a:lstStyle/>
-          <a:p>
-            <a:pPr indent="0" marL="0">
-              <a:buNone/>
-            </a:pPr>
-            <a:r>
-              <a:rPr lang="en-US" sz="1600" dirty="0">
+          <p:cNvPr id="9" name="Text 7"/>
+          <p:cNvSpPr txBox="1"/>
+          <p:nvPr/>
+        </p:nvSpPr>
+        <p:spPr>
+          <a:xfrm>
+            <a:off x="2907792" y="2331720"/>
+            <a:ext cx="457200" cy="777240"/>
+          </a:xfrm>
+          <a:prstGeom prst="rect">
+            <a:avLst/>
+          </a:prstGeom>
+          <a:noFill/>
+          <a:ln/>
+        </p:spPr>
+        <p:txBody>
+          <a:bodyPr wrap="square" lIns="0" tIns="0" rIns="0" bIns="0" rtlCol="0" anchor="ctr"/>
+          <a:lstStyle/>
+          <a:p>
+            <a:pPr indent="0" marL="0">
+              <a:buNone/>
+            </a:pPr>
+            <a:r>
+              <a:rPr lang="en-US" sz="1400" dirty="0">
                 <a:solidFill>
                   <a:schemeClr val="accent2"/>
                 </a:solidFill>
@@ -6139,36 +6100,36 @@
               </a:rPr>
               <a:t>02</a:t>
             </a:r>
-            <a:endParaRPr lang="en-US" sz="1600" dirty="0"/>
-          </a:p>
-        </p:txBody>
-      </p:sp>
-      <p:sp>
-        <p:nvSpPr>
-          <p:cNvPr id="11" name="Text 9"/>
-          <p:cNvSpPr txBox="1"/>
-          <p:nvPr/>
-        </p:nvSpPr>
-        <p:spPr>
-          <a:xfrm>
-            <a:off x="2926080" y="3291840"/>
-            <a:ext cx="1645920" cy="411480"/>
-          </a:xfrm>
-          <a:prstGeom prst="rect">
-            <a:avLst/>
-          </a:prstGeom>
-          <a:noFill/>
-          <a:ln/>
-        </p:spPr>
-        <p:txBody>
-          <a:bodyPr wrap="square" lIns="0" tIns="0" rIns="0" bIns="0" rtlCol="0" anchor="t"/>
-          <a:lstStyle/>
-          <a:p>
-            <a:pPr indent="0" marL="0">
-              <a:buNone/>
-            </a:pPr>
-            <a:r>
-              <a:rPr lang="en-US" sz="2000" dirty="0">
+            <a:endParaRPr lang="en-US" sz="1400" dirty="0"/>
+          </a:p>
+        </p:txBody>
+      </p:sp>
+      <p:sp>
+        <p:nvSpPr>
+          <p:cNvPr id="10" name="Text 8"/>
+          <p:cNvSpPr txBox="1"/>
+          <p:nvPr/>
+        </p:nvSpPr>
+        <p:spPr>
+          <a:xfrm>
+            <a:off x="3310128" y="2331720"/>
+            <a:ext cx="1325880" cy="777240"/>
+          </a:xfrm>
+          <a:prstGeom prst="rect">
+            <a:avLst/>
+          </a:prstGeom>
+          <a:noFill/>
+          <a:ln/>
+        </p:spPr>
+        <p:txBody>
+          <a:bodyPr wrap="square" lIns="0" tIns="0" rIns="0" bIns="0" rtlCol="0" anchor="ctr"/>
+          <a:lstStyle/>
+          <a:p>
+            <a:pPr indent="0" marL="0">
+              <a:buNone/>
+            </a:pPr>
+            <a:r>
+              <a:rPr lang="en-US" sz="1700" dirty="0">
                 <a:solidFill>
                   <a:schemeClr val="tx1"/>
                 </a:solidFill>
@@ -6178,20 +6139,20 @@
               </a:rPr>
               <a:t>Geography</a:t>
             </a:r>
-            <a:endParaRPr lang="en-US" sz="2000" dirty="0"/>
-          </a:p>
-        </p:txBody>
-      </p:sp>
-      <p:sp>
-        <p:nvSpPr>
-          <p:cNvPr id="12" name="Faculty Physics"/>
+            <a:endParaRPr lang="en-US" sz="1700" dirty="0"/>
+          </a:p>
+        </p:txBody>
+      </p:sp>
+      <p:sp>
+        <p:nvSpPr>
+          <p:cNvPr id="11" name="Faculty Physics"/>
           <p:cNvSpPr/>
           <p:nvPr/>
         </p:nvSpPr>
         <p:spPr>
           <a:xfrm>
-            <a:off x="4846320" y="2377440"/>
-            <a:ext cx="1920240" cy="1508760"/>
+            <a:off x="4846320" y="2331720"/>
+            <a:ext cx="1920240" cy="777240"/>
           </a:xfrm>
           <a:prstGeom prst="rect">
             <a:avLst/>
@@ -6209,30 +6170,30 @@
       </p:sp>
       <p:sp>
         <p:nvSpPr>
-          <p:cNvPr id="13" name="Text 11"/>
-          <p:cNvSpPr txBox="1"/>
-          <p:nvPr/>
-        </p:nvSpPr>
-        <p:spPr>
-          <a:xfrm>
-            <a:off x="5029200" y="2542032"/>
-            <a:ext cx="914400" cy="320040"/>
-          </a:xfrm>
-          <a:prstGeom prst="rect">
-            <a:avLst/>
-          </a:prstGeom>
-          <a:noFill/>
-          <a:ln/>
-        </p:spPr>
-        <p:txBody>
-          <a:bodyPr wrap="square" lIns="0" tIns="0" rIns="0" bIns="0" rtlCol="0" anchor="t"/>
-          <a:lstStyle/>
-          <a:p>
-            <a:pPr indent="0" marL="0">
-              <a:buNone/>
-            </a:pPr>
-            <a:r>
-              <a:rPr lang="en-US" sz="1600" dirty="0">
+          <p:cNvPr id="12" name="Text 10"/>
+          <p:cNvSpPr txBox="1"/>
+          <p:nvPr/>
+        </p:nvSpPr>
+        <p:spPr>
+          <a:xfrm>
+            <a:off x="5010912" y="2331720"/>
+            <a:ext cx="457200" cy="777240"/>
+          </a:xfrm>
+          <a:prstGeom prst="rect">
+            <a:avLst/>
+          </a:prstGeom>
+          <a:noFill/>
+          <a:ln/>
+        </p:spPr>
+        <p:txBody>
+          <a:bodyPr wrap="square" lIns="0" tIns="0" rIns="0" bIns="0" rtlCol="0" anchor="ctr"/>
+          <a:lstStyle/>
+          <a:p>
+            <a:pPr indent="0" marL="0">
+              <a:buNone/>
+            </a:pPr>
+            <a:r>
+              <a:rPr lang="en-US" sz="1400" dirty="0">
                 <a:solidFill>
                   <a:schemeClr val="accent2"/>
                 </a:solidFill>
@@ -6242,36 +6203,36 @@
               </a:rPr>
               <a:t>03</a:t>
             </a:r>
-            <a:endParaRPr lang="en-US" sz="1600" dirty="0"/>
-          </a:p>
-        </p:txBody>
-      </p:sp>
-      <p:sp>
-        <p:nvSpPr>
-          <p:cNvPr id="14" name="Text 12"/>
-          <p:cNvSpPr txBox="1"/>
-          <p:nvPr/>
-        </p:nvSpPr>
-        <p:spPr>
-          <a:xfrm>
-            <a:off x="5029200" y="3291840"/>
-            <a:ext cx="1645920" cy="411480"/>
-          </a:xfrm>
-          <a:prstGeom prst="rect">
-            <a:avLst/>
-          </a:prstGeom>
-          <a:noFill/>
-          <a:ln/>
-        </p:spPr>
-        <p:txBody>
-          <a:bodyPr wrap="square" lIns="0" tIns="0" rIns="0" bIns="0" rtlCol="0" anchor="t"/>
-          <a:lstStyle/>
-          <a:p>
-            <a:pPr indent="0" marL="0">
-              <a:buNone/>
-            </a:pPr>
-            <a:r>
-              <a:rPr lang="en-US" sz="2000" dirty="0">
+            <a:endParaRPr lang="en-US" sz="1400" dirty="0"/>
+          </a:p>
+        </p:txBody>
+      </p:sp>
+      <p:sp>
+        <p:nvSpPr>
+          <p:cNvPr id="13" name="Text 11"/>
+          <p:cNvSpPr txBox="1"/>
+          <p:nvPr/>
+        </p:nvSpPr>
+        <p:spPr>
+          <a:xfrm>
+            <a:off x="5413248" y="2331720"/>
+            <a:ext cx="1325880" cy="777240"/>
+          </a:xfrm>
+          <a:prstGeom prst="rect">
+            <a:avLst/>
+          </a:prstGeom>
+          <a:noFill/>
+          <a:ln/>
+        </p:spPr>
+        <p:txBody>
+          <a:bodyPr wrap="square" lIns="0" tIns="0" rIns="0" bIns="0" rtlCol="0" anchor="ctr"/>
+          <a:lstStyle/>
+          <a:p>
+            <a:pPr indent="0" marL="0">
+              <a:buNone/>
+            </a:pPr>
+            <a:r>
+              <a:rPr lang="en-US" sz="1700" dirty="0">
                 <a:solidFill>
                   <a:schemeClr val="tx1"/>
                 </a:solidFill>
@@ -6281,20 +6242,20 @@
               </a:rPr>
               <a:t>Physics</a:t>
             </a:r>
-            <a:endParaRPr lang="en-US" sz="2000" dirty="0"/>
-          </a:p>
-        </p:txBody>
-      </p:sp>
-      <p:sp>
-        <p:nvSpPr>
-          <p:cNvPr id="15" name="Faculty Chemistry"/>
+            <a:endParaRPr lang="en-US" sz="1700" dirty="0"/>
+          </a:p>
+        </p:txBody>
+      </p:sp>
+      <p:sp>
+        <p:nvSpPr>
+          <p:cNvPr id="14" name="Faculty Chemistry"/>
           <p:cNvSpPr/>
           <p:nvPr/>
         </p:nvSpPr>
         <p:spPr>
           <a:xfrm>
-            <a:off x="640080" y="4069080"/>
-            <a:ext cx="1920240" cy="1508760"/>
+            <a:off x="640080" y="3246120"/>
+            <a:ext cx="1920240" cy="777240"/>
           </a:xfrm>
           <a:prstGeom prst="rect">
             <a:avLst/>
@@ -6312,30 +6273,30 @@
       </p:sp>
       <p:sp>
         <p:nvSpPr>
-          <p:cNvPr id="16" name="Text 14"/>
-          <p:cNvSpPr txBox="1"/>
-          <p:nvPr/>
-        </p:nvSpPr>
-        <p:spPr>
-          <a:xfrm>
-            <a:off x="822960" y="4233672"/>
-            <a:ext cx="914400" cy="320040"/>
-          </a:xfrm>
-          <a:prstGeom prst="rect">
-            <a:avLst/>
-          </a:prstGeom>
-          <a:noFill/>
-          <a:ln/>
-        </p:spPr>
-        <p:txBody>
-          <a:bodyPr wrap="square" lIns="0" tIns="0" rIns="0" bIns="0" rtlCol="0" anchor="t"/>
-          <a:lstStyle/>
-          <a:p>
-            <a:pPr indent="0" marL="0">
-              <a:buNone/>
-            </a:pPr>
-            <a:r>
-              <a:rPr lang="en-US" sz="1600" dirty="0">
+          <p:cNvPr id="15" name="Text 13"/>
+          <p:cNvSpPr txBox="1"/>
+          <p:nvPr/>
+        </p:nvSpPr>
+        <p:spPr>
+          <a:xfrm>
+            <a:off x="804672" y="3246120"/>
+            <a:ext cx="457200" cy="777240"/>
+          </a:xfrm>
+          <a:prstGeom prst="rect">
+            <a:avLst/>
+          </a:prstGeom>
+          <a:noFill/>
+          <a:ln/>
+        </p:spPr>
+        <p:txBody>
+          <a:bodyPr wrap="square" lIns="0" tIns="0" rIns="0" bIns="0" rtlCol="0" anchor="ctr"/>
+          <a:lstStyle/>
+          <a:p>
+            <a:pPr indent="0" marL="0">
+              <a:buNone/>
+            </a:pPr>
+            <a:r>
+              <a:rPr lang="en-US" sz="1400" dirty="0">
                 <a:solidFill>
                   <a:schemeClr val="accent2"/>
                 </a:solidFill>
@@ -6345,36 +6306,36 @@
               </a:rPr>
               <a:t>04</a:t>
             </a:r>
-            <a:endParaRPr lang="en-US" sz="1600" dirty="0"/>
-          </a:p>
-        </p:txBody>
-      </p:sp>
-      <p:sp>
-        <p:nvSpPr>
-          <p:cNvPr id="17" name="Text 15"/>
-          <p:cNvSpPr txBox="1"/>
-          <p:nvPr/>
-        </p:nvSpPr>
-        <p:spPr>
-          <a:xfrm>
-            <a:off x="822960" y="4983480"/>
-            <a:ext cx="1645920" cy="411480"/>
-          </a:xfrm>
-          <a:prstGeom prst="rect">
-            <a:avLst/>
-          </a:prstGeom>
-          <a:noFill/>
-          <a:ln/>
-        </p:spPr>
-        <p:txBody>
-          <a:bodyPr wrap="square" lIns="0" tIns="0" rIns="0" bIns="0" rtlCol="0" anchor="t"/>
-          <a:lstStyle/>
-          <a:p>
-            <a:pPr indent="0" marL="0">
-              <a:buNone/>
-            </a:pPr>
-            <a:r>
-              <a:rPr lang="en-US" sz="2000" dirty="0">
+            <a:endParaRPr lang="en-US" sz="1400" dirty="0"/>
+          </a:p>
+        </p:txBody>
+      </p:sp>
+      <p:sp>
+        <p:nvSpPr>
+          <p:cNvPr id="16" name="Text 14"/>
+          <p:cNvSpPr txBox="1"/>
+          <p:nvPr/>
+        </p:nvSpPr>
+        <p:spPr>
+          <a:xfrm>
+            <a:off x="1207008" y="3246120"/>
+            <a:ext cx="1325880" cy="777240"/>
+          </a:xfrm>
+          <a:prstGeom prst="rect">
+            <a:avLst/>
+          </a:prstGeom>
+          <a:noFill/>
+          <a:ln/>
+        </p:spPr>
+        <p:txBody>
+          <a:bodyPr wrap="square" lIns="0" tIns="0" rIns="0" bIns="0" rtlCol="0" anchor="ctr"/>
+          <a:lstStyle/>
+          <a:p>
+            <a:pPr indent="0" marL="0">
+              <a:buNone/>
+            </a:pPr>
+            <a:r>
+              <a:rPr lang="en-US" sz="1700" dirty="0">
                 <a:solidFill>
                   <a:schemeClr val="tx1"/>
                 </a:solidFill>
@@ -6384,20 +6345,20 @@
               </a:rPr>
               <a:t>Chemistry</a:t>
             </a:r>
-            <a:endParaRPr lang="en-US" sz="2000" dirty="0"/>
-          </a:p>
-        </p:txBody>
-      </p:sp>
-      <p:sp>
-        <p:nvSpPr>
-          <p:cNvPr id="18" name="Faculty Economics"/>
+            <a:endParaRPr lang="en-US" sz="1700" dirty="0"/>
+          </a:p>
+        </p:txBody>
+      </p:sp>
+      <p:sp>
+        <p:nvSpPr>
+          <p:cNvPr id="17" name="Faculty Economics"/>
           <p:cNvSpPr/>
           <p:nvPr/>
         </p:nvSpPr>
         <p:spPr>
           <a:xfrm>
-            <a:off x="2743200" y="4069080"/>
-            <a:ext cx="1920240" cy="1508760"/>
+            <a:off x="2743200" y="3246120"/>
+            <a:ext cx="1920240" cy="777240"/>
           </a:xfrm>
           <a:prstGeom prst="rect">
             <a:avLst/>
@@ -6415,30 +6376,30 @@
       </p:sp>
       <p:sp>
         <p:nvSpPr>
-          <p:cNvPr id="19" name="Text 17"/>
-          <p:cNvSpPr txBox="1"/>
-          <p:nvPr/>
-        </p:nvSpPr>
-        <p:spPr>
-          <a:xfrm>
-            <a:off x="2926080" y="4233672"/>
-            <a:ext cx="914400" cy="320040"/>
-          </a:xfrm>
-          <a:prstGeom prst="rect">
-            <a:avLst/>
-          </a:prstGeom>
-          <a:noFill/>
-          <a:ln/>
-        </p:spPr>
-        <p:txBody>
-          <a:bodyPr wrap="square" lIns="0" tIns="0" rIns="0" bIns="0" rtlCol="0" anchor="t"/>
-          <a:lstStyle/>
-          <a:p>
-            <a:pPr indent="0" marL="0">
-              <a:buNone/>
-            </a:pPr>
-            <a:r>
-              <a:rPr lang="en-US" sz="1600" dirty="0">
+          <p:cNvPr id="18" name="Text 16"/>
+          <p:cNvSpPr txBox="1"/>
+          <p:nvPr/>
+        </p:nvSpPr>
+        <p:spPr>
+          <a:xfrm>
+            <a:off x="2907792" y="3246120"/>
+            <a:ext cx="457200" cy="777240"/>
+          </a:xfrm>
+          <a:prstGeom prst="rect">
+            <a:avLst/>
+          </a:prstGeom>
+          <a:noFill/>
+          <a:ln/>
+        </p:spPr>
+        <p:txBody>
+          <a:bodyPr wrap="square" lIns="0" tIns="0" rIns="0" bIns="0" rtlCol="0" anchor="ctr"/>
+          <a:lstStyle/>
+          <a:p>
+            <a:pPr indent="0" marL="0">
+              <a:buNone/>
+            </a:pPr>
+            <a:r>
+              <a:rPr lang="en-US" sz="1400" dirty="0">
                 <a:solidFill>
                   <a:schemeClr val="accent2"/>
                 </a:solidFill>
@@ -6448,36 +6409,36 @@
               </a:rPr>
               <a:t>05</a:t>
             </a:r>
-            <a:endParaRPr lang="en-US" sz="1600" dirty="0"/>
-          </a:p>
-        </p:txBody>
-      </p:sp>
-      <p:sp>
-        <p:nvSpPr>
-          <p:cNvPr id="20" name="Text 18"/>
-          <p:cNvSpPr txBox="1"/>
-          <p:nvPr/>
-        </p:nvSpPr>
-        <p:spPr>
-          <a:xfrm>
-            <a:off x="2926080" y="4983480"/>
-            <a:ext cx="1645920" cy="411480"/>
-          </a:xfrm>
-          <a:prstGeom prst="rect">
-            <a:avLst/>
-          </a:prstGeom>
-          <a:noFill/>
-          <a:ln/>
-        </p:spPr>
-        <p:txBody>
-          <a:bodyPr wrap="square" lIns="0" tIns="0" rIns="0" bIns="0" rtlCol="0" anchor="t"/>
-          <a:lstStyle/>
-          <a:p>
-            <a:pPr indent="0" marL="0">
-              <a:buNone/>
-            </a:pPr>
-            <a:r>
-              <a:rPr lang="en-US" sz="2000" dirty="0">
+            <a:endParaRPr lang="en-US" sz="1400" dirty="0"/>
+          </a:p>
+        </p:txBody>
+      </p:sp>
+      <p:sp>
+        <p:nvSpPr>
+          <p:cNvPr id="19" name="Text 17"/>
+          <p:cNvSpPr txBox="1"/>
+          <p:nvPr/>
+        </p:nvSpPr>
+        <p:spPr>
+          <a:xfrm>
+            <a:off x="3310128" y="3246120"/>
+            <a:ext cx="1325880" cy="777240"/>
+          </a:xfrm>
+          <a:prstGeom prst="rect">
+            <a:avLst/>
+          </a:prstGeom>
+          <a:noFill/>
+          <a:ln/>
+        </p:spPr>
+        <p:txBody>
+          <a:bodyPr wrap="square" lIns="0" tIns="0" rIns="0" bIns="0" rtlCol="0" anchor="ctr"/>
+          <a:lstStyle/>
+          <a:p>
+            <a:pPr indent="0" marL="0">
+              <a:buNone/>
+            </a:pPr>
+            <a:r>
+              <a:rPr lang="en-US" sz="1700" dirty="0">
                 <a:solidFill>
                   <a:schemeClr val="tx1"/>
                 </a:solidFill>
@@ -6487,20 +6448,20 @@
               </a:rPr>
               <a:t>Economics</a:t>
             </a:r>
-            <a:endParaRPr lang="en-US" sz="2000" dirty="0"/>
-          </a:p>
-        </p:txBody>
-      </p:sp>
-      <p:sp>
-        <p:nvSpPr>
-          <p:cNvPr id="21" name="Faculty History"/>
+            <a:endParaRPr lang="en-US" sz="1700" dirty="0"/>
+          </a:p>
+        </p:txBody>
+      </p:sp>
+      <p:sp>
+        <p:nvSpPr>
+          <p:cNvPr id="20" name="Faculty History"/>
           <p:cNvSpPr/>
           <p:nvPr/>
         </p:nvSpPr>
         <p:spPr>
           <a:xfrm>
-            <a:off x="4846320" y="4069080"/>
-            <a:ext cx="1920240" cy="1508760"/>
+            <a:off x="4846320" y="3246120"/>
+            <a:ext cx="1920240" cy="777240"/>
           </a:xfrm>
           <a:prstGeom prst="rect">
             <a:avLst/>
@@ -6518,30 +6479,30 @@
       </p:sp>
       <p:sp>
         <p:nvSpPr>
-          <p:cNvPr id="22" name="Text 20"/>
-          <p:cNvSpPr txBox="1"/>
-          <p:nvPr/>
-        </p:nvSpPr>
-        <p:spPr>
-          <a:xfrm>
-            <a:off x="5029200" y="4233672"/>
-            <a:ext cx="914400" cy="320040"/>
-          </a:xfrm>
-          <a:prstGeom prst="rect">
-            <a:avLst/>
-          </a:prstGeom>
-          <a:noFill/>
-          <a:ln/>
-        </p:spPr>
-        <p:txBody>
-          <a:bodyPr wrap="square" lIns="0" tIns="0" rIns="0" bIns="0" rtlCol="0" anchor="t"/>
-          <a:lstStyle/>
-          <a:p>
-            <a:pPr indent="0" marL="0">
-              <a:buNone/>
-            </a:pPr>
-            <a:r>
-              <a:rPr lang="en-US" sz="1600" dirty="0">
+          <p:cNvPr id="21" name="Text 19"/>
+          <p:cNvSpPr txBox="1"/>
+          <p:nvPr/>
+        </p:nvSpPr>
+        <p:spPr>
+          <a:xfrm>
+            <a:off x="5010912" y="3246120"/>
+            <a:ext cx="457200" cy="777240"/>
+          </a:xfrm>
+          <a:prstGeom prst="rect">
+            <a:avLst/>
+          </a:prstGeom>
+          <a:noFill/>
+          <a:ln/>
+        </p:spPr>
+        <p:txBody>
+          <a:bodyPr wrap="square" lIns="0" tIns="0" rIns="0" bIns="0" rtlCol="0" anchor="ctr"/>
+          <a:lstStyle/>
+          <a:p>
+            <a:pPr indent="0" marL="0">
+              <a:buNone/>
+            </a:pPr>
+            <a:r>
+              <a:rPr lang="en-US" sz="1400" dirty="0">
                 <a:solidFill>
                   <a:schemeClr val="accent2"/>
                 </a:solidFill>
@@ -6551,36 +6512,36 @@
               </a:rPr>
               <a:t>06</a:t>
             </a:r>
-            <a:endParaRPr lang="en-US" sz="1600" dirty="0"/>
-          </a:p>
-        </p:txBody>
-      </p:sp>
-      <p:sp>
-        <p:nvSpPr>
-          <p:cNvPr id="23" name="Text 21"/>
-          <p:cNvSpPr txBox="1"/>
-          <p:nvPr/>
-        </p:nvSpPr>
-        <p:spPr>
-          <a:xfrm>
-            <a:off x="5029200" y="4983480"/>
-            <a:ext cx="1645920" cy="411480"/>
-          </a:xfrm>
-          <a:prstGeom prst="rect">
-            <a:avLst/>
-          </a:prstGeom>
-          <a:noFill/>
-          <a:ln/>
-        </p:spPr>
-        <p:txBody>
-          <a:bodyPr wrap="square" lIns="0" tIns="0" rIns="0" bIns="0" rtlCol="0" anchor="t"/>
-          <a:lstStyle/>
-          <a:p>
-            <a:pPr indent="0" marL="0">
-              <a:buNone/>
-            </a:pPr>
-            <a:r>
-              <a:rPr lang="en-US" sz="2000" dirty="0">
+            <a:endParaRPr lang="en-US" sz="1400" dirty="0"/>
+          </a:p>
+        </p:txBody>
+      </p:sp>
+      <p:sp>
+        <p:nvSpPr>
+          <p:cNvPr id="22" name="Text 20"/>
+          <p:cNvSpPr txBox="1"/>
+          <p:nvPr/>
+        </p:nvSpPr>
+        <p:spPr>
+          <a:xfrm>
+            <a:off x="5413248" y="3246120"/>
+            <a:ext cx="1325880" cy="777240"/>
+          </a:xfrm>
+          <a:prstGeom prst="rect">
+            <a:avLst/>
+          </a:prstGeom>
+          <a:noFill/>
+          <a:ln/>
+        </p:spPr>
+        <p:txBody>
+          <a:bodyPr wrap="square" lIns="0" tIns="0" rIns="0" bIns="0" rtlCol="0" anchor="ctr"/>
+          <a:lstStyle/>
+          <a:p>
+            <a:pPr indent="0" marL="0">
+              <a:buNone/>
+            </a:pPr>
+            <a:r>
+              <a:rPr lang="en-US" sz="1700" dirty="0">
                 <a:solidFill>
                   <a:schemeClr val="tx1"/>
                 </a:solidFill>
@@ -6590,20 +6551,20 @@
               </a:rPr>
               <a:t>History</a:t>
             </a:r>
-            <a:endParaRPr lang="en-US" sz="2000" dirty="0"/>
-          </a:p>
-        </p:txBody>
-      </p:sp>
-      <p:sp>
-        <p:nvSpPr>
-          <p:cNvPr id="24" name="Growth card 1"/>
+            <a:endParaRPr lang="en-US" sz="1700" dirty="0"/>
+          </a:p>
+        </p:txBody>
+      </p:sp>
+      <p:sp>
+        <p:nvSpPr>
+          <p:cNvPr id="23" name="Growth card 1"/>
           <p:cNvSpPr/>
           <p:nvPr/>
         </p:nvSpPr>
         <p:spPr>
           <a:xfrm>
-            <a:off x="7269480" y="1965960"/>
-            <a:ext cx="4279392" cy="1783080"/>
+            <a:off x="640080" y="4297680"/>
+            <a:ext cx="2971800" cy="1691640"/>
           </a:xfrm>
           <a:prstGeom prst="rect">
             <a:avLst/>
@@ -6621,30 +6582,30 @@
       </p:sp>
       <p:sp>
         <p:nvSpPr>
-          <p:cNvPr id="25" name="Text 23"/>
-          <p:cNvSpPr txBox="1"/>
-          <p:nvPr/>
-        </p:nvSpPr>
-        <p:spPr>
-          <a:xfrm>
-            <a:off x="7543800" y="2130552"/>
-            <a:ext cx="1371600" cy="685800"/>
-          </a:xfrm>
-          <a:prstGeom prst="rect">
-            <a:avLst/>
-          </a:prstGeom>
-          <a:noFill/>
-          <a:ln/>
-        </p:spPr>
-        <p:txBody>
-          <a:bodyPr wrap="square" lIns="0" tIns="0" rIns="0" bIns="0" rtlCol="0" anchor="t"/>
-          <a:lstStyle/>
-          <a:p>
-            <a:pPr indent="0" marL="0">
-              <a:buNone/>
-            </a:pPr>
-            <a:r>
-              <a:rPr lang="en-US" sz="4000" dirty="0">
+          <p:cNvPr id="24" name="Text 22"/>
+          <p:cNvSpPr txBox="1"/>
+          <p:nvPr/>
+        </p:nvSpPr>
+        <p:spPr>
+          <a:xfrm>
+            <a:off x="822960" y="4389120"/>
+            <a:ext cx="1051560" cy="548640"/>
+          </a:xfrm>
+          <a:prstGeom prst="rect">
+            <a:avLst/>
+          </a:prstGeom>
+          <a:noFill/>
+          <a:ln/>
+        </p:spPr>
+        <p:txBody>
+          <a:bodyPr wrap="square" lIns="0" tIns="0" rIns="0" bIns="0" rtlCol="0" anchor="ctr"/>
+          <a:lstStyle/>
+          <a:p>
+            <a:pPr indent="0" marL="0">
+              <a:buNone/>
+            </a:pPr>
+            <a:r>
+              <a:rPr lang="en-US" sz="3000" dirty="0">
                 <a:solidFill>
                   <a:schemeClr val="bg1"/>
                 </a:solidFill>
@@ -6654,7 +6615,43 @@
               </a:rPr>
               <a:t>1932</a:t>
             </a:r>
-            <a:endParaRPr lang="en-US" sz="4000" dirty="0"/>
+            <a:endParaRPr lang="en-US" sz="3000" dirty="0"/>
+          </a:p>
+        </p:txBody>
+      </p:sp>
+      <p:sp>
+        <p:nvSpPr>
+          <p:cNvPr id="25" name="Text 23"/>
+          <p:cNvSpPr txBox="1"/>
+          <p:nvPr/>
+        </p:nvSpPr>
+        <p:spPr>
+          <a:xfrm>
+            <a:off x="1874520" y="4389120"/>
+            <a:ext cx="1645920" cy="548640"/>
+          </a:xfrm>
+          <a:prstGeom prst="rect">
+            <a:avLst/>
+          </a:prstGeom>
+          <a:noFill/>
+          <a:ln/>
+        </p:spPr>
+        <p:txBody>
+          <a:bodyPr wrap="square" lIns="0" tIns="0" rIns="0" bIns="0" rtlCol="0" anchor="ctr"/>
+          <a:lstStyle/>
+          <a:p>
+            <a:pPr indent="0" marL="0">
+              <a:buNone/>
+            </a:pPr>
+            <a:r>
+              <a:rPr lang="en-US" sz="1300" b="1" dirty="0">
+                <a:solidFill>
+                  <a:schemeClr val="bg1"/>
+                </a:solidFill>
+              </a:rPr>
+              <a:t>Correspondence department opened</a:t>
+            </a:r>
+            <a:endParaRPr lang="en-US" sz="1300" dirty="0"/>
           </a:p>
         </p:txBody>
       </p:sp>
@@ -6666,80 +6663,44 @@
         </p:nvSpPr>
         <p:spPr>
           <a:xfrm>
-            <a:off x="8915400" y="2240280"/>
-            <a:ext cx="2468880" cy="548640"/>
-          </a:xfrm>
-          <a:prstGeom prst="rect">
-            <a:avLst/>
-          </a:prstGeom>
-          <a:noFill/>
-          <a:ln/>
-        </p:spPr>
-        <p:txBody>
-          <a:bodyPr wrap="square" lIns="0" tIns="0" rIns="0" bIns="0" rtlCol="0" anchor="ctr"/>
-          <a:lstStyle/>
-          <a:p>
-            <a:pPr indent="0" marL="0">
-              <a:buNone/>
-            </a:pPr>
-            <a:r>
-              <a:rPr lang="en-US" sz="1500" b="1" dirty="0">
+            <a:off x="822960" y="5029200"/>
+            <a:ext cx="2651760" cy="914400"/>
+          </a:xfrm>
+          <a:prstGeom prst="rect">
+            <a:avLst/>
+          </a:prstGeom>
+          <a:noFill/>
+          <a:ln/>
+        </p:spPr>
+        <p:txBody>
+          <a:bodyPr wrap="square" lIns="0" tIns="0" rIns="0" bIns="0" rtlCol="0" anchor="t"/>
+          <a:lstStyle/>
+          <a:p>
+            <a:pPr indent="0" marL="0">
+              <a:buNone/>
+            </a:pPr>
+            <a:r>
+              <a:rPr lang="en-US" sz="1300" dirty="0">
                 <a:solidFill>
                   <a:schemeClr val="bg1"/>
                 </a:solidFill>
               </a:rPr>
-              <a:t>Correspondence department opened</a:t>
-            </a:r>
-            <a:endParaRPr lang="en-US" sz="1500" dirty="0"/>
-          </a:p>
-        </p:txBody>
-      </p:sp>
-      <p:sp>
-        <p:nvSpPr>
-          <p:cNvPr id="27" name="Text 25"/>
-          <p:cNvSpPr txBox="1"/>
-          <p:nvPr/>
-        </p:nvSpPr>
-        <p:spPr>
-          <a:xfrm>
-            <a:off x="7543800" y="2880360"/>
-            <a:ext cx="3794760" cy="777240"/>
-          </a:xfrm>
-          <a:prstGeom prst="rect">
-            <a:avLst/>
-          </a:prstGeom>
-          <a:noFill/>
-          <a:ln/>
-        </p:spPr>
-        <p:txBody>
-          <a:bodyPr wrap="square" lIns="0" tIns="0" rIns="0" bIns="0" rtlCol="0" anchor="t"/>
-          <a:lstStyle/>
-          <a:p>
-            <a:pPr indent="0" marL="0">
-              <a:buNone/>
-            </a:pPr>
-            <a:r>
-              <a:rPr lang="en-US" sz="1400" dirty="0">
-                <a:solidFill>
-                  <a:schemeClr val="bg1"/>
-                </a:solidFill>
-              </a:rPr>
               <a:t>People could become teachers without leaving their jobs.</a:t>
             </a:r>
-            <a:endParaRPr lang="en-US" sz="1400" dirty="0"/>
-          </a:p>
-        </p:txBody>
-      </p:sp>
-      <p:sp>
-        <p:nvSpPr>
-          <p:cNvPr id="28" name="Growth card 2"/>
+            <a:endParaRPr lang="en-US" sz="1300" dirty="0"/>
+          </a:p>
+        </p:txBody>
+      </p:sp>
+      <p:sp>
+        <p:nvSpPr>
+          <p:cNvPr id="27" name="Growth card 2"/>
           <p:cNvSpPr/>
           <p:nvPr/>
         </p:nvSpPr>
         <p:spPr>
           <a:xfrm>
-            <a:off x="7269480" y="3931920"/>
-            <a:ext cx="4279392" cy="1783080"/>
+            <a:off x="3794760" y="4297680"/>
+            <a:ext cx="2971800" cy="1691640"/>
           </a:xfrm>
           <a:prstGeom prst="rect">
             <a:avLst/>
@@ -6757,30 +6718,30 @@
       </p:sp>
       <p:sp>
         <p:nvSpPr>
-          <p:cNvPr id="29" name="Text 27"/>
-          <p:cNvSpPr txBox="1"/>
-          <p:nvPr/>
-        </p:nvSpPr>
-        <p:spPr>
-          <a:xfrm>
-            <a:off x="7543800" y="4096512"/>
-            <a:ext cx="1371600" cy="685800"/>
-          </a:xfrm>
-          <a:prstGeom prst="rect">
-            <a:avLst/>
-          </a:prstGeom>
-          <a:noFill/>
-          <a:ln/>
-        </p:spPr>
-        <p:txBody>
-          <a:bodyPr wrap="square" lIns="0" tIns="0" rIns="0" bIns="0" rtlCol="0" anchor="t"/>
-          <a:lstStyle/>
-          <a:p>
-            <a:pPr indent="0" marL="0">
-              <a:buNone/>
-            </a:pPr>
-            <a:r>
-              <a:rPr lang="en-US" sz="4000" dirty="0">
+          <p:cNvPr id="28" name="Text 26"/>
+          <p:cNvSpPr txBox="1"/>
+          <p:nvPr/>
+        </p:nvSpPr>
+        <p:spPr>
+          <a:xfrm>
+            <a:off x="3977640" y="4389120"/>
+            <a:ext cx="1051560" cy="548640"/>
+          </a:xfrm>
+          <a:prstGeom prst="rect">
+            <a:avLst/>
+          </a:prstGeom>
+          <a:noFill/>
+          <a:ln/>
+        </p:spPr>
+        <p:txBody>
+          <a:bodyPr wrap="square" lIns="0" tIns="0" rIns="0" bIns="0" rtlCol="0" anchor="ctr"/>
+          <a:lstStyle/>
+          <a:p>
+            <a:pPr indent="0" marL="0">
+              <a:buNone/>
+            </a:pPr>
+            <a:r>
+              <a:rPr lang="en-US" sz="3000" dirty="0">
                 <a:solidFill>
                   <a:schemeClr val="bg1"/>
                 </a:solidFill>
@@ -6790,7 +6751,43 @@
               </a:rPr>
               <a:t>22</a:t>
             </a:r>
-            <a:endParaRPr lang="en-US" sz="4000" dirty="0"/>
+            <a:endParaRPr lang="en-US" sz="3000" dirty="0"/>
+          </a:p>
+        </p:txBody>
+      </p:sp>
+      <p:sp>
+        <p:nvSpPr>
+          <p:cNvPr id="29" name="Text 27"/>
+          <p:cNvSpPr txBox="1"/>
+          <p:nvPr/>
+        </p:nvSpPr>
+        <p:spPr>
+          <a:xfrm>
+            <a:off x="5029200" y="4389120"/>
+            <a:ext cx="1645920" cy="548640"/>
+          </a:xfrm>
+          <a:prstGeom prst="rect">
+            <a:avLst/>
+          </a:prstGeom>
+          <a:noFill/>
+          <a:ln/>
+        </p:spPr>
+        <p:txBody>
+          <a:bodyPr wrap="square" lIns="0" tIns="0" rIns="0" bIns="0" rtlCol="0" anchor="ctr"/>
+          <a:lstStyle/>
+          <a:p>
+            <a:pPr indent="0" marL="0">
+              <a:buNone/>
+            </a:pPr>
+            <a:r>
+              <a:rPr lang="en-US" sz="1300" b="1" dirty="0">
+                <a:solidFill>
+                  <a:schemeClr val="bg1"/>
+                </a:solidFill>
+              </a:rPr>
+              <a:t>First graduates, 1934/35</a:t>
+            </a:r>
+            <a:endParaRPr lang="en-US" sz="1300" dirty="0"/>
           </a:p>
         </p:txBody>
       </p:sp>
@@ -6802,44 +6799,68 @@
         </p:nvSpPr>
         <p:spPr>
           <a:xfrm>
-            <a:off x="8915400" y="4206240"/>
-            <a:ext cx="2468880" cy="548640"/>
-          </a:xfrm>
-          <a:prstGeom prst="rect">
-            <a:avLst/>
-          </a:prstGeom>
-          <a:noFill/>
-          <a:ln/>
-        </p:spPr>
-        <p:txBody>
-          <a:bodyPr wrap="square" lIns="0" tIns="0" rIns="0" bIns="0" rtlCol="0" anchor="ctr"/>
-          <a:lstStyle/>
-          <a:p>
-            <a:pPr indent="0" marL="0">
-              <a:buNone/>
-            </a:pPr>
-            <a:r>
-              <a:rPr lang="en-US" sz="1500" b="1" dirty="0">
+            <a:off x="3977640" y="5029200"/>
+            <a:ext cx="2651760" cy="914400"/>
+          </a:xfrm>
+          <a:prstGeom prst="rect">
+            <a:avLst/>
+          </a:prstGeom>
+          <a:noFill/>
+          <a:ln/>
+        </p:spPr>
+        <p:txBody>
+          <a:bodyPr wrap="square" lIns="0" tIns="0" rIns="0" bIns="0" rtlCol="0" anchor="t"/>
+          <a:lstStyle/>
+          <a:p>
+            <a:pPr indent="0" marL="0">
+              <a:buNone/>
+            </a:pPr>
+            <a:r>
+              <a:rPr lang="en-US" sz="1300" dirty="0">
                 <a:solidFill>
                   <a:schemeClr val="bg1"/>
                 </a:solidFill>
               </a:rPr>
-              <a:t>First graduates, 1934/35</a:t>
-            </a:r>
-            <a:endParaRPr lang="en-US" sz="1500" dirty="0"/>
-          </a:p>
-        </p:txBody>
-      </p:sp>
-      <p:sp>
-        <p:nvSpPr>
-          <p:cNvPr id="31" name="Text 29"/>
-          <p:cNvSpPr txBox="1"/>
-          <p:nvPr/>
-        </p:nvSpPr>
-        <p:spPr>
-          <a:xfrm>
-            <a:off x="7543800" y="4846320"/>
-            <a:ext cx="3794760" cy="777240"/>
+              <a:t>All from the History faculty — the number was small because the university was still very young.</a:t>
+            </a:r>
+            <a:endParaRPr lang="en-US" sz="1300" dirty="0"/>
+          </a:p>
+        </p:txBody>
+      </p:sp>
+      <p:pic>
+        <p:nvPicPr>
+          <p:cNvPr id="31" name="growth_uzboy.jpg" descr="MOPI geographical expedition to the Uzboy river (Turkmenistan), early 1930s">    </p:cNvPr>
+          <p:cNvPicPr>
+            <a:picLocks noChangeAspect="1"/>
+          </p:cNvPicPr>
+          <p:nvPr/>
+        </p:nvPicPr>
+        <p:blipFill>
+          <a:blip r:embed="rId1"/>
+          <a:stretch>
+            <a:fillRect/>
+          </a:stretch>
+        </p:blipFill>
+        <p:spPr>
+          <a:xfrm>
+            <a:off x="7269480" y="1417320"/>
+            <a:ext cx="4279392" cy="3200400"/>
+          </a:xfrm>
+          <a:prstGeom prst="rect">
+            <a:avLst/>
+          </a:prstGeom>
+        </p:spPr>
+      </p:pic>
+      <p:sp>
+        <p:nvSpPr>
+          <p:cNvPr id="32" name="Text 29"/>
+          <p:cNvSpPr txBox="1"/>
+          <p:nvPr/>
+        </p:nvSpPr>
+        <p:spPr>
+          <a:xfrm>
+            <a:off x="7269480" y="4709160"/>
+            <a:ext cx="4279392" cy="457200"/>
           </a:xfrm>
           <a:prstGeom prst="rect">
             <a:avLst/>
@@ -6855,14 +6876,14 @@
               <a:buNone/>
             </a:pPr>
             <a:r>
-              <a:rPr lang="en-US" sz="1400" dirty="0">
-                <a:solidFill>
-                  <a:schemeClr val="bg1"/>
-                </a:solidFill>
-              </a:rPr>
-              <a:t>All from the History faculty — the number was small because the university was still very young.</a:t>
-            </a:r>
-            <a:endParaRPr lang="en-US" sz="1400" dirty="0"/>
+              <a:rPr lang="en-US" sz="1100" i="1" dirty="0">
+                <a:solidFill>
+                  <a:schemeClr val="tx2"/>
+                </a:solidFill>
+              </a:rPr>
+              <a:t>Geographical expedition of MOPI to the Uzboy river (Turkmenistan), early 1930s</a:t>
+            </a:r>
+            <a:endParaRPr lang="en-US" sz="1100" dirty="0"/>
           </a:p>
         </p:txBody>
       </p:sp>
@@ -7803,48 +7824,16 @@
       </p:grpSpPr>
       <p:sp>
         <p:nvSpPr>
-          <p:cNvPr id="2" name="Text 1"/>
+          <p:cNvPr id="2" name="Text 0"/>
           <p:cNvSpPr/>
           <p:nvPr>
-            <p:ph type="pic" idx="101" hasCustomPrompt="1"/>
+            <p:ph idx="100" type="title" hasCustomPrompt="1"/>
           </p:nvPr>
         </p:nvSpPr>
         <p:spPr>
           <a:xfrm>
-            <a:off x="7863840" y="0"/>
-            <a:ext cx="4327855" cy="6858000"/>
-          </a:xfrm>
-          <a:prstGeom prst="rect">
-            <a:avLst/>
-          </a:prstGeom>
-          <a:solidFill>
-            <a:schemeClr val="accent3"/>
-          </a:solidFill>
-          <a:ln/>
-        </p:spPr>
-        <p:txBody>
-          <a:bodyPr wrap="square" rtlCol="0" anchor="ctr"/>
-          <a:lstStyle/>
-          <a:p>
-            <a:pPr algn="ctr" indent="0" marL="0">
-              <a:buNone/>
-            </a:pPr>
-            <a:endParaRPr lang="en-US" sz="1200" dirty="0"/>
-          </a:p>
-        </p:txBody>
-      </p:sp>
-      <p:sp>
-        <p:nvSpPr>
-          <p:cNvPr id="3" name="Text 1"/>
-          <p:cNvSpPr/>
-          <p:nvPr>
-            <p:ph idx="102" type="title" hasCustomPrompt="1"/>
-          </p:nvPr>
-        </p:nvSpPr>
-        <p:spPr>
-          <a:xfrm>
             <a:off x="640080" y="502920"/>
-            <a:ext cx="6766560" cy="822960"/>
+            <a:ext cx="10881360" cy="822960"/>
           </a:xfrm>
           <a:prstGeom prst="rect">
             <a:avLst/>
@@ -7876,50 +7865,50 @@
       </p:sp>
       <p:sp>
         <p:nvSpPr>
+          <p:cNvPr id="3" name="Text 1"/>
+          <p:cNvSpPr txBox="1"/>
+          <p:nvPr/>
+        </p:nvSpPr>
+        <p:spPr>
+          <a:xfrm>
+            <a:off x="640080" y="1600200"/>
+            <a:ext cx="3108960" cy="274320"/>
+          </a:xfrm>
+          <a:prstGeom prst="rect">
+            <a:avLst/>
+          </a:prstGeom>
+          <a:noFill/>
+          <a:ln/>
+        </p:spPr>
+        <p:txBody>
+          <a:bodyPr wrap="square" lIns="0" tIns="0" rIns="0" bIns="0" rtlCol="0" anchor="t"/>
+          <a:lstStyle/>
+          <a:p>
+            <a:pPr indent="0" marL="0">
+              <a:buNone/>
+            </a:pPr>
+            <a:r>
+              <a:rPr lang="en-US" sz="1100" b="1" spc="300" kern="0" dirty="0">
+                <a:solidFill>
+                  <a:schemeClr val="accent2"/>
+                </a:solidFill>
+              </a:rPr>
+              <a:t>FIRST ACADEMIC JOURNAL</a:t>
+            </a:r>
+            <a:endParaRPr lang="en-US" sz="1100" dirty="0"/>
+          </a:p>
+        </p:txBody>
+      </p:sp>
+      <p:sp>
+        <p:nvSpPr>
           <p:cNvPr id="4" name="Text 2"/>
           <p:cNvSpPr txBox="1"/>
           <p:nvPr/>
         </p:nvSpPr>
         <p:spPr>
           <a:xfrm>
-            <a:off x="640080" y="1600200"/>
-            <a:ext cx="3291840" cy="274320"/>
-          </a:xfrm>
-          <a:prstGeom prst="rect">
-            <a:avLst/>
-          </a:prstGeom>
-          <a:noFill/>
-          <a:ln/>
-        </p:spPr>
-        <p:txBody>
-          <a:bodyPr wrap="square" lIns="0" tIns="0" rIns="0" bIns="0" rtlCol="0" anchor="t"/>
-          <a:lstStyle/>
-          <a:p>
-            <a:pPr indent="0" marL="0">
-              <a:buNone/>
-            </a:pPr>
-            <a:r>
-              <a:rPr lang="en-US" sz="1100" b="1" spc="300" kern="0" dirty="0">
-                <a:solidFill>
-                  <a:schemeClr val="accent2"/>
-                </a:solidFill>
-              </a:rPr>
-              <a:t>FIRST ACADEMIC JOURNAL</a:t>
-            </a:r>
-            <a:endParaRPr lang="en-US" sz="1100" dirty="0"/>
-          </a:p>
-        </p:txBody>
-      </p:sp>
-      <p:sp>
-        <p:nvSpPr>
-          <p:cNvPr id="5" name="Text 3"/>
-          <p:cNvSpPr txBox="1"/>
-          <p:nvPr/>
-        </p:nvSpPr>
-        <p:spPr>
-          <a:xfrm>
             <a:off x="640080" y="1874520"/>
-            <a:ext cx="3200400" cy="1143000"/>
+            <a:ext cx="3017520" cy="1143000"/>
           </a:xfrm>
           <a:prstGeom prst="rect">
             <a:avLst/>
@@ -7951,14 +7940,14 @@
       </p:sp>
       <p:sp>
         <p:nvSpPr>
-          <p:cNvPr id="6" name="Text 4"/>
+          <p:cNvPr id="5" name="Text 3"/>
           <p:cNvSpPr txBox="1"/>
           <p:nvPr/>
         </p:nvSpPr>
         <p:spPr>
           <a:xfrm>
             <a:off x="640080" y="3108960"/>
-            <a:ext cx="3200400" cy="457200"/>
+            <a:ext cx="3017520" cy="457200"/>
           </a:xfrm>
           <a:prstGeom prst="rect">
             <a:avLst/>
@@ -7990,14 +7979,50 @@
       </p:sp>
       <p:sp>
         <p:nvSpPr>
+          <p:cNvPr id="6" name="Text 4"/>
+          <p:cNvSpPr txBox="1"/>
+          <p:nvPr/>
+        </p:nvSpPr>
+        <p:spPr>
+          <a:xfrm>
+            <a:off x="640080" y="3703320"/>
+            <a:ext cx="2971800" cy="1463040"/>
+          </a:xfrm>
+          <a:prstGeom prst="rect">
+            <a:avLst/>
+          </a:prstGeom>
+          <a:noFill/>
+          <a:ln/>
+        </p:spPr>
+        <p:txBody>
+          <a:bodyPr wrap="square" lIns="0" tIns="0" rIns="0" bIns="0" rtlCol="0" anchor="t"/>
+          <a:lstStyle/>
+          <a:p>
+            <a:pPr indent="0" marL="0">
+              <a:buNone/>
+            </a:pPr>
+            <a:r>
+              <a:rPr lang="en-US" sz="1600" dirty="0">
+                <a:solidFill>
+                  <a:schemeClr val="tx1"/>
+                </a:solidFill>
+              </a:rPr>
+              <a:t>The institute started publishing its own academic journal, “Uchyonye Zapiski.”</a:t>
+            </a:r>
+            <a:endParaRPr lang="en-US" sz="1600" dirty="0"/>
+          </a:p>
+        </p:txBody>
+      </p:sp>
+      <p:sp>
+        <p:nvSpPr>
           <p:cNvPr id="7" name="Text 5"/>
           <p:cNvSpPr txBox="1"/>
           <p:nvPr/>
         </p:nvSpPr>
         <p:spPr>
           <a:xfrm>
-            <a:off x="640080" y="3703320"/>
-            <a:ext cx="3154680" cy="1463040"/>
+            <a:off x="3886200" y="1600200"/>
+            <a:ext cx="3108960" cy="274320"/>
           </a:xfrm>
           <a:prstGeom prst="rect">
             <a:avLst/>
@@ -8013,14 +8038,14 @@
               <a:buNone/>
             </a:pPr>
             <a:r>
-              <a:rPr lang="en-US" sz="1600" dirty="0">
-                <a:solidFill>
-                  <a:schemeClr val="tx1"/>
-                </a:solidFill>
-              </a:rPr>
-              <a:t>The institute started publishing its own academic journal, “Uchyonye Zapiski.”</a:t>
-            </a:r>
-            <a:endParaRPr lang="en-US" sz="1600" dirty="0"/>
+              <a:rPr lang="en-US" sz="1100" b="1" spc="300" kern="0" dirty="0">
+                <a:solidFill>
+                  <a:schemeClr val="accent2"/>
+                </a:solidFill>
+              </a:rPr>
+              <a:t>POSTGRADUATE STUDIES</a:t>
+            </a:r>
+            <a:endParaRPr lang="en-US" sz="1100" dirty="0"/>
           </a:p>
         </p:txBody>
       </p:sp>
@@ -8032,44 +8057,8 @@
         </p:nvSpPr>
         <p:spPr>
           <a:xfrm>
-            <a:off x="4160520" y="1600200"/>
-            <a:ext cx="3291840" cy="274320"/>
-          </a:xfrm>
-          <a:prstGeom prst="rect">
-            <a:avLst/>
-          </a:prstGeom>
-          <a:noFill/>
-          <a:ln/>
-        </p:spPr>
-        <p:txBody>
-          <a:bodyPr wrap="square" lIns="0" tIns="0" rIns="0" bIns="0" rtlCol="0" anchor="t"/>
-          <a:lstStyle/>
-          <a:p>
-            <a:pPr indent="0" marL="0">
-              <a:buNone/>
-            </a:pPr>
-            <a:r>
-              <a:rPr lang="en-US" sz="1100" b="1" spc="300" kern="0" dirty="0">
-                <a:solidFill>
-                  <a:schemeClr val="accent2"/>
-                </a:solidFill>
-              </a:rPr>
-              <a:t>POSTGRADUATE STUDIES</a:t>
-            </a:r>
-            <a:endParaRPr lang="en-US" sz="1100" dirty="0"/>
-          </a:p>
-        </p:txBody>
-      </p:sp>
-      <p:sp>
-        <p:nvSpPr>
-          <p:cNvPr id="9" name="Text 7"/>
-          <p:cNvSpPr txBox="1"/>
-          <p:nvPr/>
-        </p:nvSpPr>
-        <p:spPr>
-          <a:xfrm>
-            <a:off x="4160520" y="1874520"/>
-            <a:ext cx="3200400" cy="1143000"/>
+            <a:off x="3886200" y="1874520"/>
+            <a:ext cx="3017520" cy="1143000"/>
           </a:xfrm>
           <a:prstGeom prst="rect">
             <a:avLst/>
@@ -8101,14 +8090,14 @@
       </p:sp>
       <p:sp>
         <p:nvSpPr>
-          <p:cNvPr id="10" name="Text 8"/>
-          <p:cNvSpPr txBox="1"/>
-          <p:nvPr/>
-        </p:nvSpPr>
-        <p:spPr>
-          <a:xfrm>
-            <a:off x="4160520" y="3108960"/>
-            <a:ext cx="3200400" cy="457200"/>
+          <p:cNvPr id="9" name="Text 7"/>
+          <p:cNvSpPr txBox="1"/>
+          <p:nvPr/>
+        </p:nvSpPr>
+        <p:spPr>
+          <a:xfrm>
+            <a:off x="3886200" y="3108960"/>
+            <a:ext cx="3017520" cy="457200"/>
           </a:xfrm>
           <a:prstGeom prst="rect">
             <a:avLst/>
@@ -8140,14 +8129,14 @@
       </p:sp>
       <p:sp>
         <p:nvSpPr>
-          <p:cNvPr id="11" name="Text 9"/>
-          <p:cNvSpPr txBox="1"/>
-          <p:nvPr/>
-        </p:nvSpPr>
-        <p:spPr>
-          <a:xfrm>
-            <a:off x="4160520" y="3703320"/>
-            <a:ext cx="3154680" cy="1463040"/>
+          <p:cNvPr id="10" name="Text 8"/>
+          <p:cNvSpPr txBox="1"/>
+          <p:nvPr/>
+        </p:nvSpPr>
+        <p:spPr>
+          <a:xfrm>
+            <a:off x="3886200" y="3703320"/>
+            <a:ext cx="2971800" cy="1463040"/>
           </a:xfrm>
           <a:prstGeom prst="rect">
             <a:avLst/>
@@ -8171,6 +8160,66 @@
               <a:t>Postgraduate studies opened. This was an important step for training young scientists.</a:t>
             </a:r>
             <a:endParaRPr lang="en-US" sz="1600" dirty="0"/>
+          </a:p>
+        </p:txBody>
+      </p:sp>
+      <p:pic>
+        <p:nvPicPr>
+          <p:cNvPr id="11" name="steps_rybakov.jpg" descr="B. A. Rybakov with MOPI students at archaeological excavations">    </p:cNvPr>
+          <p:cNvPicPr>
+            <a:picLocks noChangeAspect="1"/>
+          </p:cNvPicPr>
+          <p:nvPr/>
+        </p:nvPicPr>
+        <p:blipFill>
+          <a:blip r:embed="rId1"/>
+          <a:stretch>
+            <a:fillRect/>
+          </a:stretch>
+        </p:blipFill>
+        <p:spPr>
+          <a:xfrm>
+            <a:off x="7223760" y="1600200"/>
+            <a:ext cx="4325112" cy="2697480"/>
+          </a:xfrm>
+          <a:prstGeom prst="rect">
+            <a:avLst/>
+          </a:prstGeom>
+        </p:spPr>
+      </p:pic>
+      <p:sp>
+        <p:nvSpPr>
+          <p:cNvPr id="12" name="Text 9"/>
+          <p:cNvSpPr txBox="1"/>
+          <p:nvPr/>
+        </p:nvSpPr>
+        <p:spPr>
+          <a:xfrm>
+            <a:off x="7223760" y="4389120"/>
+            <a:ext cx="4325112" cy="457200"/>
+          </a:xfrm>
+          <a:prstGeom prst="rect">
+            <a:avLst/>
+          </a:prstGeom>
+          <a:noFill/>
+          <a:ln/>
+        </p:spPr>
+        <p:txBody>
+          <a:bodyPr wrap="square" lIns="0" tIns="0" rIns="0" bIns="0" rtlCol="0" anchor="t"/>
+          <a:lstStyle/>
+          <a:p>
+            <a:pPr indent="0" marL="0">
+              <a:buNone/>
+            </a:pPr>
+            <a:r>
+              <a:rPr lang="en-US" sz="1100" i="1" dirty="0">
+                <a:solidFill>
+                  <a:schemeClr val="tx2"/>
+                </a:solidFill>
+              </a:rPr>
+              <a:t>B. A. Rybakov with MOPI students at archaeological excavations</a:t>
+            </a:r>
+            <a:endParaRPr lang="en-US" sz="1100" dirty="0"/>
           </a:p>
         </p:txBody>
       </p:sp>
@@ -8186,7 +8235,7 @@
         </p:nvSpPr>
         <p:spPr>
           <a:xfrm>
-            <a:off x="6949440" y="6309360"/>
+            <a:off x="11091672" y="6309360"/>
             <a:ext cx="457200" cy="274320"/>
           </a:xfrm>
           <a:prstGeom prst="rect">

</xml_diff>

<commit_message>
Add Rubinstein and Porshnev portraits to the professors slide
Co-Authored-By: Claude Opus 5.5 <noreply@anthropic.com>
Claude-Session: https://claude.ai/code/session_01Gbke9ULM5RvL1ZnrLDt9QB
</commit_message>
<xml_diff>
--- a/presentation/MOPI_History_1931-1940.pptx
+++ b/presentation/MOPI_History_1931-1940.pptx
@@ -116,12 +116,12 @@
   <p:extLst>
     <p:ext uri="{521415D9-36F7-43E2-AB2F-B90AF26B5E84}">
       <p14:sectionLst xmlns:p14="http://schemas.microsoft.com/office/powerpoint/2010/main">
-        <p14:section name="Introduction" id="{853a0a86-09ec-e51e-f725-8fb034a42abc}">
+        <p14:section name="Introduction" id="{137d4d5d-01e1-f6c0-744f-7fe8ac1b069a}">
           <p14:sldIdLst>
             <p14:sldId id="256"/>
           </p14:sldIdLst>
         </p14:section>
-        <p14:section name="The First Decade" id="{44fea766-0207-4755-e9f8-bd2d21c5ebdd}">
+        <p14:section name="The First Decade" id="{28b2fd50-98cd-20c3-4707-3c970a4b8c5d}">
           <p14:sldIdLst>
             <p14:sldId id="257"/>
             <p14:sldId id="258"/>
@@ -132,7 +132,7 @@
             <p14:sldId id="263"/>
           </p14:sldIdLst>
         </p14:section>
-        <p14:section name="1941" id="{636576f4-83f0-eb40-48d3-0133e192c734}">
+        <p14:section name="1941" id="{1ad27243-bf9c-cd88-ce9f-eb9e776577bc}">
           <p14:sldIdLst>
             <p14:sldId id="264"/>
             <p14:sldId id="265"/>
@@ -6959,48 +6959,16 @@
       </p:grpSpPr>
       <p:sp>
         <p:nvSpPr>
-          <p:cNvPr id="2" name="Text 1"/>
+          <p:cNvPr id="2" name="Text 0"/>
           <p:cNvSpPr/>
           <p:nvPr>
-            <p:ph type="pic" idx="101" hasCustomPrompt="1"/>
+            <p:ph idx="100" type="title" hasCustomPrompt="1"/>
           </p:nvPr>
         </p:nvSpPr>
         <p:spPr>
           <a:xfrm>
-            <a:off x="0" y="0"/>
-            <a:ext cx="4572000" cy="6858000"/>
-          </a:xfrm>
-          <a:prstGeom prst="rect">
-            <a:avLst/>
-          </a:prstGeom>
-          <a:solidFill>
-            <a:schemeClr val="accent3"/>
-          </a:solidFill>
-          <a:ln/>
-        </p:spPr>
-        <p:txBody>
-          <a:bodyPr wrap="square" rtlCol="0" anchor="ctr"/>
-          <a:lstStyle/>
-          <a:p>
-            <a:pPr algn="ctr" indent="0" marL="0">
-              <a:buNone/>
-            </a:pPr>
-            <a:endParaRPr lang="en-US" sz="1200" dirty="0"/>
-          </a:p>
-        </p:txBody>
-      </p:sp>
-      <p:sp>
-        <p:nvSpPr>
-          <p:cNvPr id="3" name="Text 1"/>
-          <p:cNvSpPr/>
-          <p:nvPr>
-            <p:ph idx="102" type="title" hasCustomPrompt="1"/>
-          </p:nvPr>
-        </p:nvSpPr>
-        <p:spPr>
-          <a:xfrm>
-            <a:off x="5212080" y="502920"/>
-            <a:ext cx="6400800" cy="822960"/>
+            <a:off x="640080" y="502920"/>
+            <a:ext cx="10881360" cy="822960"/>
           </a:xfrm>
           <a:prstGeom prst="rect">
             <a:avLst/>
@@ -7032,49 +7000,49 @@
       </p:sp>
       <p:sp>
         <p:nvSpPr>
+          <p:cNvPr id="3" name="Text 1"/>
+          <p:cNvSpPr txBox="1"/>
+          <p:nvPr/>
+        </p:nvSpPr>
+        <p:spPr>
+          <a:xfrm>
+            <a:off x="640080" y="1325880"/>
+            <a:ext cx="6400800" cy="594360"/>
+          </a:xfrm>
+          <a:prstGeom prst="rect">
+            <a:avLst/>
+          </a:prstGeom>
+          <a:noFill/>
+          <a:ln/>
+        </p:spPr>
+        <p:txBody>
+          <a:bodyPr wrap="square" lIns="0" tIns="0" rIns="0" bIns="0" rtlCol="0" anchor="t"/>
+          <a:lstStyle/>
+          <a:p>
+            <a:pPr indent="0" marL="0">
+              <a:buNone/>
+            </a:pPr>
+            <a:r>
+              <a:rPr lang="en-US" sz="1500" dirty="0">
+                <a:solidFill>
+                  <a:schemeClr val="tx2"/>
+                </a:solidFill>
+              </a:rPr>
+              <a:t>Despite political pressure, MOPI had a strong teaching staff. Famous historians worked here:</a:t>
+            </a:r>
+            <a:endParaRPr lang="en-US" sz="1500" dirty="0"/>
+          </a:p>
+        </p:txBody>
+      </p:sp>
+      <p:sp>
+        <p:nvSpPr>
           <p:cNvPr id="4" name="Text 2"/>
           <p:cNvSpPr txBox="1"/>
           <p:nvPr/>
         </p:nvSpPr>
         <p:spPr>
           <a:xfrm>
-            <a:off x="5212080" y="1325880"/>
-            <a:ext cx="6400800" cy="594360"/>
-          </a:xfrm>
-          <a:prstGeom prst="rect">
-            <a:avLst/>
-          </a:prstGeom>
-          <a:noFill/>
-          <a:ln/>
-        </p:spPr>
-        <p:txBody>
-          <a:bodyPr wrap="square" lIns="0" tIns="0" rIns="0" bIns="0" rtlCol="0" anchor="t"/>
-          <a:lstStyle/>
-          <a:p>
-            <a:pPr indent="0" marL="0">
-              <a:buNone/>
-            </a:pPr>
-            <a:r>
-              <a:rPr lang="en-US" sz="1500" dirty="0">
-                <a:solidFill>
-                  <a:schemeClr val="tx2"/>
-                </a:solidFill>
-              </a:rPr>
-              <a:t>Despite political pressure, MOPI had a strong teaching staff. Famous historians worked here:</a:t>
-            </a:r>
-            <a:endParaRPr lang="en-US" sz="1500" dirty="0"/>
-          </a:p>
-        </p:txBody>
-      </p:sp>
-      <p:sp>
-        <p:nvSpPr>
-          <p:cNvPr id="5" name="Text 3"/>
-          <p:cNvSpPr txBox="1"/>
-          <p:nvPr/>
-        </p:nvSpPr>
-        <p:spPr>
-          <a:xfrm>
-            <a:off x="5212080" y="2075688"/>
+            <a:off x="640080" y="2075688"/>
             <a:ext cx="548640" cy="457200"/>
           </a:xfrm>
           <a:prstGeom prst="rect">
@@ -7107,14 +7075,50 @@
       </p:sp>
       <p:sp>
         <p:nvSpPr>
+          <p:cNvPr id="5" name="Text 3"/>
+          <p:cNvSpPr txBox="1"/>
+          <p:nvPr/>
+        </p:nvSpPr>
+        <p:spPr>
+          <a:xfrm>
+            <a:off x="1234440" y="2130552"/>
+            <a:ext cx="2240280" cy="365760"/>
+          </a:xfrm>
+          <a:prstGeom prst="rect">
+            <a:avLst/>
+          </a:prstGeom>
+          <a:noFill/>
+          <a:ln/>
+        </p:spPr>
+        <p:txBody>
+          <a:bodyPr wrap="square" lIns="0" tIns="0" rIns="0" bIns="0" rtlCol="0" anchor="t"/>
+          <a:lstStyle/>
+          <a:p>
+            <a:pPr indent="0" marL="0">
+              <a:buNone/>
+            </a:pPr>
+            <a:r>
+              <a:rPr lang="en-US" sz="1600" b="1" dirty="0">
+                <a:solidFill>
+                  <a:schemeClr val="tx1"/>
+                </a:solidFill>
+              </a:rPr>
+              <a:t>N. L. Rubinstein</a:t>
+            </a:r>
+            <a:endParaRPr lang="en-US" sz="1600" dirty="0"/>
+          </a:p>
+        </p:txBody>
+      </p:sp>
+      <p:sp>
+        <p:nvSpPr>
           <p:cNvPr id="6" name="Text 4"/>
           <p:cNvSpPr txBox="1"/>
           <p:nvPr/>
         </p:nvSpPr>
         <p:spPr>
           <a:xfrm>
-            <a:off x="5806440" y="2130552"/>
-            <a:ext cx="2240280" cy="365760"/>
+            <a:off x="3520440" y="2103120"/>
+            <a:ext cx="3520440" cy="502920"/>
           </a:xfrm>
           <a:prstGeom prst="rect">
             <a:avLst/>
@@ -7130,42 +7134,6 @@
               <a:buNone/>
             </a:pPr>
             <a:r>
-              <a:rPr lang="en-US" sz="1600" b="1" dirty="0">
-                <a:solidFill>
-                  <a:schemeClr val="tx1"/>
-                </a:solidFill>
-              </a:rPr>
-              <a:t>N. L. Rubinstein</a:t>
-            </a:r>
-            <a:endParaRPr lang="en-US" sz="1600" dirty="0"/>
-          </a:p>
-        </p:txBody>
-      </p:sp>
-      <p:sp>
-        <p:nvSpPr>
-          <p:cNvPr id="7" name="Text 5"/>
-          <p:cNvSpPr txBox="1"/>
-          <p:nvPr/>
-        </p:nvSpPr>
-        <p:spPr>
-          <a:xfrm>
-            <a:off x="8092440" y="2103120"/>
-            <a:ext cx="3520440" cy="502920"/>
-          </a:xfrm>
-          <a:prstGeom prst="rect">
-            <a:avLst/>
-          </a:prstGeom>
-          <a:noFill/>
-          <a:ln/>
-        </p:spPr>
-        <p:txBody>
-          <a:bodyPr wrap="square" lIns="0" tIns="0" rIns="0" bIns="0" rtlCol="0" anchor="t"/>
-          <a:lstStyle/>
-          <a:p>
-            <a:pPr indent="0" marL="0">
-              <a:buNone/>
-            </a:pPr>
-            <a:r>
               <a:rPr lang="en-US" sz="1400" dirty="0">
                 <a:solidFill>
                   <a:schemeClr val="tx2"/>
@@ -7179,13 +7147,13 @@
       </p:sp>
       <p:sp>
         <p:nvSpPr>
-          <p:cNvPr id="8" name="Row rule 1"/>
+          <p:cNvPr id="7" name="Row rule 1"/>
           <p:cNvSpPr/>
           <p:nvPr/>
         </p:nvSpPr>
         <p:spPr>
           <a:xfrm>
-            <a:off x="5212080" y="2624328"/>
+            <a:off x="640080" y="2624328"/>
             <a:ext cx="6400800" cy="0"/>
           </a:xfrm>
           <a:prstGeom prst="line">
@@ -7202,13 +7170,13 @@
       </p:sp>
       <p:sp>
         <p:nvSpPr>
-          <p:cNvPr id="9" name="Text 7"/>
-          <p:cNvSpPr txBox="1"/>
-          <p:nvPr/>
-        </p:nvSpPr>
-        <p:spPr>
-          <a:xfrm>
-            <a:off x="5212080" y="2697480"/>
+          <p:cNvPr id="8" name="Text 6"/>
+          <p:cNvSpPr txBox="1"/>
+          <p:nvPr/>
+        </p:nvSpPr>
+        <p:spPr>
+          <a:xfrm>
+            <a:off x="640080" y="2697480"/>
             <a:ext cx="548640" cy="457200"/>
           </a:xfrm>
           <a:prstGeom prst="rect">
@@ -7241,14 +7209,50 @@
       </p:sp>
       <p:sp>
         <p:nvSpPr>
+          <p:cNvPr id="9" name="Text 7"/>
+          <p:cNvSpPr txBox="1"/>
+          <p:nvPr/>
+        </p:nvSpPr>
+        <p:spPr>
+          <a:xfrm>
+            <a:off x="1234440" y="2752344"/>
+            <a:ext cx="2240280" cy="365760"/>
+          </a:xfrm>
+          <a:prstGeom prst="rect">
+            <a:avLst/>
+          </a:prstGeom>
+          <a:noFill/>
+          <a:ln/>
+        </p:spPr>
+        <p:txBody>
+          <a:bodyPr wrap="square" lIns="0" tIns="0" rIns="0" bIns="0" rtlCol="0" anchor="t"/>
+          <a:lstStyle/>
+          <a:p>
+            <a:pPr indent="0" marL="0">
+              <a:buNone/>
+            </a:pPr>
+            <a:r>
+              <a:rPr lang="en-US" sz="1600" b="1" dirty="0">
+                <a:solidFill>
+                  <a:schemeClr val="tx1"/>
+                </a:solidFill>
+              </a:rPr>
+              <a:t>B. A. Rybakov</a:t>
+            </a:r>
+            <a:endParaRPr lang="en-US" sz="1600" dirty="0"/>
+          </a:p>
+        </p:txBody>
+      </p:sp>
+      <p:sp>
+        <p:nvSpPr>
           <p:cNvPr id="10" name="Text 8"/>
           <p:cNvSpPr txBox="1"/>
           <p:nvPr/>
         </p:nvSpPr>
         <p:spPr>
           <a:xfrm>
-            <a:off x="5806440" y="2752344"/>
-            <a:ext cx="2240280" cy="365760"/>
+            <a:off x="3520440" y="2724912"/>
+            <a:ext cx="3520440" cy="502920"/>
           </a:xfrm>
           <a:prstGeom prst="rect">
             <a:avLst/>
@@ -7264,42 +7268,6 @@
               <a:buNone/>
             </a:pPr>
             <a:r>
-              <a:rPr lang="en-US" sz="1600" b="1" dirty="0">
-                <a:solidFill>
-                  <a:schemeClr val="tx1"/>
-                </a:solidFill>
-              </a:rPr>
-              <a:t>B. A. Rybakov</a:t>
-            </a:r>
-            <a:endParaRPr lang="en-US" sz="1600" dirty="0"/>
-          </a:p>
-        </p:txBody>
-      </p:sp>
-      <p:sp>
-        <p:nvSpPr>
-          <p:cNvPr id="11" name="Text 9"/>
-          <p:cNvSpPr txBox="1"/>
-          <p:nvPr/>
-        </p:nvSpPr>
-        <p:spPr>
-          <a:xfrm>
-            <a:off x="8092440" y="2724912"/>
-            <a:ext cx="3520440" cy="502920"/>
-          </a:xfrm>
-          <a:prstGeom prst="rect">
-            <a:avLst/>
-          </a:prstGeom>
-          <a:noFill/>
-          <a:ln/>
-        </p:spPr>
-        <p:txBody>
-          <a:bodyPr wrap="square" lIns="0" tIns="0" rIns="0" bIns="0" rtlCol="0" anchor="t"/>
-          <a:lstStyle/>
-          <a:p>
-            <a:pPr indent="0" marL="0">
-              <a:buNone/>
-            </a:pPr>
-            <a:r>
               <a:rPr lang="en-US" sz="1400" dirty="0">
                 <a:solidFill>
                   <a:schemeClr val="tx2"/>
@@ -7313,13 +7281,13 @@
       </p:sp>
       <p:sp>
         <p:nvSpPr>
-          <p:cNvPr id="12" name="Row rule 2"/>
+          <p:cNvPr id="11" name="Row rule 2"/>
           <p:cNvSpPr/>
           <p:nvPr/>
         </p:nvSpPr>
         <p:spPr>
           <a:xfrm>
-            <a:off x="5212080" y="3246120"/>
+            <a:off x="640080" y="3246120"/>
             <a:ext cx="6400800" cy="0"/>
           </a:xfrm>
           <a:prstGeom prst="line">
@@ -7336,13 +7304,13 @@
       </p:sp>
       <p:sp>
         <p:nvSpPr>
-          <p:cNvPr id="13" name="Text 11"/>
-          <p:cNvSpPr txBox="1"/>
-          <p:nvPr/>
-        </p:nvSpPr>
-        <p:spPr>
-          <a:xfrm>
-            <a:off x="5212080" y="3319272"/>
+          <p:cNvPr id="12" name="Text 10"/>
+          <p:cNvSpPr txBox="1"/>
+          <p:nvPr/>
+        </p:nvSpPr>
+        <p:spPr>
+          <a:xfrm>
+            <a:off x="640080" y="3319272"/>
             <a:ext cx="548640" cy="457200"/>
           </a:xfrm>
           <a:prstGeom prst="rect">
@@ -7375,14 +7343,50 @@
       </p:sp>
       <p:sp>
         <p:nvSpPr>
+          <p:cNvPr id="13" name="Text 11"/>
+          <p:cNvSpPr txBox="1"/>
+          <p:nvPr/>
+        </p:nvSpPr>
+        <p:spPr>
+          <a:xfrm>
+            <a:off x="1234440" y="3374136"/>
+            <a:ext cx="2240280" cy="365760"/>
+          </a:xfrm>
+          <a:prstGeom prst="rect">
+            <a:avLst/>
+          </a:prstGeom>
+          <a:noFill/>
+          <a:ln/>
+        </p:spPr>
+        <p:txBody>
+          <a:bodyPr wrap="square" lIns="0" tIns="0" rIns="0" bIns="0" rtlCol="0" anchor="t"/>
+          <a:lstStyle/>
+          <a:p>
+            <a:pPr indent="0" marL="0">
+              <a:buNone/>
+            </a:pPr>
+            <a:r>
+              <a:rPr lang="en-US" sz="1600" b="1" dirty="0">
+                <a:solidFill>
+                  <a:schemeClr val="tx1"/>
+                </a:solidFill>
+              </a:rPr>
+              <a:t>V. M. Khvostov</a:t>
+            </a:r>
+            <a:endParaRPr lang="en-US" sz="1600" dirty="0"/>
+          </a:p>
+        </p:txBody>
+      </p:sp>
+      <p:sp>
+        <p:nvSpPr>
           <p:cNvPr id="14" name="Text 12"/>
           <p:cNvSpPr txBox="1"/>
           <p:nvPr/>
         </p:nvSpPr>
         <p:spPr>
           <a:xfrm>
-            <a:off x="5806440" y="3374136"/>
-            <a:ext cx="2240280" cy="365760"/>
+            <a:off x="3520440" y="3346704"/>
+            <a:ext cx="3520440" cy="502920"/>
           </a:xfrm>
           <a:prstGeom prst="rect">
             <a:avLst/>
@@ -7398,42 +7402,6 @@
               <a:buNone/>
             </a:pPr>
             <a:r>
-              <a:rPr lang="en-US" sz="1600" b="1" dirty="0">
-                <a:solidFill>
-                  <a:schemeClr val="tx1"/>
-                </a:solidFill>
-              </a:rPr>
-              <a:t>V. M. Khvostov</a:t>
-            </a:r>
-            <a:endParaRPr lang="en-US" sz="1600" dirty="0"/>
-          </a:p>
-        </p:txBody>
-      </p:sp>
-      <p:sp>
-        <p:nvSpPr>
-          <p:cNvPr id="15" name="Text 13"/>
-          <p:cNvSpPr txBox="1"/>
-          <p:nvPr/>
-        </p:nvSpPr>
-        <p:spPr>
-          <a:xfrm>
-            <a:off x="8092440" y="3346704"/>
-            <a:ext cx="3520440" cy="502920"/>
-          </a:xfrm>
-          <a:prstGeom prst="rect">
-            <a:avLst/>
-          </a:prstGeom>
-          <a:noFill/>
-          <a:ln/>
-        </p:spPr>
-        <p:txBody>
-          <a:bodyPr wrap="square" lIns="0" tIns="0" rIns="0" bIns="0" rtlCol="0" anchor="t"/>
-          <a:lstStyle/>
-          <a:p>
-            <a:pPr indent="0" marL="0">
-              <a:buNone/>
-            </a:pPr>
-            <a:r>
               <a:rPr lang="en-US" sz="1400" dirty="0">
                 <a:solidFill>
                   <a:schemeClr val="tx2"/>
@@ -7447,13 +7415,13 @@
       </p:sp>
       <p:sp>
         <p:nvSpPr>
-          <p:cNvPr id="16" name="Row rule 3"/>
+          <p:cNvPr id="15" name="Row rule 3"/>
           <p:cNvSpPr/>
           <p:nvPr/>
         </p:nvSpPr>
         <p:spPr>
           <a:xfrm>
-            <a:off x="5212080" y="3867912"/>
+            <a:off x="640080" y="3867912"/>
             <a:ext cx="6400800" cy="0"/>
           </a:xfrm>
           <a:prstGeom prst="line">
@@ -7470,13 +7438,13 @@
       </p:sp>
       <p:sp>
         <p:nvSpPr>
-          <p:cNvPr id="17" name="Text 15"/>
-          <p:cNvSpPr txBox="1"/>
-          <p:nvPr/>
-        </p:nvSpPr>
-        <p:spPr>
-          <a:xfrm>
-            <a:off x="5212080" y="3941064"/>
+          <p:cNvPr id="16" name="Text 14"/>
+          <p:cNvSpPr txBox="1"/>
+          <p:nvPr/>
+        </p:nvSpPr>
+        <p:spPr>
+          <a:xfrm>
+            <a:off x="640080" y="3941064"/>
             <a:ext cx="548640" cy="457200"/>
           </a:xfrm>
           <a:prstGeom prst="rect">
@@ -7509,14 +7477,50 @@
       </p:sp>
       <p:sp>
         <p:nvSpPr>
+          <p:cNvPr id="17" name="Text 15"/>
+          <p:cNvSpPr txBox="1"/>
+          <p:nvPr/>
+        </p:nvSpPr>
+        <p:spPr>
+          <a:xfrm>
+            <a:off x="1234440" y="3995928"/>
+            <a:ext cx="2240280" cy="365760"/>
+          </a:xfrm>
+          <a:prstGeom prst="rect">
+            <a:avLst/>
+          </a:prstGeom>
+          <a:noFill/>
+          <a:ln/>
+        </p:spPr>
+        <p:txBody>
+          <a:bodyPr wrap="square" lIns="0" tIns="0" rIns="0" bIns="0" rtlCol="0" anchor="t"/>
+          <a:lstStyle/>
+          <a:p>
+            <a:pPr indent="0" marL="0">
+              <a:buNone/>
+            </a:pPr>
+            <a:r>
+              <a:rPr lang="en-US" sz="1600" b="1" dirty="0">
+                <a:solidFill>
+                  <a:schemeClr val="tx1"/>
+                </a:solidFill>
+              </a:rPr>
+              <a:t>B. F. Porshnev</a:t>
+            </a:r>
+            <a:endParaRPr lang="en-US" sz="1600" dirty="0"/>
+          </a:p>
+        </p:txBody>
+      </p:sp>
+      <p:sp>
+        <p:nvSpPr>
           <p:cNvPr id="18" name="Text 16"/>
           <p:cNvSpPr txBox="1"/>
           <p:nvPr/>
         </p:nvSpPr>
         <p:spPr>
           <a:xfrm>
-            <a:off x="5806440" y="3995928"/>
-            <a:ext cx="2240280" cy="365760"/>
+            <a:off x="3520440" y="3968496"/>
+            <a:ext cx="3520440" cy="502920"/>
           </a:xfrm>
           <a:prstGeom prst="rect">
             <a:avLst/>
@@ -7532,42 +7536,6 @@
               <a:buNone/>
             </a:pPr>
             <a:r>
-              <a:rPr lang="en-US" sz="1600" b="1" dirty="0">
-                <a:solidFill>
-                  <a:schemeClr val="tx1"/>
-                </a:solidFill>
-              </a:rPr>
-              <a:t>B. F. Porshnev</a:t>
-            </a:r>
-            <a:endParaRPr lang="en-US" sz="1600" dirty="0"/>
-          </a:p>
-        </p:txBody>
-      </p:sp>
-      <p:sp>
-        <p:nvSpPr>
-          <p:cNvPr id="19" name="Text 17"/>
-          <p:cNvSpPr txBox="1"/>
-          <p:nvPr/>
-        </p:nvSpPr>
-        <p:spPr>
-          <a:xfrm>
-            <a:off x="8092440" y="3968496"/>
-            <a:ext cx="3520440" cy="502920"/>
-          </a:xfrm>
-          <a:prstGeom prst="rect">
-            <a:avLst/>
-          </a:prstGeom>
-          <a:noFill/>
-          <a:ln/>
-        </p:spPr>
-        <p:txBody>
-          <a:bodyPr wrap="square" lIns="0" tIns="0" rIns="0" bIns="0" rtlCol="0" anchor="t"/>
-          <a:lstStyle/>
-          <a:p>
-            <a:pPr indent="0" marL="0">
-              <a:buNone/>
-            </a:pPr>
-            <a:r>
               <a:rPr lang="en-US" sz="1400" dirty="0">
                 <a:solidFill>
                   <a:schemeClr val="tx2"/>
@@ -7581,13 +7549,13 @@
       </p:sp>
       <p:sp>
         <p:nvSpPr>
-          <p:cNvPr id="20" name="Row rule 4"/>
+          <p:cNvPr id="19" name="Row rule 4"/>
           <p:cNvSpPr/>
           <p:nvPr/>
         </p:nvSpPr>
         <p:spPr>
           <a:xfrm>
-            <a:off x="5212080" y="4489704"/>
+            <a:off x="640080" y="4489704"/>
             <a:ext cx="6400800" cy="0"/>
           </a:xfrm>
           <a:prstGeom prst="line">
@@ -7604,13 +7572,13 @@
       </p:sp>
       <p:sp>
         <p:nvSpPr>
-          <p:cNvPr id="21" name="Text 19"/>
-          <p:cNvSpPr txBox="1"/>
-          <p:nvPr/>
-        </p:nvSpPr>
-        <p:spPr>
-          <a:xfrm>
-            <a:off x="5212080" y="4562856"/>
+          <p:cNvPr id="20" name="Text 18"/>
+          <p:cNvSpPr txBox="1"/>
+          <p:nvPr/>
+        </p:nvSpPr>
+        <p:spPr>
+          <a:xfrm>
+            <a:off x="640080" y="4562856"/>
             <a:ext cx="548640" cy="457200"/>
           </a:xfrm>
           <a:prstGeom prst="rect">
@@ -7643,14 +7611,50 @@
       </p:sp>
       <p:sp>
         <p:nvSpPr>
+          <p:cNvPr id="21" name="Text 19"/>
+          <p:cNvSpPr txBox="1"/>
+          <p:nvPr/>
+        </p:nvSpPr>
+        <p:spPr>
+          <a:xfrm>
+            <a:off x="1234440" y="4617720"/>
+            <a:ext cx="2240280" cy="365760"/>
+          </a:xfrm>
+          <a:prstGeom prst="rect">
+            <a:avLst/>
+          </a:prstGeom>
+          <a:noFill/>
+          <a:ln/>
+        </p:spPr>
+        <p:txBody>
+          <a:bodyPr wrap="square" lIns="0" tIns="0" rIns="0" bIns="0" rtlCol="0" anchor="t"/>
+          <a:lstStyle/>
+          <a:p>
+            <a:pPr indent="0" marL="0">
+              <a:buNone/>
+            </a:pPr>
+            <a:r>
+              <a:rPr lang="en-US" sz="1600" b="1" dirty="0">
+                <a:solidFill>
+                  <a:schemeClr val="tx1"/>
+                </a:solidFill>
+              </a:rPr>
+              <a:t>A. V. Shestakov</a:t>
+            </a:r>
+            <a:endParaRPr lang="en-US" sz="1600" dirty="0"/>
+          </a:p>
+        </p:txBody>
+      </p:sp>
+      <p:sp>
+        <p:nvSpPr>
           <p:cNvPr id="22" name="Text 20"/>
           <p:cNvSpPr txBox="1"/>
           <p:nvPr/>
         </p:nvSpPr>
         <p:spPr>
           <a:xfrm>
-            <a:off x="5806440" y="4617720"/>
-            <a:ext cx="2240280" cy="365760"/>
+            <a:off x="3520440" y="4590288"/>
+            <a:ext cx="3520440" cy="502920"/>
           </a:xfrm>
           <a:prstGeom prst="rect">
             <a:avLst/>
@@ -7666,14 +7670,14 @@
               <a:buNone/>
             </a:pPr>
             <a:r>
-              <a:rPr lang="en-US" sz="1600" b="1" dirty="0">
-                <a:solidFill>
-                  <a:schemeClr val="tx1"/>
-                </a:solidFill>
-              </a:rPr>
-              <a:t>A. V. Shestakov</a:t>
-            </a:r>
-            <a:endParaRPr lang="en-US" sz="1600" dirty="0"/>
+              <a:rPr lang="en-US" sz="1400" dirty="0">
+                <a:solidFill>
+                  <a:schemeClr val="tx2"/>
+                </a:solidFill>
+              </a:rPr>
+              <a:t>author of a school textbook on USSR history</a:t>
+            </a:r>
+            <a:endParaRPr lang="en-US" sz="1400" dirty="0"/>
           </a:p>
         </p:txBody>
       </p:sp>
@@ -7685,43 +7689,7 @@
         </p:nvSpPr>
         <p:spPr>
           <a:xfrm>
-            <a:off x="8092440" y="4590288"/>
-            <a:ext cx="3520440" cy="502920"/>
-          </a:xfrm>
-          <a:prstGeom prst="rect">
-            <a:avLst/>
-          </a:prstGeom>
-          <a:noFill/>
-          <a:ln/>
-        </p:spPr>
-        <p:txBody>
-          <a:bodyPr wrap="square" lIns="0" tIns="0" rIns="0" bIns="0" rtlCol="0" anchor="t"/>
-          <a:lstStyle/>
-          <a:p>
-            <a:pPr indent="0" marL="0">
-              <a:buNone/>
-            </a:pPr>
-            <a:r>
-              <a:rPr lang="en-US" sz="1400" dirty="0">
-                <a:solidFill>
-                  <a:schemeClr val="tx2"/>
-                </a:solidFill>
-              </a:rPr>
-              <a:t>author of a school textbook on USSR history</a:t>
-            </a:r>
-            <a:endParaRPr lang="en-US" sz="1400" dirty="0"/>
-          </a:p>
-        </p:txBody>
-      </p:sp>
-      <p:sp>
-        <p:nvSpPr>
-          <p:cNvPr id="24" name="Text 22"/>
-          <p:cNvSpPr txBox="1"/>
-          <p:nvPr/>
-        </p:nvSpPr>
-        <p:spPr>
-          <a:xfrm>
-            <a:off x="5212080" y="5349240"/>
+            <a:off x="640080" y="5349240"/>
             <a:ext cx="6400800" cy="457200"/>
           </a:xfrm>
           <a:prstGeom prst="rect">
@@ -7749,6 +7717,126 @@
               <a:t>Students remembered these professors as brilliant teachers.</a:t>
             </a:r>
             <a:endParaRPr lang="en-US" sz="1900" dirty="0"/>
+          </a:p>
+        </p:txBody>
+      </p:sp>
+      <p:pic>
+        <p:nvPicPr>
+          <p:cNvPr id="24" name="Portrait N. L. Rubinstein" descr="N. L. Rubinstein">    </p:cNvPr>
+          <p:cNvPicPr>
+            <a:picLocks noChangeAspect="1"/>
+          </p:cNvPicPr>
+          <p:nvPr/>
+        </p:nvPicPr>
+        <p:blipFill>
+          <a:blip r:embed="rId1"/>
+          <a:stretch>
+            <a:fillRect/>
+          </a:stretch>
+        </p:blipFill>
+        <p:spPr>
+          <a:xfrm>
+            <a:off x="7498080" y="1417320"/>
+            <a:ext cx="1920240" cy="2560320"/>
+          </a:xfrm>
+          <a:prstGeom prst="rect">
+            <a:avLst/>
+          </a:prstGeom>
+        </p:spPr>
+      </p:pic>
+      <p:sp>
+        <p:nvSpPr>
+          <p:cNvPr id="25" name="Text 22"/>
+          <p:cNvSpPr txBox="1"/>
+          <p:nvPr/>
+        </p:nvSpPr>
+        <p:spPr>
+          <a:xfrm>
+            <a:off x="7498080" y="4069080"/>
+            <a:ext cx="1920240" cy="320040"/>
+          </a:xfrm>
+          <a:prstGeom prst="rect">
+            <a:avLst/>
+          </a:prstGeom>
+          <a:noFill/>
+          <a:ln/>
+        </p:spPr>
+        <p:txBody>
+          <a:bodyPr wrap="square" lIns="0" tIns="0" rIns="0" bIns="0" rtlCol="0" anchor="t"/>
+          <a:lstStyle/>
+          <a:p>
+            <a:pPr indent="0" marL="0">
+              <a:buNone/>
+            </a:pPr>
+            <a:r>
+              <a:rPr lang="en-US" sz="1400" b="1" dirty="0">
+                <a:solidFill>
+                  <a:schemeClr val="tx1"/>
+                </a:solidFill>
+              </a:rPr>
+              <a:t>N. L. Rubinstein</a:t>
+            </a:r>
+            <a:endParaRPr lang="en-US" sz="1400" dirty="0"/>
+          </a:p>
+        </p:txBody>
+      </p:sp>
+      <p:pic>
+        <p:nvPicPr>
+          <p:cNvPr id="26" name="Portrait B. F. Porshnev" descr="B. F. Porshnev">    </p:cNvPr>
+          <p:cNvPicPr>
+            <a:picLocks noChangeAspect="1"/>
+          </p:cNvPicPr>
+          <p:nvPr/>
+        </p:nvPicPr>
+        <p:blipFill>
+          <a:blip r:embed="rId2"/>
+          <a:stretch>
+            <a:fillRect/>
+          </a:stretch>
+        </p:blipFill>
+        <p:spPr>
+          <a:xfrm>
+            <a:off x="9646920" y="1417320"/>
+            <a:ext cx="1920240" cy="2560320"/>
+          </a:xfrm>
+          <a:prstGeom prst="rect">
+            <a:avLst/>
+          </a:prstGeom>
+        </p:spPr>
+      </p:pic>
+      <p:sp>
+        <p:nvSpPr>
+          <p:cNvPr id="27" name="Text 23"/>
+          <p:cNvSpPr txBox="1"/>
+          <p:nvPr/>
+        </p:nvSpPr>
+        <p:spPr>
+          <a:xfrm>
+            <a:off x="9646920" y="4069080"/>
+            <a:ext cx="1920240" cy="320040"/>
+          </a:xfrm>
+          <a:prstGeom prst="rect">
+            <a:avLst/>
+          </a:prstGeom>
+          <a:noFill/>
+          <a:ln/>
+        </p:spPr>
+        <p:txBody>
+          <a:bodyPr wrap="square" lIns="0" tIns="0" rIns="0" bIns="0" rtlCol="0" anchor="t"/>
+          <a:lstStyle/>
+          <a:p>
+            <a:pPr indent="0" marL="0">
+              <a:buNone/>
+            </a:pPr>
+            <a:r>
+              <a:rPr lang="en-US" sz="1400" b="1" dirty="0">
+                <a:solidFill>
+                  <a:schemeClr val="tx1"/>
+                </a:solidFill>
+              </a:rPr>
+              <a:t>B. F. Porshnev</a:t>
+            </a:r>
+            <a:endParaRPr lang="en-US" sz="1400" dirty="0"/>
           </a:p>
         </p:txBody>
       </p:sp>

</xml_diff>